<commit_message>
Add standard slide library + catalogue; route AMS slides through it
- 02-editorial/slide_library.py: content-driven builders for every key slide type
  (logo, divider, statement, two_cards, columns, framework_stack, timeline_gantt,
  pyramid_tiers, org_chart, logo_wall, cases, kpi_grid) on top of the Deck methods.
- samples/slide_library_demo.py -> Editorial_Slide_Library.pptx: catalogue of one
  of every standard slide.
- samples/ams_slides.py refactored to thin Mivada-content wrappers over the library
  (the merged deck + standalone pack now share one implementation).
- Skill updated (editorial-system.md catalogue table; SKILL.md points at the library).

Skill now covers PPTX (build_pptx + slide_library), HTML (presentation.html/document.html),
and Word (build_docx.js) in the Editorial style.

https://claude.ai/code/session_018CuPeTbPKyC5roqRrfQGYh
</commit_message>
<xml_diff>
--- a/design-system/samples/Mivada_AMS_Services_editorial.pptx
+++ b/design-system/samples/Mivada_AMS_Services_editorial.pptx
@@ -3531,15 +3531,682 @@
           </a:p>
         </p:txBody>
       </p:sp>
+      <p:sp>
+        <p:nvSpPr>
+          <p:cNvPr id="6" name="TextBox 5"/>
+          <p:cNvSpPr txBox="1"/>
+          <p:nvPr/>
+        </p:nvSpPr>
+        <p:spPr>
+          <a:xfrm>
+            <a:off x="877824" y="2468880"/>
+            <a:ext cx="4943703" cy="457200"/>
+          </a:xfrm>
+          <a:prstGeom prst="rect">
+            <a:avLst/>
+          </a:prstGeom>
+          <a:noFill/>
+        </p:spPr>
+        <p:txBody>
+          <a:bodyPr wrap="square" anchor="t" lIns="0" rIns="0" tIns="0" bIns="0"/>
+          <a:lstStyle/>
+          <a:p>
+            <a:pPr algn="l">
+              <a:lnSpc>
+                <a:spcPct val="100000"/>
+              </a:lnSpc>
+              <a:spcBef>
+                <a:spcPts val="0"/>
+              </a:spcBef>
+              <a:spcAft>
+                <a:spcPts val="0"/>
+              </a:spcAft>
+            </a:pPr>
+            <a:r>
+              <a:rPr sz="2000" b="1" i="0" lang="en-AU" spc="-40">
+                <a:solidFill>
+                  <a:srgbClr val="111111"/>
+                </a:solidFill>
+                <a:latin typeface="Inter"/>
+              </a:rPr>
+              <a:t>HCM</a:t>
+            </a:r>
+          </a:p>
+        </p:txBody>
+      </p:sp>
+      <p:sp>
+        <p:nvSpPr>
+          <p:cNvPr id="7" name="TextBox 6"/>
+          <p:cNvSpPr txBox="1"/>
+          <p:nvPr/>
+        </p:nvSpPr>
+        <p:spPr>
+          <a:xfrm>
+            <a:off x="877824" y="3063240"/>
+            <a:ext cx="2471851" cy="347472"/>
+          </a:xfrm>
+          <a:prstGeom prst="rect">
+            <a:avLst/>
+          </a:prstGeom>
+          <a:noFill/>
+        </p:spPr>
+        <p:txBody>
+          <a:bodyPr wrap="square" anchor="t" lIns="0" rIns="0" tIns="0" bIns="0"/>
+          <a:lstStyle/>
+          <a:p>
+            <a:pPr algn="l">
+              <a:lnSpc>
+                <a:spcPct val="112000"/>
+              </a:lnSpc>
+              <a:spcBef>
+                <a:spcPts val="0"/>
+              </a:spcBef>
+              <a:spcAft>
+                <a:spcPts val="0"/>
+              </a:spcAft>
+            </a:pPr>
+            <a:r>
+              <a:rPr sz="1050" b="1" i="0" lang="en-AU" spc="0">
+                <a:solidFill>
+                  <a:srgbClr val="EA493F"/>
+                </a:solidFill>
+                <a:latin typeface="Inter"/>
+              </a:rPr>
+              <a:t>—  </a:t>
+            </a:r>
+            <a:r>
+              <a:rPr sz="1050" b="0" i="0" lang="en-AU" spc="0">
+                <a:solidFill>
+                  <a:srgbClr val="323232"/>
+                </a:solidFill>
+                <a:latin typeface="Inter"/>
+              </a:rPr>
+              <a:t>Core HCM</a:t>
+            </a:r>
+          </a:p>
+        </p:txBody>
+      </p:sp>
+      <p:sp>
+        <p:nvSpPr>
+          <p:cNvPr id="8" name="TextBox 7"/>
+          <p:cNvSpPr txBox="1"/>
+          <p:nvPr/>
+        </p:nvSpPr>
+        <p:spPr>
+          <a:xfrm>
+            <a:off x="877824" y="3410712"/>
+            <a:ext cx="2471851" cy="347472"/>
+          </a:xfrm>
+          <a:prstGeom prst="rect">
+            <a:avLst/>
+          </a:prstGeom>
+          <a:noFill/>
+        </p:spPr>
+        <p:txBody>
+          <a:bodyPr wrap="square" anchor="t" lIns="0" rIns="0" tIns="0" bIns="0"/>
+          <a:lstStyle/>
+          <a:p>
+            <a:pPr algn="l">
+              <a:lnSpc>
+                <a:spcPct val="112000"/>
+              </a:lnSpc>
+              <a:spcBef>
+                <a:spcPts val="0"/>
+              </a:spcBef>
+              <a:spcAft>
+                <a:spcPts val="0"/>
+              </a:spcAft>
+            </a:pPr>
+            <a:r>
+              <a:rPr sz="1050" b="1" i="0" lang="en-AU" spc="0">
+                <a:solidFill>
+                  <a:srgbClr val="EA493F"/>
+                </a:solidFill>
+                <a:latin typeface="Inter"/>
+              </a:rPr>
+              <a:t>—  </a:t>
+            </a:r>
+            <a:r>
+              <a:rPr sz="1050" b="0" i="0" lang="en-AU" spc="0">
+                <a:solidFill>
+                  <a:srgbClr val="323232"/>
+                </a:solidFill>
+                <a:latin typeface="Inter"/>
+              </a:rPr>
+              <a:t>Absence</a:t>
+            </a:r>
+          </a:p>
+        </p:txBody>
+      </p:sp>
+      <p:sp>
+        <p:nvSpPr>
+          <p:cNvPr id="9" name="TextBox 8"/>
+          <p:cNvSpPr txBox="1"/>
+          <p:nvPr/>
+        </p:nvSpPr>
+        <p:spPr>
+          <a:xfrm>
+            <a:off x="877824" y="3758184"/>
+            <a:ext cx="2471851" cy="347472"/>
+          </a:xfrm>
+          <a:prstGeom prst="rect">
+            <a:avLst/>
+          </a:prstGeom>
+          <a:noFill/>
+        </p:spPr>
+        <p:txBody>
+          <a:bodyPr wrap="square" anchor="t" lIns="0" rIns="0" tIns="0" bIns="0"/>
+          <a:lstStyle/>
+          <a:p>
+            <a:pPr algn="l">
+              <a:lnSpc>
+                <a:spcPct val="112000"/>
+              </a:lnSpc>
+              <a:spcBef>
+                <a:spcPts val="0"/>
+              </a:spcBef>
+              <a:spcAft>
+                <a:spcPts val="0"/>
+              </a:spcAft>
+            </a:pPr>
+            <a:r>
+              <a:rPr sz="1050" b="1" i="0" lang="en-AU" spc="0">
+                <a:solidFill>
+                  <a:srgbClr val="EA493F"/>
+                </a:solidFill>
+                <a:latin typeface="Inter"/>
+              </a:rPr>
+              <a:t>—  </a:t>
+            </a:r>
+            <a:r>
+              <a:rPr sz="1050" b="0" i="0" lang="en-AU" spc="0">
+                <a:solidFill>
+                  <a:srgbClr val="323232"/>
+                </a:solidFill>
+                <a:latin typeface="Inter"/>
+              </a:rPr>
+              <a:t>Time Tracking</a:t>
+            </a:r>
+          </a:p>
+        </p:txBody>
+      </p:sp>
+      <p:sp>
+        <p:nvSpPr>
+          <p:cNvPr id="10" name="TextBox 9"/>
+          <p:cNvSpPr txBox="1"/>
+          <p:nvPr/>
+        </p:nvSpPr>
+        <p:spPr>
+          <a:xfrm>
+            <a:off x="877824" y="4105656"/>
+            <a:ext cx="2471851" cy="347472"/>
+          </a:xfrm>
+          <a:prstGeom prst="rect">
+            <a:avLst/>
+          </a:prstGeom>
+          <a:noFill/>
+        </p:spPr>
+        <p:txBody>
+          <a:bodyPr wrap="square" anchor="t" lIns="0" rIns="0" tIns="0" bIns="0"/>
+          <a:lstStyle/>
+          <a:p>
+            <a:pPr algn="l">
+              <a:lnSpc>
+                <a:spcPct val="112000"/>
+              </a:lnSpc>
+              <a:spcBef>
+                <a:spcPts val="0"/>
+              </a:spcBef>
+              <a:spcAft>
+                <a:spcPts val="0"/>
+              </a:spcAft>
+            </a:pPr>
+            <a:r>
+              <a:rPr sz="1050" b="1" i="0" lang="en-AU" spc="0">
+                <a:solidFill>
+                  <a:srgbClr val="EA493F"/>
+                </a:solidFill>
+                <a:latin typeface="Inter"/>
+              </a:rPr>
+              <a:t>—  </a:t>
+            </a:r>
+            <a:r>
+              <a:rPr sz="1050" b="0" i="0" lang="en-AU" spc="0">
+                <a:solidFill>
+                  <a:srgbClr val="323232"/>
+                </a:solidFill>
+                <a:latin typeface="Inter"/>
+              </a:rPr>
+              <a:t>Recruiting</a:t>
+            </a:r>
+          </a:p>
+        </p:txBody>
+      </p:sp>
+      <p:sp>
+        <p:nvSpPr>
+          <p:cNvPr id="11" name="TextBox 10"/>
+          <p:cNvSpPr txBox="1"/>
+          <p:nvPr/>
+        </p:nvSpPr>
+        <p:spPr>
+          <a:xfrm>
+            <a:off x="877824" y="4453128"/>
+            <a:ext cx="2471851" cy="347472"/>
+          </a:xfrm>
+          <a:prstGeom prst="rect">
+            <a:avLst/>
+          </a:prstGeom>
+          <a:noFill/>
+        </p:spPr>
+        <p:txBody>
+          <a:bodyPr wrap="square" anchor="t" lIns="0" rIns="0" tIns="0" bIns="0"/>
+          <a:lstStyle/>
+          <a:p>
+            <a:pPr algn="l">
+              <a:lnSpc>
+                <a:spcPct val="112000"/>
+              </a:lnSpc>
+              <a:spcBef>
+                <a:spcPts val="0"/>
+              </a:spcBef>
+              <a:spcAft>
+                <a:spcPts val="0"/>
+              </a:spcAft>
+            </a:pPr>
+            <a:r>
+              <a:rPr sz="1050" b="1" i="0" lang="en-AU" spc="0">
+                <a:solidFill>
+                  <a:srgbClr val="EA493F"/>
+                </a:solidFill>
+                <a:latin typeface="Inter"/>
+              </a:rPr>
+              <a:t>—  </a:t>
+            </a:r>
+            <a:r>
+              <a:rPr sz="1050" b="0" i="0" lang="en-AU" spc="0">
+                <a:solidFill>
+                  <a:srgbClr val="323232"/>
+                </a:solidFill>
+                <a:latin typeface="Inter"/>
+              </a:rPr>
+              <a:t>Talent &amp; Performance</a:t>
+            </a:r>
+          </a:p>
+        </p:txBody>
+      </p:sp>
+      <p:sp>
+        <p:nvSpPr>
+          <p:cNvPr id="12" name="TextBox 11"/>
+          <p:cNvSpPr txBox="1"/>
+          <p:nvPr/>
+        </p:nvSpPr>
+        <p:spPr>
+          <a:xfrm>
+            <a:off x="877824" y="4800600"/>
+            <a:ext cx="2471851" cy="347472"/>
+          </a:xfrm>
+          <a:prstGeom prst="rect">
+            <a:avLst/>
+          </a:prstGeom>
+          <a:noFill/>
+        </p:spPr>
+        <p:txBody>
+          <a:bodyPr wrap="square" anchor="t" lIns="0" rIns="0" tIns="0" bIns="0"/>
+          <a:lstStyle/>
+          <a:p>
+            <a:pPr algn="l">
+              <a:lnSpc>
+                <a:spcPct val="112000"/>
+              </a:lnSpc>
+              <a:spcBef>
+                <a:spcPts val="0"/>
+              </a:spcBef>
+              <a:spcAft>
+                <a:spcPts val="0"/>
+              </a:spcAft>
+            </a:pPr>
+            <a:r>
+              <a:rPr sz="1050" b="1" i="0" lang="en-AU" spc="0">
+                <a:solidFill>
+                  <a:srgbClr val="EA493F"/>
+                </a:solidFill>
+                <a:latin typeface="Inter"/>
+              </a:rPr>
+              <a:t>—  </a:t>
+            </a:r>
+            <a:r>
+              <a:rPr sz="1050" b="0" i="0" lang="en-AU" spc="0">
+                <a:solidFill>
+                  <a:srgbClr val="323232"/>
+                </a:solidFill>
+                <a:latin typeface="Inter"/>
+              </a:rPr>
+              <a:t>Compensation</a:t>
+            </a:r>
+          </a:p>
+        </p:txBody>
+      </p:sp>
+      <p:sp>
+        <p:nvSpPr>
+          <p:cNvPr id="13" name="TextBox 12"/>
+          <p:cNvSpPr txBox="1"/>
+          <p:nvPr/>
+        </p:nvSpPr>
+        <p:spPr>
+          <a:xfrm>
+            <a:off x="3349675" y="3063240"/>
+            <a:ext cx="2471851" cy="347472"/>
+          </a:xfrm>
+          <a:prstGeom prst="rect">
+            <a:avLst/>
+          </a:prstGeom>
+          <a:noFill/>
+        </p:spPr>
+        <p:txBody>
+          <a:bodyPr wrap="square" anchor="t" lIns="0" rIns="0" tIns="0" bIns="0"/>
+          <a:lstStyle/>
+          <a:p>
+            <a:pPr algn="l">
+              <a:lnSpc>
+                <a:spcPct val="112000"/>
+              </a:lnSpc>
+              <a:spcBef>
+                <a:spcPts val="0"/>
+              </a:spcBef>
+              <a:spcAft>
+                <a:spcPts val="0"/>
+              </a:spcAft>
+            </a:pPr>
+            <a:r>
+              <a:rPr sz="1050" b="1" i="0" lang="en-AU" spc="0">
+                <a:solidFill>
+                  <a:srgbClr val="EA493F"/>
+                </a:solidFill>
+                <a:latin typeface="Inter"/>
+              </a:rPr>
+              <a:t>—  </a:t>
+            </a:r>
+            <a:r>
+              <a:rPr sz="1050" b="0" i="0" lang="en-AU" spc="0">
+                <a:solidFill>
+                  <a:srgbClr val="323232"/>
+                </a:solidFill>
+                <a:latin typeface="Inter"/>
+              </a:rPr>
+              <a:t>Benefits</a:t>
+            </a:r>
+          </a:p>
+        </p:txBody>
+      </p:sp>
+      <p:sp>
+        <p:nvSpPr>
+          <p:cNvPr id="14" name="TextBox 13"/>
+          <p:cNvSpPr txBox="1"/>
+          <p:nvPr/>
+        </p:nvSpPr>
+        <p:spPr>
+          <a:xfrm>
+            <a:off x="3349675" y="3410712"/>
+            <a:ext cx="2471851" cy="347472"/>
+          </a:xfrm>
+          <a:prstGeom prst="rect">
+            <a:avLst/>
+          </a:prstGeom>
+          <a:noFill/>
+        </p:spPr>
+        <p:txBody>
+          <a:bodyPr wrap="square" anchor="t" lIns="0" rIns="0" tIns="0" bIns="0"/>
+          <a:lstStyle/>
+          <a:p>
+            <a:pPr algn="l">
+              <a:lnSpc>
+                <a:spcPct val="112000"/>
+              </a:lnSpc>
+              <a:spcBef>
+                <a:spcPts val="0"/>
+              </a:spcBef>
+              <a:spcAft>
+                <a:spcPts val="0"/>
+              </a:spcAft>
+            </a:pPr>
+            <a:r>
+              <a:rPr sz="1050" b="1" i="0" lang="en-AU" spc="0">
+                <a:solidFill>
+                  <a:srgbClr val="EA493F"/>
+                </a:solidFill>
+                <a:latin typeface="Inter"/>
+              </a:rPr>
+              <a:t>—  </a:t>
+            </a:r>
+            <a:r>
+              <a:rPr sz="1050" b="0" i="0" lang="en-AU" spc="0">
+                <a:solidFill>
+                  <a:srgbClr val="323232"/>
+                </a:solidFill>
+                <a:latin typeface="Inter"/>
+              </a:rPr>
+              <a:t>Payroll (AU / global)</a:t>
+            </a:r>
+          </a:p>
+        </p:txBody>
+      </p:sp>
+      <p:sp>
+        <p:nvSpPr>
+          <p:cNvPr id="15" name="TextBox 14"/>
+          <p:cNvSpPr txBox="1"/>
+          <p:nvPr/>
+        </p:nvSpPr>
+        <p:spPr>
+          <a:xfrm>
+            <a:off x="3349675" y="3758184"/>
+            <a:ext cx="2471851" cy="347472"/>
+          </a:xfrm>
+          <a:prstGeom prst="rect">
+            <a:avLst/>
+          </a:prstGeom>
+          <a:noFill/>
+        </p:spPr>
+        <p:txBody>
+          <a:bodyPr wrap="square" anchor="t" lIns="0" rIns="0" tIns="0" bIns="0"/>
+          <a:lstStyle/>
+          <a:p>
+            <a:pPr algn="l">
+              <a:lnSpc>
+                <a:spcPct val="112000"/>
+              </a:lnSpc>
+              <a:spcBef>
+                <a:spcPts val="0"/>
+              </a:spcBef>
+              <a:spcAft>
+                <a:spcPts val="0"/>
+              </a:spcAft>
+            </a:pPr>
+            <a:r>
+              <a:rPr sz="1050" b="1" i="0" lang="en-AU" spc="0">
+                <a:solidFill>
+                  <a:srgbClr val="EA493F"/>
+                </a:solidFill>
+                <a:latin typeface="Inter"/>
+              </a:rPr>
+              <a:t>—  </a:t>
+            </a:r>
+            <a:r>
+              <a:rPr sz="1050" b="0" i="0" lang="en-AU" spc="0">
+                <a:solidFill>
+                  <a:srgbClr val="323232"/>
+                </a:solidFill>
+                <a:latin typeface="Inter"/>
+              </a:rPr>
+              <a:t>Learning</a:t>
+            </a:r>
+          </a:p>
+        </p:txBody>
+      </p:sp>
+      <p:sp>
+        <p:nvSpPr>
+          <p:cNvPr id="16" name="TextBox 15"/>
+          <p:cNvSpPr txBox="1"/>
+          <p:nvPr/>
+        </p:nvSpPr>
+        <p:spPr>
+          <a:xfrm>
+            <a:off x="3349675" y="4105656"/>
+            <a:ext cx="2471851" cy="347472"/>
+          </a:xfrm>
+          <a:prstGeom prst="rect">
+            <a:avLst/>
+          </a:prstGeom>
+          <a:noFill/>
+        </p:spPr>
+        <p:txBody>
+          <a:bodyPr wrap="square" anchor="t" lIns="0" rIns="0" tIns="0" bIns="0"/>
+          <a:lstStyle/>
+          <a:p>
+            <a:pPr algn="l">
+              <a:lnSpc>
+                <a:spcPct val="112000"/>
+              </a:lnSpc>
+              <a:spcBef>
+                <a:spcPts val="0"/>
+              </a:spcBef>
+              <a:spcAft>
+                <a:spcPts val="0"/>
+              </a:spcAft>
+            </a:pPr>
+            <a:r>
+              <a:rPr sz="1050" b="1" i="0" lang="en-AU" spc="0">
+                <a:solidFill>
+                  <a:srgbClr val="EA493F"/>
+                </a:solidFill>
+                <a:latin typeface="Inter"/>
+              </a:rPr>
+              <a:t>—  </a:t>
+            </a:r>
+            <a:r>
+              <a:rPr sz="1050" b="0" i="0" lang="en-AU" spc="0">
+                <a:solidFill>
+                  <a:srgbClr val="323232"/>
+                </a:solidFill>
+                <a:latin typeface="Inter"/>
+              </a:rPr>
+              <a:t>Security &amp; BP config</a:t>
+            </a:r>
+          </a:p>
+        </p:txBody>
+      </p:sp>
+      <p:sp>
+        <p:nvSpPr>
+          <p:cNvPr id="17" name="TextBox 16"/>
+          <p:cNvSpPr txBox="1"/>
+          <p:nvPr/>
+        </p:nvSpPr>
+        <p:spPr>
+          <a:xfrm>
+            <a:off x="3349675" y="4453128"/>
+            <a:ext cx="2471851" cy="347472"/>
+          </a:xfrm>
+          <a:prstGeom prst="rect">
+            <a:avLst/>
+          </a:prstGeom>
+          <a:noFill/>
+        </p:spPr>
+        <p:txBody>
+          <a:bodyPr wrap="square" anchor="t" lIns="0" rIns="0" tIns="0" bIns="0"/>
+          <a:lstStyle/>
+          <a:p>
+            <a:pPr algn="l">
+              <a:lnSpc>
+                <a:spcPct val="112000"/>
+              </a:lnSpc>
+              <a:spcBef>
+                <a:spcPts val="0"/>
+              </a:spcBef>
+              <a:spcAft>
+                <a:spcPts val="0"/>
+              </a:spcAft>
+            </a:pPr>
+            <a:r>
+              <a:rPr sz="1050" b="1" i="0" lang="en-AU" spc="0">
+                <a:solidFill>
+                  <a:srgbClr val="EA493F"/>
+                </a:solidFill>
+                <a:latin typeface="Inter"/>
+              </a:rPr>
+              <a:t>—  </a:t>
+            </a:r>
+            <a:r>
+              <a:rPr sz="1050" b="0" i="0" lang="en-AU" spc="0">
+                <a:solidFill>
+                  <a:srgbClr val="323232"/>
+                </a:solidFill>
+                <a:latin typeface="Inter"/>
+              </a:rPr>
+              <a:t>Integrations (EIB, CC, Studio)</a:t>
+            </a:r>
+          </a:p>
+        </p:txBody>
+      </p:sp>
+      <p:sp>
+        <p:nvSpPr>
+          <p:cNvPr id="18" name="TextBox 17"/>
+          <p:cNvSpPr txBox="1"/>
+          <p:nvPr/>
+        </p:nvSpPr>
+        <p:spPr>
+          <a:xfrm>
+            <a:off x="3349675" y="4800600"/>
+            <a:ext cx="2471851" cy="347472"/>
+          </a:xfrm>
+          <a:prstGeom prst="rect">
+            <a:avLst/>
+          </a:prstGeom>
+          <a:noFill/>
+        </p:spPr>
+        <p:txBody>
+          <a:bodyPr wrap="square" anchor="t" lIns="0" rIns="0" tIns="0" bIns="0"/>
+          <a:lstStyle/>
+          <a:p>
+            <a:pPr algn="l">
+              <a:lnSpc>
+                <a:spcPct val="112000"/>
+              </a:lnSpc>
+              <a:spcBef>
+                <a:spcPts val="0"/>
+              </a:spcBef>
+              <a:spcAft>
+                <a:spcPts val="0"/>
+              </a:spcAft>
+            </a:pPr>
+            <a:r>
+              <a:rPr sz="1050" b="1" i="0" lang="en-AU" spc="0">
+                <a:solidFill>
+                  <a:srgbClr val="EA493F"/>
+                </a:solidFill>
+                <a:latin typeface="Inter"/>
+              </a:rPr>
+              <a:t>—  </a:t>
+            </a:r>
+            <a:r>
+              <a:rPr sz="1050" b="0" i="0" lang="en-AU" spc="0">
+                <a:solidFill>
+                  <a:srgbClr val="323232"/>
+                </a:solidFill>
+                <a:latin typeface="Inter"/>
+              </a:rPr>
+              <a:t>Advanced &amp; Composite Reporting</a:t>
+            </a:r>
+          </a:p>
+        </p:txBody>
+      </p:sp>
       <p:cxnSp>
         <p:nvCxnSpPr>
-          <p:cNvPr id="6" name="Connector 5"/>
+          <p:cNvPr id="19" name="Connector 18"/>
           <p:cNvCxnSpPr/>
           <p:nvPr/>
         </p:nvCxnSpPr>
         <p:spPr>
           <a:xfrm>
-            <a:off x="6089904" y="2468880"/>
+            <a:off x="6095847" y="2468880"/>
             <a:ext cx="0" cy="3200400"/>
           </a:xfrm>
           <a:prstGeom prst="bentConnector3">
@@ -3569,14 +4236,14 @@
       </p:cxnSp>
       <p:sp>
         <p:nvSpPr>
-          <p:cNvPr id="7" name="TextBox 6"/>
-          <p:cNvSpPr txBox="1"/>
-          <p:nvPr/>
-        </p:nvSpPr>
-        <p:spPr>
-          <a:xfrm>
-            <a:off x="877824" y="2468880"/>
-            <a:ext cx="4572000" cy="457200"/>
+          <p:cNvPr id="20" name="TextBox 19"/>
+          <p:cNvSpPr txBox="1"/>
+          <p:nvPr/>
+        </p:nvSpPr>
+        <p:spPr>
+          <a:xfrm>
+            <a:off x="6406743" y="2468880"/>
+            <a:ext cx="4632807" cy="457200"/>
           </a:xfrm>
           <a:prstGeom prst="rect">
             <a:avLst/>
@@ -3599,27 +4266,27 @@
               </a:spcAft>
             </a:pPr>
             <a:r>
-              <a:rPr sz="2200" b="1" i="0" lang="en-AU" spc="-44">
+              <a:rPr sz="2000" b="1" i="0" lang="en-AU" spc="-40">
                 <a:solidFill>
                   <a:srgbClr val="111111"/>
                 </a:solidFill>
                 <a:latin typeface="Inter"/>
               </a:rPr>
-              <a:t>HCM</a:t>
-            </a:r>
-          </a:p>
-        </p:txBody>
-      </p:sp>
-      <p:sp>
-        <p:nvSpPr>
-          <p:cNvPr id="8" name="TextBox 7"/>
-          <p:cNvSpPr txBox="1"/>
-          <p:nvPr/>
-        </p:nvSpPr>
-        <p:spPr>
-          <a:xfrm>
-            <a:off x="877824" y="3063240"/>
-            <a:ext cx="2286000" cy="347472"/>
+              <a:t>FIN</a:t>
+            </a:r>
+          </a:p>
+        </p:txBody>
+      </p:sp>
+      <p:sp>
+        <p:nvSpPr>
+          <p:cNvPr id="21" name="TextBox 20"/>
+          <p:cNvSpPr txBox="1"/>
+          <p:nvPr/>
+        </p:nvSpPr>
+        <p:spPr>
+          <a:xfrm>
+            <a:off x="6406743" y="3063240"/>
+            <a:ext cx="2316403" cy="347472"/>
           </a:xfrm>
           <a:prstGeom prst="rect">
             <a:avLst/>
@@ -3657,21 +4324,21 @@
                 </a:solidFill>
                 <a:latin typeface="Inter"/>
               </a:rPr>
-              <a:t>Core HCM</a:t>
-            </a:r>
-          </a:p>
-        </p:txBody>
-      </p:sp>
-      <p:sp>
-        <p:nvSpPr>
-          <p:cNvPr id="9" name="TextBox 8"/>
-          <p:cNvSpPr txBox="1"/>
-          <p:nvPr/>
-        </p:nvSpPr>
-        <p:spPr>
-          <a:xfrm>
-            <a:off x="877824" y="3410712"/>
-            <a:ext cx="2286000" cy="347472"/>
+              <a:t>Financial Accounting (GL)</a:t>
+            </a:r>
+          </a:p>
+        </p:txBody>
+      </p:sp>
+      <p:sp>
+        <p:nvSpPr>
+          <p:cNvPr id="22" name="TextBox 21"/>
+          <p:cNvSpPr txBox="1"/>
+          <p:nvPr/>
+        </p:nvSpPr>
+        <p:spPr>
+          <a:xfrm>
+            <a:off x="6406743" y="3410712"/>
+            <a:ext cx="2316403" cy="347472"/>
           </a:xfrm>
           <a:prstGeom prst="rect">
             <a:avLst/>
@@ -3709,21 +4376,21 @@
                 </a:solidFill>
                 <a:latin typeface="Inter"/>
               </a:rPr>
-              <a:t>Absence</a:t>
-            </a:r>
-          </a:p>
-        </p:txBody>
-      </p:sp>
-      <p:sp>
-        <p:nvSpPr>
-          <p:cNvPr id="10" name="TextBox 9"/>
-          <p:cNvSpPr txBox="1"/>
-          <p:nvPr/>
-        </p:nvSpPr>
-        <p:spPr>
-          <a:xfrm>
-            <a:off x="877824" y="3758184"/>
-            <a:ext cx="2286000" cy="347472"/>
+              <a:t>Accounting Center</a:t>
+            </a:r>
+          </a:p>
+        </p:txBody>
+      </p:sp>
+      <p:sp>
+        <p:nvSpPr>
+          <p:cNvPr id="23" name="TextBox 22"/>
+          <p:cNvSpPr txBox="1"/>
+          <p:nvPr/>
+        </p:nvSpPr>
+        <p:spPr>
+          <a:xfrm>
+            <a:off x="6406743" y="3758184"/>
+            <a:ext cx="2316403" cy="347472"/>
           </a:xfrm>
           <a:prstGeom prst="rect">
             <a:avLst/>
@@ -3761,21 +4428,21 @@
                 </a:solidFill>
                 <a:latin typeface="Inter"/>
               </a:rPr>
-              <a:t>Time Tracking</a:t>
-            </a:r>
-          </a:p>
-        </p:txBody>
-      </p:sp>
-      <p:sp>
-        <p:nvSpPr>
-          <p:cNvPr id="11" name="TextBox 10"/>
-          <p:cNvSpPr txBox="1"/>
-          <p:nvPr/>
-        </p:nvSpPr>
-        <p:spPr>
-          <a:xfrm>
-            <a:off x="877824" y="4105656"/>
-            <a:ext cx="2286000" cy="347472"/>
+              <a:t>Accounts Payable / Suppliers</a:t>
+            </a:r>
+          </a:p>
+        </p:txBody>
+      </p:sp>
+      <p:sp>
+        <p:nvSpPr>
+          <p:cNvPr id="24" name="TextBox 23"/>
+          <p:cNvSpPr txBox="1"/>
+          <p:nvPr/>
+        </p:nvSpPr>
+        <p:spPr>
+          <a:xfrm>
+            <a:off x="6406743" y="4105656"/>
+            <a:ext cx="2316403" cy="347472"/>
           </a:xfrm>
           <a:prstGeom prst="rect">
             <a:avLst/>
@@ -3813,21 +4480,21 @@
                 </a:solidFill>
                 <a:latin typeface="Inter"/>
               </a:rPr>
-              <a:t>Recruiting</a:t>
-            </a:r>
-          </a:p>
-        </p:txBody>
-      </p:sp>
-      <p:sp>
-        <p:nvSpPr>
-          <p:cNvPr id="12" name="TextBox 11"/>
-          <p:cNvSpPr txBox="1"/>
-          <p:nvPr/>
-        </p:nvSpPr>
-        <p:spPr>
-          <a:xfrm>
-            <a:off x="877824" y="4453128"/>
-            <a:ext cx="2286000" cy="347472"/>
+              <a:t>Accounts Receivable / Customers</a:t>
+            </a:r>
+          </a:p>
+        </p:txBody>
+      </p:sp>
+      <p:sp>
+        <p:nvSpPr>
+          <p:cNvPr id="25" name="TextBox 24"/>
+          <p:cNvSpPr txBox="1"/>
+          <p:nvPr/>
+        </p:nvSpPr>
+        <p:spPr>
+          <a:xfrm>
+            <a:off x="6406743" y="4453128"/>
+            <a:ext cx="2316403" cy="347472"/>
           </a:xfrm>
           <a:prstGeom prst="rect">
             <a:avLst/>
@@ -3865,21 +4532,21 @@
                 </a:solidFill>
                 <a:latin typeface="Inter"/>
               </a:rPr>
-              <a:t>Talent &amp; Performance</a:t>
-            </a:r>
-          </a:p>
-        </p:txBody>
-      </p:sp>
-      <p:sp>
-        <p:nvSpPr>
-          <p:cNvPr id="13" name="TextBox 12"/>
-          <p:cNvSpPr txBox="1"/>
-          <p:nvPr/>
-        </p:nvSpPr>
-        <p:spPr>
-          <a:xfrm>
-            <a:off x="877824" y="4800600"/>
-            <a:ext cx="2286000" cy="347472"/>
+              <a:t>Procurement</a:t>
+            </a:r>
+          </a:p>
+        </p:txBody>
+      </p:sp>
+      <p:sp>
+        <p:nvSpPr>
+          <p:cNvPr id="26" name="TextBox 25"/>
+          <p:cNvSpPr txBox="1"/>
+          <p:nvPr/>
+        </p:nvSpPr>
+        <p:spPr>
+          <a:xfrm>
+            <a:off x="6406743" y="4800600"/>
+            <a:ext cx="2316403" cy="347472"/>
           </a:xfrm>
           <a:prstGeom prst="rect">
             <a:avLst/>
@@ -3917,21 +4584,21 @@
                 </a:solidFill>
                 <a:latin typeface="Inter"/>
               </a:rPr>
-              <a:t>Compensation</a:t>
-            </a:r>
-          </a:p>
-        </p:txBody>
-      </p:sp>
-      <p:sp>
-        <p:nvSpPr>
-          <p:cNvPr id="14" name="TextBox 13"/>
-          <p:cNvSpPr txBox="1"/>
-          <p:nvPr/>
-        </p:nvSpPr>
-        <p:spPr>
-          <a:xfrm>
-            <a:off x="3209544" y="3063240"/>
-            <a:ext cx="2286000" cy="347472"/>
+              <a:t>Expenses</a:t>
+            </a:r>
+          </a:p>
+        </p:txBody>
+      </p:sp>
+      <p:sp>
+        <p:nvSpPr>
+          <p:cNvPr id="27" name="TextBox 26"/>
+          <p:cNvSpPr txBox="1"/>
+          <p:nvPr/>
+        </p:nvSpPr>
+        <p:spPr>
+          <a:xfrm>
+            <a:off x="8723147" y="3063240"/>
+            <a:ext cx="2316403" cy="347472"/>
           </a:xfrm>
           <a:prstGeom prst="rect">
             <a:avLst/>
@@ -3969,21 +4636,21 @@
                 </a:solidFill>
                 <a:latin typeface="Inter"/>
               </a:rPr>
-              <a:t>Benefits</a:t>
-            </a:r>
-          </a:p>
-        </p:txBody>
-      </p:sp>
-      <p:sp>
-        <p:nvSpPr>
-          <p:cNvPr id="15" name="TextBox 14"/>
-          <p:cNvSpPr txBox="1"/>
-          <p:nvPr/>
-        </p:nvSpPr>
-        <p:spPr>
-          <a:xfrm>
-            <a:off x="3209544" y="3410712"/>
-            <a:ext cx="2286000" cy="347472"/>
+              <a:t>Banking &amp; Settlement</a:t>
+            </a:r>
+          </a:p>
+        </p:txBody>
+      </p:sp>
+      <p:sp>
+        <p:nvSpPr>
+          <p:cNvPr id="28" name="TextBox 27"/>
+          <p:cNvSpPr txBox="1"/>
+          <p:nvPr/>
+        </p:nvSpPr>
+        <p:spPr>
+          <a:xfrm>
+            <a:off x="8723147" y="3410712"/>
+            <a:ext cx="2316403" cy="347472"/>
           </a:xfrm>
           <a:prstGeom prst="rect">
             <a:avLst/>
@@ -4021,21 +4688,21 @@
                 </a:solidFill>
                 <a:latin typeface="Inter"/>
               </a:rPr>
-              <a:t>Payroll (AU / global)</a:t>
-            </a:r>
-          </a:p>
-        </p:txBody>
-      </p:sp>
-      <p:sp>
-        <p:nvSpPr>
-          <p:cNvPr id="16" name="TextBox 15"/>
-          <p:cNvSpPr txBox="1"/>
-          <p:nvPr/>
-        </p:nvSpPr>
-        <p:spPr>
-          <a:xfrm>
-            <a:off x="3209544" y="3758184"/>
-            <a:ext cx="2286000" cy="347472"/>
+              <a:t>Business Assets</a:t>
+            </a:r>
+          </a:p>
+        </p:txBody>
+      </p:sp>
+      <p:sp>
+        <p:nvSpPr>
+          <p:cNvPr id="29" name="TextBox 28"/>
+          <p:cNvSpPr txBox="1"/>
+          <p:nvPr/>
+        </p:nvSpPr>
+        <p:spPr>
+          <a:xfrm>
+            <a:off x="8723147" y="3758184"/>
+            <a:ext cx="2316403" cy="347472"/>
           </a:xfrm>
           <a:prstGeom prst="rect">
             <a:avLst/>
@@ -4073,21 +4740,21 @@
                 </a:solidFill>
                 <a:latin typeface="Inter"/>
               </a:rPr>
-              <a:t>Learning</a:t>
-            </a:r>
-          </a:p>
-        </p:txBody>
-      </p:sp>
-      <p:sp>
-        <p:nvSpPr>
-          <p:cNvPr id="17" name="TextBox 16"/>
-          <p:cNvSpPr txBox="1"/>
-          <p:nvPr/>
-        </p:nvSpPr>
-        <p:spPr>
-          <a:xfrm>
-            <a:off x="3209544" y="4105656"/>
-            <a:ext cx="2286000" cy="347472"/>
+              <a:t>Financial Reporting</a:t>
+            </a:r>
+          </a:p>
+        </p:txBody>
+      </p:sp>
+      <p:sp>
+        <p:nvSpPr>
+          <p:cNvPr id="30" name="TextBox 29"/>
+          <p:cNvSpPr txBox="1"/>
+          <p:nvPr/>
+        </p:nvSpPr>
+        <p:spPr>
+          <a:xfrm>
+            <a:off x="8723147" y="4105656"/>
+            <a:ext cx="2316403" cy="347472"/>
           </a:xfrm>
           <a:prstGeom prst="rect">
             <a:avLst/>
@@ -4125,6 +4792,58 @@
                 </a:solidFill>
                 <a:latin typeface="Inter"/>
               </a:rPr>
+              <a:t>Prism Analytics</a:t>
+            </a:r>
+          </a:p>
+        </p:txBody>
+      </p:sp>
+      <p:sp>
+        <p:nvSpPr>
+          <p:cNvPr id="31" name="TextBox 30"/>
+          <p:cNvSpPr txBox="1"/>
+          <p:nvPr/>
+        </p:nvSpPr>
+        <p:spPr>
+          <a:xfrm>
+            <a:off x="8723147" y="4453128"/>
+            <a:ext cx="2316403" cy="347472"/>
+          </a:xfrm>
+          <a:prstGeom prst="rect">
+            <a:avLst/>
+          </a:prstGeom>
+          <a:noFill/>
+        </p:spPr>
+        <p:txBody>
+          <a:bodyPr wrap="square" anchor="t" lIns="0" rIns="0" tIns="0" bIns="0"/>
+          <a:lstStyle/>
+          <a:p>
+            <a:pPr algn="l">
+              <a:lnSpc>
+                <a:spcPct val="112000"/>
+              </a:lnSpc>
+              <a:spcBef>
+                <a:spcPts val="0"/>
+              </a:spcBef>
+              <a:spcAft>
+                <a:spcPts val="0"/>
+              </a:spcAft>
+            </a:pPr>
+            <a:r>
+              <a:rPr sz="1050" b="1" i="0" lang="en-AU" spc="0">
+                <a:solidFill>
+                  <a:srgbClr val="EA493F"/>
+                </a:solidFill>
+                <a:latin typeface="Inter"/>
+              </a:rPr>
+              <a:t>—  </a:t>
+            </a:r>
+            <a:r>
+              <a:rPr sz="1050" b="0" i="0" lang="en-AU" spc="0">
+                <a:solidFill>
+                  <a:srgbClr val="323232"/>
+                </a:solidFill>
+                <a:latin typeface="Inter"/>
+              </a:rPr>
               <a:t>Security &amp; BP config</a:t>
             </a:r>
           </a:p>
@@ -4132,14 +4851,14 @@
       </p:sp>
       <p:sp>
         <p:nvSpPr>
-          <p:cNvPr id="18" name="TextBox 17"/>
-          <p:cNvSpPr txBox="1"/>
-          <p:nvPr/>
-        </p:nvSpPr>
-        <p:spPr>
-          <a:xfrm>
-            <a:off x="3209544" y="4453128"/>
-            <a:ext cx="2286000" cy="347472"/>
+          <p:cNvPr id="32" name="TextBox 31"/>
+          <p:cNvSpPr txBox="1"/>
+          <p:nvPr/>
+        </p:nvSpPr>
+        <p:spPr>
+          <a:xfrm>
+            <a:off x="8723147" y="4800600"/>
+            <a:ext cx="2316403" cy="347472"/>
           </a:xfrm>
           <a:prstGeom prst="rect">
             <a:avLst/>
@@ -4184,14 +4903,14 @@
       </p:sp>
       <p:sp>
         <p:nvSpPr>
-          <p:cNvPr id="19" name="TextBox 18"/>
-          <p:cNvSpPr txBox="1"/>
-          <p:nvPr/>
-        </p:nvSpPr>
-        <p:spPr>
-          <a:xfrm>
-            <a:off x="3209544" y="4800600"/>
-            <a:ext cx="2286000" cy="347472"/>
+          <p:cNvPr id="33" name="TextBox 32"/>
+          <p:cNvSpPr txBox="1"/>
+          <p:nvPr/>
+        </p:nvSpPr>
+        <p:spPr>
+          <a:xfrm>
+            <a:off x="877824" y="6035040"/>
+            <a:ext cx="10436047" cy="365760"/>
           </a:xfrm>
           <a:prstGeom prst="rect">
             <a:avLst/>
@@ -4204,751 +4923,23 @@
           <a:p>
             <a:pPr algn="l">
               <a:lnSpc>
-                <a:spcPct val="112000"/>
-              </a:lnSpc>
-              <a:spcBef>
-                <a:spcPts val="0"/>
-              </a:spcBef>
-              <a:spcAft>
-                <a:spcPts val="0"/>
-              </a:spcAft>
-            </a:pPr>
-            <a:r>
-              <a:rPr sz="1050" b="1" i="0" lang="en-AU" spc="0">
+                <a:spcPct val="100000"/>
+              </a:lnSpc>
+              <a:spcBef>
+                <a:spcPts val="0"/>
+              </a:spcBef>
+              <a:spcAft>
+                <a:spcPts val="0"/>
+              </a:spcAft>
+            </a:pPr>
+            <a:r>
+              <a:rPr sz="1250" b="1" i="0" lang="en-AU" spc="25">
                 <a:solidFill>
                   <a:srgbClr val="EA493F"/>
                 </a:solidFill>
                 <a:latin typeface="Inter"/>
               </a:rPr>
-              <a:t>—  </a:t>
-            </a:r>
-            <a:r>
-              <a:rPr sz="1050" b="0" i="0" lang="en-AU" spc="0">
-                <a:solidFill>
-                  <a:srgbClr val="323232"/>
-                </a:solidFill>
-                <a:latin typeface="Inter"/>
-              </a:rPr>
-              <a:t>Advanced &amp; Composite Reporting</a:t>
-            </a:r>
-          </a:p>
-        </p:txBody>
-      </p:sp>
-      <p:sp>
-        <p:nvSpPr>
-          <p:cNvPr id="20" name="TextBox 19"/>
-          <p:cNvSpPr txBox="1"/>
-          <p:nvPr/>
-        </p:nvSpPr>
-        <p:spPr>
-          <a:xfrm>
-            <a:off x="6400800" y="2468880"/>
-            <a:ext cx="4572000" cy="457200"/>
-          </a:xfrm>
-          <a:prstGeom prst="rect">
-            <a:avLst/>
-          </a:prstGeom>
-          <a:noFill/>
-        </p:spPr>
-        <p:txBody>
-          <a:bodyPr wrap="square" anchor="t" lIns="0" rIns="0" tIns="0" bIns="0"/>
-          <a:lstStyle/>
-          <a:p>
-            <a:pPr algn="l">
-              <a:lnSpc>
-                <a:spcPct val="100000"/>
-              </a:lnSpc>
-              <a:spcBef>
-                <a:spcPts val="0"/>
-              </a:spcBef>
-              <a:spcAft>
-                <a:spcPts val="0"/>
-              </a:spcAft>
-            </a:pPr>
-            <a:r>
-              <a:rPr sz="2200" b="1" i="0" lang="en-AU" spc="-44">
-                <a:solidFill>
-                  <a:srgbClr val="111111"/>
-                </a:solidFill>
-                <a:latin typeface="Inter"/>
-              </a:rPr>
-              <a:t>FIN</a:t>
-            </a:r>
-          </a:p>
-        </p:txBody>
-      </p:sp>
-      <p:sp>
-        <p:nvSpPr>
-          <p:cNvPr id="21" name="TextBox 20"/>
-          <p:cNvSpPr txBox="1"/>
-          <p:nvPr/>
-        </p:nvSpPr>
-        <p:spPr>
-          <a:xfrm>
-            <a:off x="6400800" y="3063240"/>
-            <a:ext cx="2286000" cy="347472"/>
-          </a:xfrm>
-          <a:prstGeom prst="rect">
-            <a:avLst/>
-          </a:prstGeom>
-          <a:noFill/>
-        </p:spPr>
-        <p:txBody>
-          <a:bodyPr wrap="square" anchor="t" lIns="0" rIns="0" tIns="0" bIns="0"/>
-          <a:lstStyle/>
-          <a:p>
-            <a:pPr algn="l">
-              <a:lnSpc>
-                <a:spcPct val="112000"/>
-              </a:lnSpc>
-              <a:spcBef>
-                <a:spcPts val="0"/>
-              </a:spcBef>
-              <a:spcAft>
-                <a:spcPts val="0"/>
-              </a:spcAft>
-            </a:pPr>
-            <a:r>
-              <a:rPr sz="1050" b="1" i="0" lang="en-AU" spc="0">
-                <a:solidFill>
-                  <a:srgbClr val="EA493F"/>
-                </a:solidFill>
-                <a:latin typeface="Inter"/>
-              </a:rPr>
-              <a:t>—  </a:t>
-            </a:r>
-            <a:r>
-              <a:rPr sz="1050" b="0" i="0" lang="en-AU" spc="0">
-                <a:solidFill>
-                  <a:srgbClr val="323232"/>
-                </a:solidFill>
-                <a:latin typeface="Inter"/>
-              </a:rPr>
-              <a:t>Financial Accounting (GL)</a:t>
-            </a:r>
-          </a:p>
-        </p:txBody>
-      </p:sp>
-      <p:sp>
-        <p:nvSpPr>
-          <p:cNvPr id="22" name="TextBox 21"/>
-          <p:cNvSpPr txBox="1"/>
-          <p:nvPr/>
-        </p:nvSpPr>
-        <p:spPr>
-          <a:xfrm>
-            <a:off x="6400800" y="3410712"/>
-            <a:ext cx="2286000" cy="347472"/>
-          </a:xfrm>
-          <a:prstGeom prst="rect">
-            <a:avLst/>
-          </a:prstGeom>
-          <a:noFill/>
-        </p:spPr>
-        <p:txBody>
-          <a:bodyPr wrap="square" anchor="t" lIns="0" rIns="0" tIns="0" bIns="0"/>
-          <a:lstStyle/>
-          <a:p>
-            <a:pPr algn="l">
-              <a:lnSpc>
-                <a:spcPct val="112000"/>
-              </a:lnSpc>
-              <a:spcBef>
-                <a:spcPts val="0"/>
-              </a:spcBef>
-              <a:spcAft>
-                <a:spcPts val="0"/>
-              </a:spcAft>
-            </a:pPr>
-            <a:r>
-              <a:rPr sz="1050" b="1" i="0" lang="en-AU" spc="0">
-                <a:solidFill>
-                  <a:srgbClr val="EA493F"/>
-                </a:solidFill>
-                <a:latin typeface="Inter"/>
-              </a:rPr>
-              <a:t>—  </a:t>
-            </a:r>
-            <a:r>
-              <a:rPr sz="1050" b="0" i="0" lang="en-AU" spc="0">
-                <a:solidFill>
-                  <a:srgbClr val="323232"/>
-                </a:solidFill>
-                <a:latin typeface="Inter"/>
-              </a:rPr>
-              <a:t>Accounting Center</a:t>
-            </a:r>
-          </a:p>
-        </p:txBody>
-      </p:sp>
-      <p:sp>
-        <p:nvSpPr>
-          <p:cNvPr id="23" name="TextBox 22"/>
-          <p:cNvSpPr txBox="1"/>
-          <p:nvPr/>
-        </p:nvSpPr>
-        <p:spPr>
-          <a:xfrm>
-            <a:off x="6400800" y="3758184"/>
-            <a:ext cx="2286000" cy="347472"/>
-          </a:xfrm>
-          <a:prstGeom prst="rect">
-            <a:avLst/>
-          </a:prstGeom>
-          <a:noFill/>
-        </p:spPr>
-        <p:txBody>
-          <a:bodyPr wrap="square" anchor="t" lIns="0" rIns="0" tIns="0" bIns="0"/>
-          <a:lstStyle/>
-          <a:p>
-            <a:pPr algn="l">
-              <a:lnSpc>
-                <a:spcPct val="112000"/>
-              </a:lnSpc>
-              <a:spcBef>
-                <a:spcPts val="0"/>
-              </a:spcBef>
-              <a:spcAft>
-                <a:spcPts val="0"/>
-              </a:spcAft>
-            </a:pPr>
-            <a:r>
-              <a:rPr sz="1050" b="1" i="0" lang="en-AU" spc="0">
-                <a:solidFill>
-                  <a:srgbClr val="EA493F"/>
-                </a:solidFill>
-                <a:latin typeface="Inter"/>
-              </a:rPr>
-              <a:t>—  </a:t>
-            </a:r>
-            <a:r>
-              <a:rPr sz="1050" b="0" i="0" lang="en-AU" spc="0">
-                <a:solidFill>
-                  <a:srgbClr val="323232"/>
-                </a:solidFill>
-                <a:latin typeface="Inter"/>
-              </a:rPr>
-              <a:t>Accounts Payable / Suppliers</a:t>
-            </a:r>
-          </a:p>
-        </p:txBody>
-      </p:sp>
-      <p:sp>
-        <p:nvSpPr>
-          <p:cNvPr id="24" name="TextBox 23"/>
-          <p:cNvSpPr txBox="1"/>
-          <p:nvPr/>
-        </p:nvSpPr>
-        <p:spPr>
-          <a:xfrm>
-            <a:off x="6400800" y="4105656"/>
-            <a:ext cx="2286000" cy="347472"/>
-          </a:xfrm>
-          <a:prstGeom prst="rect">
-            <a:avLst/>
-          </a:prstGeom>
-          <a:noFill/>
-        </p:spPr>
-        <p:txBody>
-          <a:bodyPr wrap="square" anchor="t" lIns="0" rIns="0" tIns="0" bIns="0"/>
-          <a:lstStyle/>
-          <a:p>
-            <a:pPr algn="l">
-              <a:lnSpc>
-                <a:spcPct val="112000"/>
-              </a:lnSpc>
-              <a:spcBef>
-                <a:spcPts val="0"/>
-              </a:spcBef>
-              <a:spcAft>
-                <a:spcPts val="0"/>
-              </a:spcAft>
-            </a:pPr>
-            <a:r>
-              <a:rPr sz="1050" b="1" i="0" lang="en-AU" spc="0">
-                <a:solidFill>
-                  <a:srgbClr val="EA493F"/>
-                </a:solidFill>
-                <a:latin typeface="Inter"/>
-              </a:rPr>
-              <a:t>—  </a:t>
-            </a:r>
-            <a:r>
-              <a:rPr sz="1050" b="0" i="0" lang="en-AU" spc="0">
-                <a:solidFill>
-                  <a:srgbClr val="323232"/>
-                </a:solidFill>
-                <a:latin typeface="Inter"/>
-              </a:rPr>
-              <a:t>Accounts Receivable / Customers</a:t>
-            </a:r>
-          </a:p>
-        </p:txBody>
-      </p:sp>
-      <p:sp>
-        <p:nvSpPr>
-          <p:cNvPr id="25" name="TextBox 24"/>
-          <p:cNvSpPr txBox="1"/>
-          <p:nvPr/>
-        </p:nvSpPr>
-        <p:spPr>
-          <a:xfrm>
-            <a:off x="6400800" y="4453128"/>
-            <a:ext cx="2286000" cy="347472"/>
-          </a:xfrm>
-          <a:prstGeom prst="rect">
-            <a:avLst/>
-          </a:prstGeom>
-          <a:noFill/>
-        </p:spPr>
-        <p:txBody>
-          <a:bodyPr wrap="square" anchor="t" lIns="0" rIns="0" tIns="0" bIns="0"/>
-          <a:lstStyle/>
-          <a:p>
-            <a:pPr algn="l">
-              <a:lnSpc>
-                <a:spcPct val="112000"/>
-              </a:lnSpc>
-              <a:spcBef>
-                <a:spcPts val="0"/>
-              </a:spcBef>
-              <a:spcAft>
-                <a:spcPts val="0"/>
-              </a:spcAft>
-            </a:pPr>
-            <a:r>
-              <a:rPr sz="1050" b="1" i="0" lang="en-AU" spc="0">
-                <a:solidFill>
-                  <a:srgbClr val="EA493F"/>
-                </a:solidFill>
-                <a:latin typeface="Inter"/>
-              </a:rPr>
-              <a:t>—  </a:t>
-            </a:r>
-            <a:r>
-              <a:rPr sz="1050" b="0" i="0" lang="en-AU" spc="0">
-                <a:solidFill>
-                  <a:srgbClr val="323232"/>
-                </a:solidFill>
-                <a:latin typeface="Inter"/>
-              </a:rPr>
-              <a:t>Procurement</a:t>
-            </a:r>
-          </a:p>
-        </p:txBody>
-      </p:sp>
-      <p:sp>
-        <p:nvSpPr>
-          <p:cNvPr id="26" name="TextBox 25"/>
-          <p:cNvSpPr txBox="1"/>
-          <p:nvPr/>
-        </p:nvSpPr>
-        <p:spPr>
-          <a:xfrm>
-            <a:off x="6400800" y="4800600"/>
-            <a:ext cx="2286000" cy="347472"/>
-          </a:xfrm>
-          <a:prstGeom prst="rect">
-            <a:avLst/>
-          </a:prstGeom>
-          <a:noFill/>
-        </p:spPr>
-        <p:txBody>
-          <a:bodyPr wrap="square" anchor="t" lIns="0" rIns="0" tIns="0" bIns="0"/>
-          <a:lstStyle/>
-          <a:p>
-            <a:pPr algn="l">
-              <a:lnSpc>
-                <a:spcPct val="112000"/>
-              </a:lnSpc>
-              <a:spcBef>
-                <a:spcPts val="0"/>
-              </a:spcBef>
-              <a:spcAft>
-                <a:spcPts val="0"/>
-              </a:spcAft>
-            </a:pPr>
-            <a:r>
-              <a:rPr sz="1050" b="1" i="0" lang="en-AU" spc="0">
-                <a:solidFill>
-                  <a:srgbClr val="EA493F"/>
-                </a:solidFill>
-                <a:latin typeface="Inter"/>
-              </a:rPr>
-              <a:t>—  </a:t>
-            </a:r>
-            <a:r>
-              <a:rPr sz="1050" b="0" i="0" lang="en-AU" spc="0">
-                <a:solidFill>
-                  <a:srgbClr val="323232"/>
-                </a:solidFill>
-                <a:latin typeface="Inter"/>
-              </a:rPr>
-              <a:t>Expenses</a:t>
-            </a:r>
-          </a:p>
-        </p:txBody>
-      </p:sp>
-      <p:sp>
-        <p:nvSpPr>
-          <p:cNvPr id="27" name="TextBox 26"/>
-          <p:cNvSpPr txBox="1"/>
-          <p:nvPr/>
-        </p:nvSpPr>
-        <p:spPr>
-          <a:xfrm>
-            <a:off x="8732520" y="3063240"/>
-            <a:ext cx="2286000" cy="347472"/>
-          </a:xfrm>
-          <a:prstGeom prst="rect">
-            <a:avLst/>
-          </a:prstGeom>
-          <a:noFill/>
-        </p:spPr>
-        <p:txBody>
-          <a:bodyPr wrap="square" anchor="t" lIns="0" rIns="0" tIns="0" bIns="0"/>
-          <a:lstStyle/>
-          <a:p>
-            <a:pPr algn="l">
-              <a:lnSpc>
-                <a:spcPct val="112000"/>
-              </a:lnSpc>
-              <a:spcBef>
-                <a:spcPts val="0"/>
-              </a:spcBef>
-              <a:spcAft>
-                <a:spcPts val="0"/>
-              </a:spcAft>
-            </a:pPr>
-            <a:r>
-              <a:rPr sz="1050" b="1" i="0" lang="en-AU" spc="0">
-                <a:solidFill>
-                  <a:srgbClr val="EA493F"/>
-                </a:solidFill>
-                <a:latin typeface="Inter"/>
-              </a:rPr>
-              <a:t>—  </a:t>
-            </a:r>
-            <a:r>
-              <a:rPr sz="1050" b="0" i="0" lang="en-AU" spc="0">
-                <a:solidFill>
-                  <a:srgbClr val="323232"/>
-                </a:solidFill>
-                <a:latin typeface="Inter"/>
-              </a:rPr>
-              <a:t>Banking &amp; Settlement</a:t>
-            </a:r>
-          </a:p>
-        </p:txBody>
-      </p:sp>
-      <p:sp>
-        <p:nvSpPr>
-          <p:cNvPr id="28" name="TextBox 27"/>
-          <p:cNvSpPr txBox="1"/>
-          <p:nvPr/>
-        </p:nvSpPr>
-        <p:spPr>
-          <a:xfrm>
-            <a:off x="8732520" y="3410712"/>
-            <a:ext cx="2286000" cy="347472"/>
-          </a:xfrm>
-          <a:prstGeom prst="rect">
-            <a:avLst/>
-          </a:prstGeom>
-          <a:noFill/>
-        </p:spPr>
-        <p:txBody>
-          <a:bodyPr wrap="square" anchor="t" lIns="0" rIns="0" tIns="0" bIns="0"/>
-          <a:lstStyle/>
-          <a:p>
-            <a:pPr algn="l">
-              <a:lnSpc>
-                <a:spcPct val="112000"/>
-              </a:lnSpc>
-              <a:spcBef>
-                <a:spcPts val="0"/>
-              </a:spcBef>
-              <a:spcAft>
-                <a:spcPts val="0"/>
-              </a:spcAft>
-            </a:pPr>
-            <a:r>
-              <a:rPr sz="1050" b="1" i="0" lang="en-AU" spc="0">
-                <a:solidFill>
-                  <a:srgbClr val="EA493F"/>
-                </a:solidFill>
-                <a:latin typeface="Inter"/>
-              </a:rPr>
-              <a:t>—  </a:t>
-            </a:r>
-            <a:r>
-              <a:rPr sz="1050" b="0" i="0" lang="en-AU" spc="0">
-                <a:solidFill>
-                  <a:srgbClr val="323232"/>
-                </a:solidFill>
-                <a:latin typeface="Inter"/>
-              </a:rPr>
-              <a:t>Business Assets</a:t>
-            </a:r>
-          </a:p>
-        </p:txBody>
-      </p:sp>
-      <p:sp>
-        <p:nvSpPr>
-          <p:cNvPr id="29" name="TextBox 28"/>
-          <p:cNvSpPr txBox="1"/>
-          <p:nvPr/>
-        </p:nvSpPr>
-        <p:spPr>
-          <a:xfrm>
-            <a:off x="8732520" y="3758184"/>
-            <a:ext cx="2286000" cy="347472"/>
-          </a:xfrm>
-          <a:prstGeom prst="rect">
-            <a:avLst/>
-          </a:prstGeom>
-          <a:noFill/>
-        </p:spPr>
-        <p:txBody>
-          <a:bodyPr wrap="square" anchor="t" lIns="0" rIns="0" tIns="0" bIns="0"/>
-          <a:lstStyle/>
-          <a:p>
-            <a:pPr algn="l">
-              <a:lnSpc>
-                <a:spcPct val="112000"/>
-              </a:lnSpc>
-              <a:spcBef>
-                <a:spcPts val="0"/>
-              </a:spcBef>
-              <a:spcAft>
-                <a:spcPts val="0"/>
-              </a:spcAft>
-            </a:pPr>
-            <a:r>
-              <a:rPr sz="1050" b="1" i="0" lang="en-AU" spc="0">
-                <a:solidFill>
-                  <a:srgbClr val="EA493F"/>
-                </a:solidFill>
-                <a:latin typeface="Inter"/>
-              </a:rPr>
-              <a:t>—  </a:t>
-            </a:r>
-            <a:r>
-              <a:rPr sz="1050" b="0" i="0" lang="en-AU" spc="0">
-                <a:solidFill>
-                  <a:srgbClr val="323232"/>
-                </a:solidFill>
-                <a:latin typeface="Inter"/>
-              </a:rPr>
-              <a:t>Financial Reporting</a:t>
-            </a:r>
-          </a:p>
-        </p:txBody>
-      </p:sp>
-      <p:sp>
-        <p:nvSpPr>
-          <p:cNvPr id="30" name="TextBox 29"/>
-          <p:cNvSpPr txBox="1"/>
-          <p:nvPr/>
-        </p:nvSpPr>
-        <p:spPr>
-          <a:xfrm>
-            <a:off x="8732520" y="4105656"/>
-            <a:ext cx="2286000" cy="347472"/>
-          </a:xfrm>
-          <a:prstGeom prst="rect">
-            <a:avLst/>
-          </a:prstGeom>
-          <a:noFill/>
-        </p:spPr>
-        <p:txBody>
-          <a:bodyPr wrap="square" anchor="t" lIns="0" rIns="0" tIns="0" bIns="0"/>
-          <a:lstStyle/>
-          <a:p>
-            <a:pPr algn="l">
-              <a:lnSpc>
-                <a:spcPct val="112000"/>
-              </a:lnSpc>
-              <a:spcBef>
-                <a:spcPts val="0"/>
-              </a:spcBef>
-              <a:spcAft>
-                <a:spcPts val="0"/>
-              </a:spcAft>
-            </a:pPr>
-            <a:r>
-              <a:rPr sz="1050" b="1" i="0" lang="en-AU" spc="0">
-                <a:solidFill>
-                  <a:srgbClr val="EA493F"/>
-                </a:solidFill>
-                <a:latin typeface="Inter"/>
-              </a:rPr>
-              <a:t>—  </a:t>
-            </a:r>
-            <a:r>
-              <a:rPr sz="1050" b="0" i="0" lang="en-AU" spc="0">
-                <a:solidFill>
-                  <a:srgbClr val="323232"/>
-                </a:solidFill>
-                <a:latin typeface="Inter"/>
-              </a:rPr>
-              <a:t>Prism Analytics</a:t>
-            </a:r>
-          </a:p>
-        </p:txBody>
-      </p:sp>
-      <p:sp>
-        <p:nvSpPr>
-          <p:cNvPr id="31" name="TextBox 30"/>
-          <p:cNvSpPr txBox="1"/>
-          <p:nvPr/>
-        </p:nvSpPr>
-        <p:spPr>
-          <a:xfrm>
-            <a:off x="8732520" y="4453128"/>
-            <a:ext cx="2286000" cy="347472"/>
-          </a:xfrm>
-          <a:prstGeom prst="rect">
-            <a:avLst/>
-          </a:prstGeom>
-          <a:noFill/>
-        </p:spPr>
-        <p:txBody>
-          <a:bodyPr wrap="square" anchor="t" lIns="0" rIns="0" tIns="0" bIns="0"/>
-          <a:lstStyle/>
-          <a:p>
-            <a:pPr algn="l">
-              <a:lnSpc>
-                <a:spcPct val="112000"/>
-              </a:lnSpc>
-              <a:spcBef>
-                <a:spcPts val="0"/>
-              </a:spcBef>
-              <a:spcAft>
-                <a:spcPts val="0"/>
-              </a:spcAft>
-            </a:pPr>
-            <a:r>
-              <a:rPr sz="1050" b="1" i="0" lang="en-AU" spc="0">
-                <a:solidFill>
-                  <a:srgbClr val="EA493F"/>
-                </a:solidFill>
-                <a:latin typeface="Inter"/>
-              </a:rPr>
-              <a:t>—  </a:t>
-            </a:r>
-            <a:r>
-              <a:rPr sz="1050" b="0" i="0" lang="en-AU" spc="0">
-                <a:solidFill>
-                  <a:srgbClr val="323232"/>
-                </a:solidFill>
-                <a:latin typeface="Inter"/>
-              </a:rPr>
-              <a:t>Security &amp; BP config</a:t>
-            </a:r>
-          </a:p>
-        </p:txBody>
-      </p:sp>
-      <p:sp>
-        <p:nvSpPr>
-          <p:cNvPr id="32" name="TextBox 31"/>
-          <p:cNvSpPr txBox="1"/>
-          <p:nvPr/>
-        </p:nvSpPr>
-        <p:spPr>
-          <a:xfrm>
-            <a:off x="8732520" y="4800600"/>
-            <a:ext cx="2286000" cy="347472"/>
-          </a:xfrm>
-          <a:prstGeom prst="rect">
-            <a:avLst/>
-          </a:prstGeom>
-          <a:noFill/>
-        </p:spPr>
-        <p:txBody>
-          <a:bodyPr wrap="square" anchor="t" lIns="0" rIns="0" tIns="0" bIns="0"/>
-          <a:lstStyle/>
-          <a:p>
-            <a:pPr algn="l">
-              <a:lnSpc>
-                <a:spcPct val="112000"/>
-              </a:lnSpc>
-              <a:spcBef>
-                <a:spcPts val="0"/>
-              </a:spcBef>
-              <a:spcAft>
-                <a:spcPts val="0"/>
-              </a:spcAft>
-            </a:pPr>
-            <a:r>
-              <a:rPr sz="1050" b="1" i="0" lang="en-AU" spc="0">
-                <a:solidFill>
-                  <a:srgbClr val="EA493F"/>
-                </a:solidFill>
-                <a:latin typeface="Inter"/>
-              </a:rPr>
-              <a:t>—  </a:t>
-            </a:r>
-            <a:r>
-              <a:rPr sz="1050" b="0" i="0" lang="en-AU" spc="0">
-                <a:solidFill>
-                  <a:srgbClr val="323232"/>
-                </a:solidFill>
-                <a:latin typeface="Inter"/>
-              </a:rPr>
-              <a:t>Integrations (EIB, CC, Studio)</a:t>
-            </a:r>
-          </a:p>
-        </p:txBody>
-      </p:sp>
-      <p:sp>
-        <p:nvSpPr>
-          <p:cNvPr id="33" name="TextBox 32"/>
-          <p:cNvSpPr txBox="1"/>
-          <p:nvPr/>
-        </p:nvSpPr>
-        <p:spPr>
-          <a:xfrm>
-            <a:off x="877824" y="5943600"/>
-            <a:ext cx="10436047" cy="457200"/>
-          </a:xfrm>
-          <a:prstGeom prst="rect">
-            <a:avLst/>
-          </a:prstGeom>
-          <a:noFill/>
-        </p:spPr>
-        <p:txBody>
-          <a:bodyPr wrap="square" anchor="t" lIns="0" rIns="0" tIns="0" bIns="0"/>
-          <a:lstStyle/>
-          <a:p>
-            <a:pPr algn="l">
-              <a:lnSpc>
-                <a:spcPct val="100000"/>
-              </a:lnSpc>
-              <a:spcBef>
-                <a:spcPts val="0"/>
-              </a:spcBef>
-              <a:spcAft>
-                <a:spcPts val="0"/>
-              </a:spcAft>
-            </a:pPr>
-            <a:r>
-              <a:rPr sz="1250" b="1" i="0" lang="en-AU" spc="12">
-                <a:solidFill>
-                  <a:srgbClr val="EA493F"/>
-                </a:solidFill>
-                <a:latin typeface="Inter"/>
-              </a:rPr>
-              <a:t>Adaptive Planning — all modules.   </a:t>
-            </a:r>
-            <a:r>
-              <a:rPr sz="1250" b="0" i="0" lang="en-AU" spc="0">
-                <a:solidFill>
-                  <a:srgbClr val="323232"/>
-                </a:solidFill>
-                <a:latin typeface="Inter"/>
-              </a:rPr>
-              <a:t>Cross-skilled in reporting, security and integrations across both suites — one team, two suites.</a:t>
+              <a:t>Adaptive Planning — all modules.  ·  Cross-skilled across both suites — one team, two suites.</a:t>
             </a:r>
           </a:p>
         </p:txBody>
@@ -5320,7 +5311,7 @@
                 </a:solidFill>
                 <a:latin typeface="Inter"/>
               </a:rPr>
-              <a:t>You direct the work; we provide certified Workday FIN &amp; HCM consultants</a:t>
+              <a:t>You direct the work; certified Workday FIN &amp; HCM consultants</a:t>
             </a:r>
           </a:p>
         </p:txBody>
@@ -8313,28 +8304,6 @@
         </p:nvSpPr>
         <p:spPr>
           <a:xfrm>
-            <a:off x="877824" y="2423160"/>
-            <a:ext cx="1097280" cy="228600"/>
-          </a:xfrm>
-          <a:prstGeom prst="rect">
-            <a:avLst/>
-          </a:prstGeom>
-          <a:noFill/>
-        </p:spPr>
-        <p:txBody>
-          <a:bodyPr wrap="square" anchor="t" lIns="0" rIns="0" tIns="0" bIns="0"/>
-          <a:lstStyle/>
-          <a:p/>
-        </p:txBody>
-      </p:sp>
-      <p:sp>
-        <p:nvSpPr>
-          <p:cNvPr id="7" name="TextBox 6"/>
-          <p:cNvSpPr txBox="1"/>
-          <p:nvPr/>
-        </p:nvSpPr>
-        <p:spPr>
-          <a:xfrm>
             <a:off x="877824" y="2441448"/>
             <a:ext cx="745431" cy="219456"/>
           </a:xfrm>
@@ -8372,7 +8341,7 @@
       </p:sp>
       <p:sp>
         <p:nvSpPr>
-          <p:cNvPr id="8" name="TextBox 7"/>
+          <p:cNvPr id="7" name="TextBox 6"/>
           <p:cNvSpPr txBox="1"/>
           <p:nvPr/>
         </p:nvSpPr>
@@ -8415,7 +8384,7 @@
       </p:sp>
       <p:sp>
         <p:nvSpPr>
-          <p:cNvPr id="9" name="TextBox 8"/>
+          <p:cNvPr id="8" name="TextBox 7"/>
           <p:cNvSpPr txBox="1"/>
           <p:nvPr/>
         </p:nvSpPr>
@@ -8458,7 +8427,7 @@
       </p:sp>
       <p:sp>
         <p:nvSpPr>
-          <p:cNvPr id="10" name="TextBox 9"/>
+          <p:cNvPr id="9" name="TextBox 8"/>
           <p:cNvSpPr txBox="1"/>
           <p:nvPr/>
         </p:nvSpPr>
@@ -8501,7 +8470,7 @@
       </p:sp>
       <p:sp>
         <p:nvSpPr>
-          <p:cNvPr id="11" name="TextBox 10"/>
+          <p:cNvPr id="10" name="TextBox 9"/>
           <p:cNvSpPr txBox="1"/>
           <p:nvPr/>
         </p:nvSpPr>
@@ -8544,7 +8513,7 @@
       </p:sp>
       <p:sp>
         <p:nvSpPr>
-          <p:cNvPr id="12" name="TextBox 11"/>
+          <p:cNvPr id="11" name="TextBox 10"/>
           <p:cNvSpPr txBox="1"/>
           <p:nvPr/>
         </p:nvSpPr>
@@ -8587,7 +8556,7 @@
       </p:sp>
       <p:sp>
         <p:nvSpPr>
-          <p:cNvPr id="13" name="TextBox 12"/>
+          <p:cNvPr id="12" name="TextBox 11"/>
           <p:cNvSpPr txBox="1"/>
           <p:nvPr/>
         </p:nvSpPr>
@@ -8630,7 +8599,7 @@
       </p:sp>
       <p:sp>
         <p:nvSpPr>
-          <p:cNvPr id="14" name="TextBox 13"/>
+          <p:cNvPr id="13" name="TextBox 12"/>
           <p:cNvSpPr txBox="1"/>
           <p:nvPr/>
         </p:nvSpPr>
@@ -8673,7 +8642,7 @@
       </p:sp>
       <p:sp>
         <p:nvSpPr>
-          <p:cNvPr id="15" name="TextBox 14"/>
+          <p:cNvPr id="14" name="TextBox 13"/>
           <p:cNvSpPr txBox="1"/>
           <p:nvPr/>
         </p:nvSpPr>
@@ -8716,7 +8685,7 @@
       </p:sp>
       <p:sp>
         <p:nvSpPr>
-          <p:cNvPr id="16" name="TextBox 15"/>
+          <p:cNvPr id="15" name="TextBox 14"/>
           <p:cNvSpPr txBox="1"/>
           <p:nvPr/>
         </p:nvSpPr>
@@ -8759,7 +8728,7 @@
       </p:sp>
       <p:sp>
         <p:nvSpPr>
-          <p:cNvPr id="17" name="TextBox 16"/>
+          <p:cNvPr id="16" name="TextBox 15"/>
           <p:cNvSpPr txBox="1"/>
           <p:nvPr/>
         </p:nvSpPr>
@@ -8802,7 +8771,7 @@
       </p:sp>
       <p:sp>
         <p:nvSpPr>
-          <p:cNvPr id="18" name="TextBox 17"/>
+          <p:cNvPr id="17" name="TextBox 16"/>
           <p:cNvSpPr txBox="1"/>
           <p:nvPr/>
         </p:nvSpPr>
@@ -8845,7 +8814,7 @@
       </p:sp>
       <p:sp>
         <p:nvSpPr>
-          <p:cNvPr id="19" name="TextBox 18"/>
+          <p:cNvPr id="18" name="TextBox 17"/>
           <p:cNvSpPr txBox="1"/>
           <p:nvPr/>
         </p:nvSpPr>
@@ -8888,7 +8857,7 @@
       </p:sp>
       <p:sp>
         <p:nvSpPr>
-          <p:cNvPr id="20" name="TextBox 19"/>
+          <p:cNvPr id="19" name="TextBox 18"/>
           <p:cNvSpPr txBox="1"/>
           <p:nvPr/>
         </p:nvSpPr>
@@ -8929,6 +8898,42 @@
           </a:p>
         </p:txBody>
       </p:sp>
+      <p:cxnSp>
+        <p:nvCxnSpPr>
+          <p:cNvPr id="20" name="Connector 19"/>
+          <p:cNvCxnSpPr/>
+          <p:nvPr/>
+        </p:nvCxnSpPr>
+        <p:spPr>
+          <a:xfrm>
+            <a:off x="877824" y="2697480"/>
+            <a:ext cx="0" cy="1371600"/>
+          </a:xfrm>
+          <a:prstGeom prst="bentConnector3">
+            <a:avLst/>
+          </a:prstGeom>
+          <a:ln w="9525">
+            <a:solidFill>
+              <a:srgbClr val="E4E4E0"/>
+            </a:solidFill>
+          </a:ln>
+          <a:effectLst/>
+        </p:spPr>
+        <p:style>
+          <a:lnRef idx="2">
+            <a:schemeClr val="accent1"/>
+          </a:lnRef>
+          <a:fillRef idx="0">
+            <a:schemeClr val="accent1"/>
+          </a:fillRef>
+          <a:effectRef idx="1">
+            <a:schemeClr val="accent1"/>
+          </a:effectRef>
+          <a:fontRef idx="minor">
+            <a:schemeClr val="tx1"/>
+          </a:fontRef>
+        </p:style>
+      </p:cxnSp>
       <p:cxnSp>
         <p:nvCxnSpPr>
           <p:cNvPr id="21" name="Connector 20"/>
@@ -8937,7 +8942,7 @@
         </p:nvCxnSpPr>
         <p:spPr>
           <a:xfrm>
-            <a:off x="877824" y="2697480"/>
+            <a:off x="1623255" y="2697480"/>
             <a:ext cx="0" cy="1371600"/>
           </a:xfrm>
           <a:prstGeom prst="bentConnector3">
@@ -8973,7 +8978,7 @@
         </p:nvCxnSpPr>
         <p:spPr>
           <a:xfrm>
-            <a:off x="1623255" y="2697480"/>
+            <a:off x="2368687" y="2697480"/>
             <a:ext cx="0" cy="1371600"/>
           </a:xfrm>
           <a:prstGeom prst="bentConnector3">
@@ -9009,7 +9014,7 @@
         </p:nvCxnSpPr>
         <p:spPr>
           <a:xfrm>
-            <a:off x="2368687" y="2697480"/>
+            <a:off x="3114119" y="2697480"/>
             <a:ext cx="0" cy="1371600"/>
           </a:xfrm>
           <a:prstGeom prst="bentConnector3">
@@ -9045,7 +9050,7 @@
         </p:nvCxnSpPr>
         <p:spPr>
           <a:xfrm>
-            <a:off x="3114119" y="2697480"/>
+            <a:off x="3859551" y="2697480"/>
             <a:ext cx="0" cy="1371600"/>
           </a:xfrm>
           <a:prstGeom prst="bentConnector3">
@@ -9081,7 +9086,7 @@
         </p:nvCxnSpPr>
         <p:spPr>
           <a:xfrm>
-            <a:off x="3859551" y="2697480"/>
+            <a:off x="4604983" y="2697480"/>
             <a:ext cx="0" cy="1371600"/>
           </a:xfrm>
           <a:prstGeom prst="bentConnector3">
@@ -9117,7 +9122,7 @@
         </p:nvCxnSpPr>
         <p:spPr>
           <a:xfrm>
-            <a:off x="4604983" y="2697480"/>
+            <a:off x="5350415" y="2697480"/>
             <a:ext cx="0" cy="1371600"/>
           </a:xfrm>
           <a:prstGeom prst="bentConnector3">
@@ -9153,7 +9158,7 @@
         </p:nvCxnSpPr>
         <p:spPr>
           <a:xfrm>
-            <a:off x="5350415" y="2697480"/>
+            <a:off x="6095847" y="2697480"/>
             <a:ext cx="0" cy="1371600"/>
           </a:xfrm>
           <a:prstGeom prst="bentConnector3">
@@ -9189,7 +9194,7 @@
         </p:nvCxnSpPr>
         <p:spPr>
           <a:xfrm>
-            <a:off x="6095847" y="2697480"/>
+            <a:off x="6841279" y="2697480"/>
             <a:ext cx="0" cy="1371600"/>
           </a:xfrm>
           <a:prstGeom prst="bentConnector3">
@@ -9225,7 +9230,7 @@
         </p:nvCxnSpPr>
         <p:spPr>
           <a:xfrm>
-            <a:off x="6841279" y="2697480"/>
+            <a:off x="7586711" y="2697480"/>
             <a:ext cx="0" cy="1371600"/>
           </a:xfrm>
           <a:prstGeom prst="bentConnector3">
@@ -9261,7 +9266,7 @@
         </p:nvCxnSpPr>
         <p:spPr>
           <a:xfrm>
-            <a:off x="7586711" y="2697480"/>
+            <a:off x="8332143" y="2697480"/>
             <a:ext cx="0" cy="1371600"/>
           </a:xfrm>
           <a:prstGeom prst="bentConnector3">
@@ -9297,7 +9302,7 @@
         </p:nvCxnSpPr>
         <p:spPr>
           <a:xfrm>
-            <a:off x="8332143" y="2697480"/>
+            <a:off x="9077575" y="2697480"/>
             <a:ext cx="0" cy="1371600"/>
           </a:xfrm>
           <a:prstGeom prst="bentConnector3">
@@ -9333,7 +9338,7 @@
         </p:nvCxnSpPr>
         <p:spPr>
           <a:xfrm>
-            <a:off x="9077575" y="2697480"/>
+            <a:off x="9823007" y="2697480"/>
             <a:ext cx="0" cy="1371600"/>
           </a:xfrm>
           <a:prstGeom prst="bentConnector3">
@@ -9369,7 +9374,7 @@
         </p:nvCxnSpPr>
         <p:spPr>
           <a:xfrm>
-            <a:off x="9823007" y="2697480"/>
+            <a:off x="10568439" y="2697480"/>
             <a:ext cx="0" cy="1371600"/>
           </a:xfrm>
           <a:prstGeom prst="bentConnector3">
@@ -9405,7 +9410,7 @@
         </p:nvCxnSpPr>
         <p:spPr>
           <a:xfrm>
-            <a:off x="10568439" y="2697480"/>
+            <a:off x="11313871" y="2697480"/>
             <a:ext cx="0" cy="1371600"/>
           </a:xfrm>
           <a:prstGeom prst="bentConnector3">
@@ -9441,8 +9446,8 @@
         </p:nvCxnSpPr>
         <p:spPr>
           <a:xfrm>
-            <a:off x="11313871" y="2697480"/>
-            <a:ext cx="0" cy="1371600"/>
+            <a:off x="877824" y="2697480"/>
+            <a:ext cx="10436047" cy="0"/>
           </a:xfrm>
           <a:prstGeom prst="bentConnector3">
             <a:avLst/>
@@ -9477,7 +9482,7 @@
         </p:nvCxnSpPr>
         <p:spPr>
           <a:xfrm>
-            <a:off x="877824" y="2697480"/>
+            <a:off x="877824" y="4069080"/>
             <a:ext cx="10436047" cy="0"/>
           </a:xfrm>
           <a:prstGeom prst="bentConnector3">
@@ -9505,45 +9510,9 @@
           </a:fontRef>
         </p:style>
       </p:cxnSp>
-      <p:cxnSp>
-        <p:nvCxnSpPr>
-          <p:cNvPr id="37" name="Connector 36"/>
-          <p:cNvCxnSpPr/>
-          <p:nvPr/>
-        </p:nvCxnSpPr>
-        <p:spPr>
-          <a:xfrm>
-            <a:off x="877824" y="4069080"/>
-            <a:ext cx="10436047" cy="0"/>
-          </a:xfrm>
-          <a:prstGeom prst="bentConnector3">
-            <a:avLst/>
-          </a:prstGeom>
-          <a:ln w="9525">
-            <a:solidFill>
-              <a:srgbClr val="E4E4E0"/>
-            </a:solidFill>
-          </a:ln>
-          <a:effectLst/>
-        </p:spPr>
-        <p:style>
-          <a:lnRef idx="2">
-            <a:schemeClr val="accent1"/>
-          </a:lnRef>
-          <a:fillRef idx="0">
-            <a:schemeClr val="accent1"/>
-          </a:fillRef>
-          <a:effectRef idx="1">
-            <a:schemeClr val="accent1"/>
-          </a:effectRef>
-          <a:fontRef idx="minor">
-            <a:schemeClr val="tx1"/>
-          </a:fontRef>
-        </p:style>
-      </p:cxnSp>
-      <p:sp>
-        <p:nvSpPr>
-          <p:cNvPr id="38" name="Rectangle 37"/>
+      <p:sp>
+        <p:nvSpPr>
+          <p:cNvPr id="37" name="Rectangle 36"/>
           <p:cNvSpPr/>
           <p:nvPr/>
         </p:nvSpPr>
@@ -9587,7 +9556,7 @@
       </p:sp>
       <p:sp>
         <p:nvSpPr>
-          <p:cNvPr id="39" name="Rectangle 38"/>
+          <p:cNvPr id="38" name="Rectangle 37"/>
           <p:cNvSpPr/>
           <p:nvPr/>
         </p:nvSpPr>
@@ -9631,7 +9600,7 @@
       </p:sp>
       <p:sp>
         <p:nvSpPr>
-          <p:cNvPr id="40" name="TextBox 39"/>
+          <p:cNvPr id="39" name="TextBox 38"/>
           <p:cNvSpPr txBox="1"/>
           <p:nvPr/>
         </p:nvSpPr>
@@ -9674,7 +9643,7 @@
       </p:sp>
       <p:sp>
         <p:nvSpPr>
-          <p:cNvPr id="41" name="Rectangle 40"/>
+          <p:cNvPr id="40" name="Rectangle 39"/>
           <p:cNvSpPr/>
           <p:nvPr/>
         </p:nvSpPr>
@@ -9718,7 +9687,7 @@
       </p:sp>
       <p:sp>
         <p:nvSpPr>
-          <p:cNvPr id="42" name="TextBox 41"/>
+          <p:cNvPr id="41" name="TextBox 40"/>
           <p:cNvSpPr txBox="1"/>
           <p:nvPr/>
         </p:nvSpPr>
@@ -9761,7 +9730,7 @@
       </p:sp>
       <p:sp>
         <p:nvSpPr>
-          <p:cNvPr id="43" name="TextBox 42"/>
+          <p:cNvPr id="42" name="TextBox 41"/>
           <p:cNvSpPr txBox="1"/>
           <p:nvPr/>
         </p:nvSpPr>
@@ -9804,7 +9773,7 @@
       </p:sp>
       <p:sp>
         <p:nvSpPr>
-          <p:cNvPr id="44" name="TextBox 43"/>
+          <p:cNvPr id="43" name="TextBox 42"/>
           <p:cNvSpPr txBox="1"/>
           <p:nvPr/>
         </p:nvSpPr>
@@ -9847,7 +9816,7 @@
       </p:sp>
       <p:sp>
         <p:nvSpPr>
-          <p:cNvPr id="45" name="TextBox 44"/>
+          <p:cNvPr id="44" name="TextBox 43"/>
           <p:cNvSpPr txBox="1"/>
           <p:nvPr/>
         </p:nvSpPr>
@@ -9890,7 +9859,7 @@
       </p:sp>
       <p:sp>
         <p:nvSpPr>
-          <p:cNvPr id="46" name="TextBox 45"/>
+          <p:cNvPr id="45" name="TextBox 44"/>
           <p:cNvSpPr txBox="1"/>
           <p:nvPr/>
         </p:nvSpPr>
@@ -9933,7 +9902,7 @@
       </p:sp>
       <p:sp>
         <p:nvSpPr>
-          <p:cNvPr id="47" name="TextBox 46"/>
+          <p:cNvPr id="46" name="TextBox 45"/>
           <p:cNvSpPr txBox="1"/>
           <p:nvPr/>
         </p:nvSpPr>
@@ -9976,7 +9945,7 @@
       </p:sp>
       <p:sp>
         <p:nvSpPr>
-          <p:cNvPr id="48" name="TextBox 47"/>
+          <p:cNvPr id="47" name="TextBox 46"/>
           <p:cNvSpPr txBox="1"/>
           <p:nvPr/>
         </p:nvSpPr>
@@ -10019,7 +9988,7 @@
       </p:sp>
       <p:sp>
         <p:nvSpPr>
-          <p:cNvPr id="49" name="TextBox 48"/>
+          <p:cNvPr id="48" name="TextBox 47"/>
           <p:cNvSpPr txBox="1"/>
           <p:nvPr/>
         </p:nvSpPr>
@@ -10062,7 +10031,7 @@
       </p:sp>
       <p:sp>
         <p:nvSpPr>
-          <p:cNvPr id="50" name="TextBox 49"/>
+          <p:cNvPr id="49" name="TextBox 48"/>
           <p:cNvSpPr txBox="1"/>
           <p:nvPr/>
         </p:nvSpPr>
@@ -10105,7 +10074,7 @@
       </p:sp>
       <p:sp>
         <p:nvSpPr>
-          <p:cNvPr id="51" name="TextBox 50"/>
+          <p:cNvPr id="50" name="TextBox 49"/>
           <p:cNvSpPr txBox="1"/>
           <p:nvPr/>
         </p:nvSpPr>
@@ -10148,7 +10117,7 @@
       </p:sp>
       <p:sp>
         <p:nvSpPr>
-          <p:cNvPr id="52" name="TextBox 51"/>
+          <p:cNvPr id="51" name="TextBox 50"/>
           <p:cNvSpPr txBox="1"/>
           <p:nvPr/>
         </p:nvSpPr>
@@ -10191,7 +10160,7 @@
       </p:sp>
       <p:sp>
         <p:nvSpPr>
-          <p:cNvPr id="53" name="TextBox 52"/>
+          <p:cNvPr id="52" name="TextBox 51"/>
           <p:cNvSpPr txBox="1"/>
           <p:nvPr/>
         </p:nvSpPr>
@@ -10234,7 +10203,7 @@
       </p:sp>
       <p:sp>
         <p:nvSpPr>
-          <p:cNvPr id="54" name="TextBox 53"/>
+          <p:cNvPr id="53" name="TextBox 52"/>
           <p:cNvSpPr txBox="1"/>
           <p:nvPr/>
         </p:nvSpPr>
@@ -10277,7 +10246,7 @@
       </p:sp>
       <p:sp>
         <p:nvSpPr>
-          <p:cNvPr id="55" name="TextBox 54"/>
+          <p:cNvPr id="54" name="TextBox 53"/>
           <p:cNvSpPr txBox="1"/>
           <p:nvPr/>
         </p:nvSpPr>
@@ -10320,7 +10289,7 @@
       </p:sp>
       <p:sp>
         <p:nvSpPr>
-          <p:cNvPr id="56" name="TextBox 55"/>
+          <p:cNvPr id="55" name="TextBox 54"/>
           <p:cNvSpPr txBox="1"/>
           <p:nvPr/>
         </p:nvSpPr>
@@ -10363,50 +10332,50 @@
       </p:sp>
       <p:sp>
         <p:nvSpPr>
+          <p:cNvPr id="56" name="TextBox 55"/>
+          <p:cNvSpPr txBox="1"/>
+          <p:nvPr/>
+        </p:nvSpPr>
+        <p:spPr>
+          <a:xfrm>
+            <a:off x="877824" y="4325112"/>
+            <a:ext cx="3657600" cy="201168"/>
+          </a:xfrm>
+          <a:prstGeom prst="rect">
+            <a:avLst/>
+          </a:prstGeom>
+          <a:noFill/>
+        </p:spPr>
+        <p:txBody>
+          <a:bodyPr wrap="square" anchor="t" lIns="0" rIns="0" tIns="0" bIns="0"/>
+          <a:lstStyle/>
+          <a:p>
+            <a:pPr algn="l">
+              <a:lnSpc>
+                <a:spcPct val="100000"/>
+              </a:lnSpc>
+              <a:spcBef>
+                <a:spcPts val="0"/>
+              </a:spcBef>
+              <a:spcAft>
+                <a:spcPts val="0"/>
+              </a:spcAft>
+            </a:pPr>
+            <a:r>
+              <a:rPr sz="850" b="1" i="0" lang="en-AU" spc="51" cap="all">
+                <a:solidFill>
+                  <a:srgbClr val="EA493F"/>
+                </a:solidFill>
+                <a:latin typeface="Inter"/>
+              </a:rPr>
+              <a:t>← AEST   ·   IST →</a:t>
+            </a:r>
+          </a:p>
+        </p:txBody>
+      </p:sp>
+      <p:sp>
+        <p:nvSpPr>
           <p:cNvPr id="57" name="TextBox 56"/>
-          <p:cNvSpPr txBox="1"/>
-          <p:nvPr/>
-        </p:nvSpPr>
-        <p:spPr>
-          <a:xfrm>
-            <a:off x="877824" y="4325112"/>
-            <a:ext cx="2743200" cy="201168"/>
-          </a:xfrm>
-          <a:prstGeom prst="rect">
-            <a:avLst/>
-          </a:prstGeom>
-          <a:noFill/>
-        </p:spPr>
-        <p:txBody>
-          <a:bodyPr wrap="square" anchor="t" lIns="0" rIns="0" tIns="0" bIns="0"/>
-          <a:lstStyle/>
-          <a:p>
-            <a:pPr algn="l">
-              <a:lnSpc>
-                <a:spcPct val="100000"/>
-              </a:lnSpc>
-              <a:spcBef>
-                <a:spcPts val="0"/>
-              </a:spcBef>
-              <a:spcAft>
-                <a:spcPts val="0"/>
-              </a:spcAft>
-            </a:pPr>
-            <a:r>
-              <a:rPr sz="850" b="1" i="0" lang="en-AU" spc="51" cap="all">
-                <a:solidFill>
-                  <a:srgbClr val="EA493F"/>
-                </a:solidFill>
-                <a:latin typeface="Inter"/>
-              </a:rPr>
-              <a:t>← AEST   ·   IST →</a:t>
-            </a:r>
-          </a:p>
-        </p:txBody>
-      </p:sp>
-      <p:sp>
-        <p:nvSpPr>
-          <p:cNvPr id="58" name="TextBox 57"/>
           <p:cNvSpPr txBox="1"/>
           <p:nvPr/>
         </p:nvSpPr>
@@ -10458,7 +10427,7 @@
       </p:sp>
       <p:sp>
         <p:nvSpPr>
-          <p:cNvPr id="59" name="TextBox 58"/>
+          <p:cNvPr id="58" name="TextBox 57"/>
           <p:cNvSpPr txBox="1"/>
           <p:nvPr/>
         </p:nvSpPr>
@@ -10510,7 +10479,7 @@
       </p:sp>
       <p:sp>
         <p:nvSpPr>
-          <p:cNvPr id="60" name="TextBox 59"/>
+          <p:cNvPr id="59" name="TextBox 58"/>
           <p:cNvSpPr txBox="1"/>
           <p:nvPr/>
         </p:nvSpPr>
@@ -10562,7 +10531,7 @@
       </p:sp>
       <p:sp>
         <p:nvSpPr>
-          <p:cNvPr id="61" name="TextBox 60"/>
+          <p:cNvPr id="60" name="TextBox 59"/>
           <p:cNvSpPr txBox="1"/>
           <p:nvPr/>
         </p:nvSpPr>
@@ -10614,7 +10583,7 @@
       </p:sp>
       <p:sp>
         <p:nvSpPr>
-          <p:cNvPr id="62" name="TextBox 61"/>
+          <p:cNvPr id="61" name="TextBox 60"/>
           <p:cNvSpPr txBox="1"/>
           <p:nvPr/>
         </p:nvSpPr>
@@ -10666,7 +10635,7 @@
       </p:sp>
       <p:sp>
         <p:nvSpPr>
-          <p:cNvPr id="63" name="TextBox 62"/>
+          <p:cNvPr id="62" name="TextBox 61"/>
           <p:cNvSpPr txBox="1"/>
           <p:nvPr/>
         </p:nvSpPr>
@@ -10718,7 +10687,7 @@
       </p:sp>
       <p:sp>
         <p:nvSpPr>
-          <p:cNvPr id="64" name="Rectangle 63"/>
+          <p:cNvPr id="63" name="Rectangle 62"/>
           <p:cNvSpPr/>
           <p:nvPr/>
         </p:nvSpPr>
@@ -10762,7 +10731,7 @@
       </p:sp>
       <p:sp>
         <p:nvSpPr>
-          <p:cNvPr id="65" name="TextBox 64"/>
+          <p:cNvPr id="64" name="TextBox 63"/>
           <p:cNvSpPr txBox="1"/>
           <p:nvPr/>
         </p:nvSpPr>
@@ -10798,7 +10767,7 @@
                 </a:solidFill>
                 <a:latin typeface="Inter"/>
               </a:rPr>
-              <a:t>24×7 P1/P2 ON-CALL   </a:t>
+              <a:t>24×7 P1/P2 on-call   </a:t>
             </a:r>
             <a:r>
               <a:rPr sz="1100" b="0" i="0" lang="en-AU" spc="0">
@@ -10965,49 +10934,6 @@
         </p:nvSpPr>
         <p:spPr>
           <a:xfrm>
-            <a:off x="877824" y="1737360"/>
-            <a:ext cx="10241280" cy="548640"/>
-          </a:xfrm>
-          <a:prstGeom prst="rect">
-            <a:avLst/>
-          </a:prstGeom>
-          <a:noFill/>
-        </p:spPr>
-        <p:txBody>
-          <a:bodyPr wrap="square" anchor="t" lIns="0" rIns="0" tIns="0" bIns="0"/>
-          <a:lstStyle/>
-          <a:p>
-            <a:pPr algn="l">
-              <a:lnSpc>
-                <a:spcPct val="125000"/>
-              </a:lnSpc>
-              <a:spcBef>
-                <a:spcPts val="0"/>
-              </a:spcBef>
-              <a:spcAft>
-                <a:spcPts val="0"/>
-              </a:spcAft>
-            </a:pPr>
-            <a:r>
-              <a:rPr sz="1300" b="0" i="0" lang="en-AU" spc="0">
-                <a:solidFill>
-                  <a:srgbClr val="323232"/>
-                </a:solidFill>
-                <a:latin typeface="Inter"/>
-              </a:rPr>
-              <a:t>Strong governance. Aligned teams. Confident execution.</a:t>
-            </a:r>
-          </a:p>
-        </p:txBody>
-      </p:sp>
-      <p:sp>
-        <p:nvSpPr>
-          <p:cNvPr id="6" name="TextBox 5"/>
-          <p:cNvSpPr txBox="1"/>
-          <p:nvPr/>
-        </p:nvSpPr>
-        <p:spPr>
-          <a:xfrm>
             <a:off x="877824" y="2194560"/>
             <a:ext cx="1828800" cy="274320"/>
           </a:xfrm>
@@ -11045,7 +10971,7 @@
       </p:sp>
       <p:sp>
         <p:nvSpPr>
-          <p:cNvPr id="7" name="TextBox 6"/>
+          <p:cNvPr id="6" name="TextBox 5"/>
           <p:cNvSpPr txBox="1"/>
           <p:nvPr/>
         </p:nvSpPr>
@@ -11088,7 +11014,7 @@
       </p:sp>
       <p:sp>
         <p:nvSpPr>
-          <p:cNvPr id="8" name="TextBox 7"/>
+          <p:cNvPr id="7" name="TextBox 6"/>
           <p:cNvSpPr txBox="1"/>
           <p:nvPr/>
         </p:nvSpPr>
@@ -11131,7 +11057,7 @@
       </p:sp>
       <p:sp>
         <p:nvSpPr>
-          <p:cNvPr id="9" name="TextBox 8"/>
+          <p:cNvPr id="8" name="TextBox 7"/>
           <p:cNvSpPr txBox="1"/>
           <p:nvPr/>
         </p:nvSpPr>
@@ -11174,7 +11100,7 @@
       </p:sp>
       <p:sp>
         <p:nvSpPr>
-          <p:cNvPr id="10" name="Rectangle 9"/>
+          <p:cNvPr id="9" name="Rectangle 8"/>
           <p:cNvSpPr/>
           <p:nvPr/>
         </p:nvSpPr>
@@ -11218,7 +11144,7 @@
       </p:sp>
       <p:sp>
         <p:nvSpPr>
-          <p:cNvPr id="11" name="TextBox 10"/>
+          <p:cNvPr id="10" name="TextBox 9"/>
           <p:cNvSpPr txBox="1"/>
           <p:nvPr/>
         </p:nvSpPr>
@@ -11261,7 +11187,7 @@
       </p:sp>
       <p:sp>
         <p:nvSpPr>
-          <p:cNvPr id="12" name="TextBox 11"/>
+          <p:cNvPr id="11" name="TextBox 10"/>
           <p:cNvSpPr txBox="1"/>
           <p:nvPr/>
         </p:nvSpPr>
@@ -11304,7 +11230,7 @@
       </p:sp>
       <p:sp>
         <p:nvSpPr>
-          <p:cNvPr id="13" name="TextBox 12"/>
+          <p:cNvPr id="12" name="TextBox 11"/>
           <p:cNvSpPr txBox="1"/>
           <p:nvPr/>
         </p:nvSpPr>
@@ -11347,7 +11273,7 @@
       </p:sp>
       <p:sp>
         <p:nvSpPr>
-          <p:cNvPr id="14" name="TextBox 13"/>
+          <p:cNvPr id="13" name="TextBox 12"/>
           <p:cNvSpPr txBox="1"/>
           <p:nvPr/>
         </p:nvSpPr>
@@ -11390,7 +11316,7 @@
       </p:sp>
       <p:sp>
         <p:nvSpPr>
-          <p:cNvPr id="15" name="TextBox 14"/>
+          <p:cNvPr id="14" name="TextBox 13"/>
           <p:cNvSpPr txBox="1"/>
           <p:nvPr/>
         </p:nvSpPr>
@@ -11433,7 +11359,7 @@
       </p:sp>
       <p:cxnSp>
         <p:nvCxnSpPr>
-          <p:cNvPr id="16" name="Connector 15"/>
+          <p:cNvPr id="15" name="Connector 14"/>
           <p:cNvCxnSpPr/>
           <p:nvPr/>
         </p:nvCxnSpPr>
@@ -11469,7 +11395,7 @@
       </p:cxnSp>
       <p:sp>
         <p:nvSpPr>
-          <p:cNvPr id="17" name="Rectangle 16"/>
+          <p:cNvPr id="16" name="Rectangle 15"/>
           <p:cNvSpPr/>
           <p:nvPr/>
         </p:nvSpPr>
@@ -11513,7 +11439,7 @@
       </p:sp>
       <p:sp>
         <p:nvSpPr>
-          <p:cNvPr id="18" name="TextBox 17"/>
+          <p:cNvPr id="17" name="TextBox 16"/>
           <p:cNvSpPr txBox="1"/>
           <p:nvPr/>
         </p:nvSpPr>
@@ -11556,7 +11482,7 @@
       </p:sp>
       <p:sp>
         <p:nvSpPr>
-          <p:cNvPr id="19" name="TextBox 18"/>
+          <p:cNvPr id="18" name="TextBox 17"/>
           <p:cNvSpPr txBox="1"/>
           <p:nvPr/>
         </p:nvSpPr>
@@ -11599,7 +11525,7 @@
       </p:sp>
       <p:sp>
         <p:nvSpPr>
-          <p:cNvPr id="20" name="TextBox 19"/>
+          <p:cNvPr id="19" name="TextBox 18"/>
           <p:cNvSpPr txBox="1"/>
           <p:nvPr/>
         </p:nvSpPr>
@@ -11642,7 +11568,7 @@
       </p:sp>
       <p:sp>
         <p:nvSpPr>
-          <p:cNvPr id="21" name="TextBox 20"/>
+          <p:cNvPr id="20" name="TextBox 19"/>
           <p:cNvSpPr txBox="1"/>
           <p:nvPr/>
         </p:nvSpPr>
@@ -11685,7 +11611,7 @@
       </p:sp>
       <p:sp>
         <p:nvSpPr>
-          <p:cNvPr id="22" name="TextBox 21"/>
+          <p:cNvPr id="21" name="TextBox 20"/>
           <p:cNvSpPr txBox="1"/>
           <p:nvPr/>
         </p:nvSpPr>
@@ -11728,7 +11654,7 @@
       </p:sp>
       <p:cxnSp>
         <p:nvCxnSpPr>
-          <p:cNvPr id="23" name="Connector 22"/>
+          <p:cNvPr id="22" name="Connector 21"/>
           <p:cNvCxnSpPr/>
           <p:nvPr/>
         </p:nvCxnSpPr>
@@ -11764,7 +11690,7 @@
       </p:cxnSp>
       <p:sp>
         <p:nvSpPr>
-          <p:cNvPr id="24" name="Rectangle 23"/>
+          <p:cNvPr id="23" name="Rectangle 22"/>
           <p:cNvSpPr/>
           <p:nvPr/>
         </p:nvSpPr>
@@ -11808,7 +11734,7 @@
       </p:sp>
       <p:sp>
         <p:nvSpPr>
-          <p:cNvPr id="25" name="TextBox 24"/>
+          <p:cNvPr id="24" name="TextBox 23"/>
           <p:cNvSpPr txBox="1"/>
           <p:nvPr/>
         </p:nvSpPr>
@@ -11851,7 +11777,7 @@
       </p:sp>
       <p:sp>
         <p:nvSpPr>
-          <p:cNvPr id="26" name="TextBox 25"/>
+          <p:cNvPr id="25" name="TextBox 24"/>
           <p:cNvSpPr txBox="1"/>
           <p:nvPr/>
         </p:nvSpPr>
@@ -11894,7 +11820,7 @@
       </p:sp>
       <p:sp>
         <p:nvSpPr>
-          <p:cNvPr id="27" name="TextBox 26"/>
+          <p:cNvPr id="26" name="TextBox 25"/>
           <p:cNvSpPr txBox="1"/>
           <p:nvPr/>
         </p:nvSpPr>
@@ -11937,7 +11863,7 @@
       </p:sp>
       <p:sp>
         <p:nvSpPr>
-          <p:cNvPr id="28" name="TextBox 27"/>
+          <p:cNvPr id="27" name="TextBox 26"/>
           <p:cNvSpPr txBox="1"/>
           <p:nvPr/>
         </p:nvSpPr>
@@ -11980,7 +11906,7 @@
       </p:sp>
       <p:sp>
         <p:nvSpPr>
-          <p:cNvPr id="29" name="TextBox 28"/>
+          <p:cNvPr id="28" name="TextBox 27"/>
           <p:cNvSpPr txBox="1"/>
           <p:nvPr/>
         </p:nvSpPr>
@@ -12023,7 +11949,7 @@
       </p:sp>
       <p:cxnSp>
         <p:nvCxnSpPr>
-          <p:cNvPr id="30" name="Connector 29"/>
+          <p:cNvPr id="29" name="Connector 28"/>
           <p:cNvCxnSpPr/>
           <p:nvPr/>
         </p:nvCxnSpPr>
@@ -12059,7 +11985,7 @@
       </p:cxnSp>
       <p:cxnSp>
         <p:nvCxnSpPr>
-          <p:cNvPr id="31" name="Connector 30"/>
+          <p:cNvPr id="30" name="Connector 29"/>
           <p:cNvCxnSpPr/>
           <p:nvPr/>
         </p:nvCxnSpPr>
@@ -12095,7 +12021,7 @@
       </p:cxnSp>
       <p:sp>
         <p:nvSpPr>
-          <p:cNvPr id="32" name="TextBox 31"/>
+          <p:cNvPr id="31" name="TextBox 30"/>
           <p:cNvSpPr txBox="1"/>
           <p:nvPr/>
         </p:nvSpPr>
@@ -12283,50 +12209,7 @@
       </p:sp>
       <p:sp>
         <p:nvSpPr>
-          <p:cNvPr id="5" name="TextBox 4"/>
-          <p:cNvSpPr txBox="1"/>
-          <p:nvPr/>
-        </p:nvSpPr>
-        <p:spPr>
-          <a:xfrm>
-            <a:off x="877824" y="1737360"/>
-            <a:ext cx="10241280" cy="548640"/>
-          </a:xfrm>
-          <a:prstGeom prst="rect">
-            <a:avLst/>
-          </a:prstGeom>
-          <a:noFill/>
-        </p:spPr>
-        <p:txBody>
-          <a:bodyPr wrap="square" anchor="t" lIns="0" rIns="0" tIns="0" bIns="0"/>
-          <a:lstStyle/>
-          <a:p>
-            <a:pPr algn="l">
-              <a:lnSpc>
-                <a:spcPct val="125000"/>
-              </a:lnSpc>
-              <a:spcBef>
-                <a:spcPts val="0"/>
-              </a:spcBef>
-              <a:spcAft>
-                <a:spcPts val="0"/>
-              </a:spcAft>
-            </a:pPr>
-            <a:r>
-              <a:rPr sz="1300" b="0" i="0" lang="en-AU" spc="0">
-                <a:solidFill>
-                  <a:srgbClr val="323232"/>
-                </a:solidFill>
-                <a:latin typeface="Inter"/>
-              </a:rPr>
-              <a:t>Integrated onshore–offshore teams delivering as one.</a:t>
-            </a:r>
-          </a:p>
-        </p:txBody>
-      </p:sp>
-      <p:sp>
-        <p:nvSpPr>
-          <p:cNvPr id="6" name="Rectangle 5"/>
+          <p:cNvPr id="5" name="Rectangle 4"/>
           <p:cNvSpPr/>
           <p:nvPr/>
         </p:nvSpPr>
@@ -12372,7 +12255,7 @@
       </p:sp>
       <p:sp>
         <p:nvSpPr>
-          <p:cNvPr id="7" name="TextBox 6"/>
+          <p:cNvPr id="6" name="TextBox 5"/>
           <p:cNvSpPr txBox="1"/>
           <p:nvPr/>
         </p:nvSpPr>
@@ -12415,7 +12298,7 @@
       </p:sp>
       <p:sp>
         <p:nvSpPr>
-          <p:cNvPr id="8" name="TextBox 7"/>
+          <p:cNvPr id="7" name="TextBox 6"/>
           <p:cNvSpPr txBox="1"/>
           <p:nvPr/>
         </p:nvSpPr>
@@ -12458,7 +12341,7 @@
       </p:sp>
       <p:sp>
         <p:nvSpPr>
-          <p:cNvPr id="9" name="Rectangle 8"/>
+          <p:cNvPr id="8" name="Rectangle 7"/>
           <p:cNvSpPr/>
           <p:nvPr/>
         </p:nvSpPr>
@@ -12504,7 +12387,7 @@
       </p:sp>
       <p:sp>
         <p:nvSpPr>
-          <p:cNvPr id="10" name="TextBox 9"/>
+          <p:cNvPr id="9" name="TextBox 8"/>
           <p:cNvSpPr txBox="1"/>
           <p:nvPr/>
         </p:nvSpPr>
@@ -12547,7 +12430,7 @@
       </p:sp>
       <p:sp>
         <p:nvSpPr>
-          <p:cNvPr id="11" name="TextBox 10"/>
+          <p:cNvPr id="10" name="TextBox 9"/>
           <p:cNvSpPr txBox="1"/>
           <p:nvPr/>
         </p:nvSpPr>
@@ -12588,6 +12471,42 @@
           </a:p>
         </p:txBody>
       </p:sp>
+      <p:cxnSp>
+        <p:nvCxnSpPr>
+          <p:cNvPr id="11" name="Connector 10"/>
+          <p:cNvCxnSpPr/>
+          <p:nvPr/>
+        </p:nvCxnSpPr>
+        <p:spPr>
+          <a:xfrm>
+            <a:off x="3372535" y="3246120"/>
+            <a:ext cx="0" cy="320040"/>
+          </a:xfrm>
+          <a:prstGeom prst="bentConnector3">
+            <a:avLst/>
+          </a:prstGeom>
+          <a:ln w="12700">
+            <a:solidFill>
+              <a:srgbClr val="AEAEAE"/>
+            </a:solidFill>
+          </a:ln>
+          <a:effectLst/>
+        </p:spPr>
+        <p:style>
+          <a:lnRef idx="2">
+            <a:schemeClr val="accent1"/>
+          </a:lnRef>
+          <a:fillRef idx="0">
+            <a:schemeClr val="accent1"/>
+          </a:fillRef>
+          <a:effectRef idx="1">
+            <a:schemeClr val="accent1"/>
+          </a:effectRef>
+          <a:fontRef idx="minor">
+            <a:schemeClr val="tx1"/>
+          </a:fontRef>
+        </p:style>
+      </p:cxnSp>
       <p:cxnSp>
         <p:nvCxnSpPr>
           <p:cNvPr id="12" name="Connector 11"/>
@@ -12596,7 +12515,7 @@
         </p:nvCxnSpPr>
         <p:spPr>
           <a:xfrm>
-            <a:off x="3372535" y="3246120"/>
+            <a:off x="8819159" y="3246120"/>
             <a:ext cx="0" cy="320040"/>
           </a:xfrm>
           <a:prstGeom prst="bentConnector3">
@@ -12632,8 +12551,8 @@
         </p:nvCxnSpPr>
         <p:spPr>
           <a:xfrm>
-            <a:off x="8819159" y="3246120"/>
-            <a:ext cx="0" cy="320040"/>
+            <a:off x="3372535" y="3566160"/>
+            <a:ext cx="5446624" cy="0"/>
           </a:xfrm>
           <a:prstGeom prst="bentConnector3">
             <a:avLst/>
@@ -12668,8 +12587,8 @@
         </p:nvCxnSpPr>
         <p:spPr>
           <a:xfrm>
-            <a:off x="3372535" y="3566160"/>
-            <a:ext cx="5446624" cy="0"/>
+            <a:off x="6095847" y="3566160"/>
+            <a:ext cx="0" cy="274320"/>
           </a:xfrm>
           <a:prstGeom prst="bentConnector3">
             <a:avLst/>
@@ -12696,45 +12615,9 @@
           </a:fontRef>
         </p:style>
       </p:cxnSp>
-      <p:cxnSp>
-        <p:nvCxnSpPr>
-          <p:cNvPr id="15" name="Connector 14"/>
-          <p:cNvCxnSpPr/>
-          <p:nvPr/>
-        </p:nvCxnSpPr>
-        <p:spPr>
-          <a:xfrm>
-            <a:off x="6095847" y="3566160"/>
-            <a:ext cx="0" cy="274320"/>
-          </a:xfrm>
-          <a:prstGeom prst="bentConnector3">
-            <a:avLst/>
-          </a:prstGeom>
-          <a:ln w="12700">
-            <a:solidFill>
-              <a:srgbClr val="AEAEAE"/>
-            </a:solidFill>
-          </a:ln>
-          <a:effectLst/>
-        </p:spPr>
-        <p:style>
-          <a:lnRef idx="2">
-            <a:schemeClr val="accent1"/>
-          </a:lnRef>
-          <a:fillRef idx="0">
-            <a:schemeClr val="accent1"/>
-          </a:fillRef>
-          <a:effectRef idx="1">
-            <a:schemeClr val="accent1"/>
-          </a:effectRef>
-          <a:fontRef idx="minor">
-            <a:schemeClr val="tx1"/>
-          </a:fontRef>
-        </p:style>
-      </p:cxnSp>
-      <p:sp>
-        <p:nvSpPr>
-          <p:cNvPr id="16" name="Rectangle 15"/>
+      <p:sp>
+        <p:nvSpPr>
+          <p:cNvPr id="15" name="Rectangle 14"/>
           <p:cNvSpPr/>
           <p:nvPr/>
         </p:nvSpPr>
@@ -12780,7 +12663,7 @@
       </p:sp>
       <p:sp>
         <p:nvSpPr>
-          <p:cNvPr id="17" name="TextBox 16"/>
+          <p:cNvPr id="16" name="TextBox 15"/>
           <p:cNvSpPr txBox="1"/>
           <p:nvPr/>
         </p:nvSpPr>
@@ -12823,7 +12706,7 @@
       </p:sp>
       <p:sp>
         <p:nvSpPr>
-          <p:cNvPr id="18" name="TextBox 17"/>
+          <p:cNvPr id="17" name="TextBox 16"/>
           <p:cNvSpPr txBox="1"/>
           <p:nvPr/>
         </p:nvSpPr>
@@ -12866,7 +12749,7 @@
       </p:sp>
       <p:sp>
         <p:nvSpPr>
-          <p:cNvPr id="19" name="Rectangle 18"/>
+          <p:cNvPr id="18" name="Rectangle 17"/>
           <p:cNvSpPr/>
           <p:nvPr/>
         </p:nvSpPr>
@@ -12912,7 +12795,7 @@
       </p:sp>
       <p:sp>
         <p:nvSpPr>
-          <p:cNvPr id="20" name="TextBox 19"/>
+          <p:cNvPr id="19" name="TextBox 18"/>
           <p:cNvSpPr txBox="1"/>
           <p:nvPr/>
         </p:nvSpPr>
@@ -12955,7 +12838,7 @@
       </p:sp>
       <p:sp>
         <p:nvSpPr>
-          <p:cNvPr id="21" name="TextBox 20"/>
+          <p:cNvPr id="20" name="TextBox 19"/>
           <p:cNvSpPr txBox="1"/>
           <p:nvPr/>
         </p:nvSpPr>
@@ -12998,7 +12881,7 @@
       </p:sp>
       <p:sp>
         <p:nvSpPr>
-          <p:cNvPr id="22" name="Rectangle 21"/>
+          <p:cNvPr id="21" name="Rectangle 20"/>
           <p:cNvSpPr/>
           <p:nvPr/>
         </p:nvSpPr>
@@ -13042,7 +12925,7 @@
       </p:sp>
       <p:sp>
         <p:nvSpPr>
-          <p:cNvPr id="23" name="TextBox 22"/>
+          <p:cNvPr id="22" name="TextBox 21"/>
           <p:cNvSpPr txBox="1"/>
           <p:nvPr/>
         </p:nvSpPr>
@@ -13085,7 +12968,7 @@
       </p:sp>
       <p:sp>
         <p:nvSpPr>
-          <p:cNvPr id="24" name="TextBox 23"/>
+          <p:cNvPr id="23" name="TextBox 22"/>
           <p:cNvSpPr txBox="1"/>
           <p:nvPr/>
         </p:nvSpPr>
@@ -13128,7 +13011,7 @@
       </p:sp>
       <p:sp>
         <p:nvSpPr>
-          <p:cNvPr id="25" name="Rectangle 24"/>
+          <p:cNvPr id="24" name="Rectangle 23"/>
           <p:cNvSpPr/>
           <p:nvPr/>
         </p:nvSpPr>
@@ -13172,7 +13055,7 @@
       </p:sp>
       <p:sp>
         <p:nvSpPr>
-          <p:cNvPr id="26" name="TextBox 25"/>
+          <p:cNvPr id="25" name="TextBox 24"/>
           <p:cNvSpPr txBox="1"/>
           <p:nvPr/>
         </p:nvSpPr>
@@ -13215,7 +13098,7 @@
       </p:sp>
       <p:sp>
         <p:nvSpPr>
-          <p:cNvPr id="27" name="TextBox 26"/>
+          <p:cNvPr id="26" name="TextBox 25"/>
           <p:cNvSpPr txBox="1"/>
           <p:nvPr/>
         </p:nvSpPr>

</xml_diff>

<commit_message>
Redesign two standard slides: Workday lifecycle (3 boxes) + AMS on ITIL
- New library builders: lifecycle() (3 stage boxes + engagement "wrap" band) and
  cards3() (three what/why/how boxes).
- Workday services slide → "Across the whole Workday lifecycle": Implement › Optimise
  › Manage, with Staff Augmentation wrapping Implement→Optimise and Managed Services
  + Managed Payroll at Manage. Less text, three boxes.
- AMS framework slide → "AMS, built on ITIL": what it is / why it matters / how we
  apply it (benefit-level; dropped the 23-item detail).
- Rebuilt standard, AMS-pack and merged decks.

https://claude.ai/code/session_018CuPeTbPKyC5roqRrfQGYh
</commit_message>
<xml_diff>
--- a/design-system/samples/Mivada_AMS_Services_editorial.pptx
+++ b/design-system/samples/Mivada_AMS_Services_editorial.pptx
@@ -5032,7 +5032,7 @@
                 </a:solidFill>
                 <a:latin typeface="Inter"/>
               </a:rPr>
-              <a:t>ENGAGEMENT MODELS</a:t>
+              <a:t>WORKDAY SERVICES</a:t>
             </a:r>
           </a:p>
         </p:txBody>
@@ -5075,7 +5075,7 @@
                 </a:solidFill>
                 <a:latin typeface="Inter"/>
               </a:rPr>
-              <a:t>Two ways we </a:t>
+              <a:t>Across the whole </a:t>
             </a:r>
             <a:r>
               <a:rPr sz="3300" b="1" i="0" lang="en-AU" spc="-72">
@@ -5084,64 +5084,21 @@
                 </a:solidFill>
                 <a:latin typeface="Inter"/>
               </a:rPr>
-              <a:t>support you.</a:t>
-            </a:r>
-          </a:p>
-        </p:txBody>
-      </p:sp>
-      <p:sp>
-        <p:nvSpPr>
-          <p:cNvPr id="5" name="TextBox 4"/>
-          <p:cNvSpPr txBox="1"/>
-          <p:nvPr/>
-        </p:nvSpPr>
-        <p:spPr>
-          <a:xfrm>
-            <a:off x="877824" y="1737360"/>
-            <a:ext cx="10241280" cy="548640"/>
-          </a:xfrm>
-          <a:prstGeom prst="rect">
-            <a:avLst/>
-          </a:prstGeom>
-          <a:noFill/>
-        </p:spPr>
-        <p:txBody>
-          <a:bodyPr wrap="square" anchor="t" lIns="0" rIns="0" tIns="0" bIns="0"/>
-          <a:lstStyle/>
-          <a:p>
-            <a:pPr algn="l">
-              <a:lnSpc>
-                <a:spcPct val="125000"/>
-              </a:lnSpc>
-              <a:spcBef>
-                <a:spcPts val="0"/>
-              </a:spcBef>
-              <a:spcAft>
-                <a:spcPts val="0"/>
-              </a:spcAft>
-            </a:pPr>
-            <a:r>
-              <a:rPr sz="1300" b="0" i="0" lang="en-AU" spc="0">
-                <a:solidFill>
-                  <a:srgbClr val="CFCFCF"/>
-                </a:solidFill>
-                <a:latin typeface="Inter"/>
-              </a:rPr>
-              <a:t>Augmentation and Application Management Services — flex between them as your needs change.</a:t>
-            </a:r>
-          </a:p>
-        </p:txBody>
-      </p:sp>
-      <p:sp>
-        <p:nvSpPr>
-          <p:cNvPr id="6" name="Rectangle 5"/>
+              <a:t>Workday lifecycle.</a:t>
+            </a:r>
+          </a:p>
+        </p:txBody>
+      </p:sp>
+      <p:sp>
+        <p:nvSpPr>
+          <p:cNvPr id="5" name="Rectangle 4"/>
           <p:cNvSpPr/>
           <p:nvPr/>
         </p:nvSpPr>
         <p:spPr>
           <a:xfrm>
-            <a:off x="877824" y="2331720"/>
-            <a:ext cx="5035143" cy="3291840"/>
+            <a:off x="877824" y="2194560"/>
+            <a:ext cx="3234842" cy="1783080"/>
           </a:xfrm>
           <a:prstGeom prst="rect">
             <a:avLst/>
@@ -5180,14 +5137,57 @@
       </p:sp>
       <p:sp>
         <p:nvSpPr>
+          <p:cNvPr id="6" name="TextBox 5"/>
+          <p:cNvSpPr txBox="1"/>
+          <p:nvPr/>
+        </p:nvSpPr>
+        <p:spPr>
+          <a:xfrm>
+            <a:off x="1152144" y="2468879"/>
+            <a:ext cx="2731922" cy="365760"/>
+          </a:xfrm>
+          <a:prstGeom prst="rect">
+            <a:avLst/>
+          </a:prstGeom>
+          <a:noFill/>
+        </p:spPr>
+        <p:txBody>
+          <a:bodyPr wrap="square" anchor="t" lIns="0" rIns="0" tIns="0" bIns="0"/>
+          <a:lstStyle/>
+          <a:p>
+            <a:pPr algn="l">
+              <a:lnSpc>
+                <a:spcPct val="100000"/>
+              </a:lnSpc>
+              <a:spcBef>
+                <a:spcPts val="0"/>
+              </a:spcBef>
+              <a:spcAft>
+                <a:spcPts val="0"/>
+              </a:spcAft>
+            </a:pPr>
+            <a:r>
+              <a:rPr sz="1400" b="1" i="0" lang="en-AU" spc="112" cap="all">
+                <a:solidFill>
+                  <a:srgbClr val="EA493F"/>
+                </a:solidFill>
+                <a:latin typeface="Inter"/>
+              </a:rPr>
+              <a:t>IMPLEMENT</a:t>
+            </a:r>
+          </a:p>
+        </p:txBody>
+      </p:sp>
+      <p:sp>
+        <p:nvSpPr>
           <p:cNvPr id="7" name="TextBox 6"/>
           <p:cNvSpPr txBox="1"/>
           <p:nvPr/>
         </p:nvSpPr>
         <p:spPr>
           <a:xfrm>
-            <a:off x="1152144" y="2569463"/>
-            <a:ext cx="4532223" cy="365760"/>
+            <a:off x="1152144" y="2962656"/>
+            <a:ext cx="2686202" cy="822959"/>
           </a:xfrm>
           <a:prstGeom prst="rect">
             <a:avLst/>
@@ -5200,340 +5200,37 @@
           <a:p>
             <a:pPr algn="l">
               <a:lnSpc>
-                <a:spcPct val="100000"/>
-              </a:lnSpc>
-              <a:spcBef>
-                <a:spcPts val="0"/>
-              </a:spcBef>
-              <a:spcAft>
-                <a:spcPts val="0"/>
-              </a:spcAft>
-            </a:pPr>
-            <a:r>
-              <a:rPr sz="1250" b="1" i="0" lang="en-AU" spc="150" cap="all">
-                <a:solidFill>
-                  <a:srgbClr val="EA493F"/>
-                </a:solidFill>
-                <a:latin typeface="Inter"/>
-              </a:rPr>
-              <a:t>STAFF AUGMENTATION</a:t>
-            </a:r>
-          </a:p>
-        </p:txBody>
-      </p:sp>
-      <p:sp>
-        <p:nvSpPr>
-          <p:cNvPr id="8" name="TextBox 7"/>
-          <p:cNvSpPr txBox="1"/>
-          <p:nvPr/>
-        </p:nvSpPr>
-        <p:spPr>
-          <a:xfrm>
-            <a:off x="1152144" y="2935224"/>
-            <a:ext cx="4532223" cy="457200"/>
-          </a:xfrm>
-          <a:prstGeom prst="rect">
-            <a:avLst/>
-          </a:prstGeom>
-          <a:noFill/>
-        </p:spPr>
-        <p:txBody>
-          <a:bodyPr wrap="square" anchor="t" lIns="0" rIns="0" tIns="0" bIns="0"/>
-          <a:lstStyle/>
-          <a:p>
-            <a:pPr algn="l">
-              <a:lnSpc>
-                <a:spcPct val="105000"/>
-              </a:lnSpc>
-              <a:spcBef>
-                <a:spcPts val="0"/>
-              </a:spcBef>
-              <a:spcAft>
-                <a:spcPts val="0"/>
-              </a:spcAft>
-            </a:pPr>
-            <a:r>
-              <a:rPr sz="1450" b="1" i="0" lang="en-AU" spc="-14">
+                <a:spcPct val="132000"/>
+              </a:lnSpc>
+              <a:spcBef>
+                <a:spcPts val="0"/>
+              </a:spcBef>
+              <a:spcAft>
+                <a:spcPts val="0"/>
+              </a:spcAft>
+            </a:pPr>
+            <a:r>
+              <a:rPr sz="1350" b="1" i="0" lang="en-AU" spc="-13">
                 <a:solidFill>
                   <a:srgbClr val="FFFFFF"/>
                 </a:solidFill>
                 <a:latin typeface="Inter"/>
               </a:rPr>
-              <a:t>Our certified consultants, embedded in your team</a:t>
-            </a:r>
-          </a:p>
-        </p:txBody>
-      </p:sp>
-      <p:sp>
-        <p:nvSpPr>
-          <p:cNvPr id="9" name="TextBox 8"/>
-          <p:cNvSpPr txBox="1"/>
-          <p:nvPr/>
-        </p:nvSpPr>
-        <p:spPr>
-          <a:xfrm>
-            <a:off x="1152144" y="3538728"/>
-            <a:ext cx="4486503" cy="420624"/>
-          </a:xfrm>
-          <a:prstGeom prst="rect">
-            <a:avLst/>
-          </a:prstGeom>
-          <a:noFill/>
-        </p:spPr>
-        <p:txBody>
-          <a:bodyPr wrap="square" anchor="t" lIns="0" rIns="0" tIns="0" bIns="0"/>
-          <a:lstStyle/>
-          <a:p>
-            <a:pPr algn="l">
-              <a:lnSpc>
-                <a:spcPct val="112000"/>
-              </a:lnSpc>
-              <a:spcBef>
-                <a:spcPts val="0"/>
-              </a:spcBef>
-              <a:spcAft>
-                <a:spcPts val="0"/>
-              </a:spcAft>
-            </a:pPr>
-            <a:r>
-              <a:rPr sz="1050" b="1" i="0" lang="en-AU" spc="0">
-                <a:solidFill>
-                  <a:srgbClr val="EA493F"/>
-                </a:solidFill>
-                <a:latin typeface="Inter"/>
-              </a:rPr>
-              <a:t>—  </a:t>
-            </a:r>
-            <a:r>
-              <a:rPr sz="1050" b="0" i="0" lang="en-AU" spc="0">
-                <a:solidFill>
-                  <a:srgbClr val="D6D6D6"/>
-                </a:solidFill>
-                <a:latin typeface="Inter"/>
-              </a:rPr>
-              <a:t>You direct the work; certified Workday FIN &amp; HCM consultants</a:t>
-            </a:r>
-          </a:p>
-        </p:txBody>
-      </p:sp>
-      <p:sp>
-        <p:nvSpPr>
-          <p:cNvPr id="10" name="TextBox 9"/>
-          <p:cNvSpPr txBox="1"/>
-          <p:nvPr/>
-        </p:nvSpPr>
-        <p:spPr>
-          <a:xfrm>
-            <a:off x="1152144" y="3959352"/>
-            <a:ext cx="4486503" cy="420624"/>
-          </a:xfrm>
-          <a:prstGeom prst="rect">
-            <a:avLst/>
-          </a:prstGeom>
-          <a:noFill/>
-        </p:spPr>
-        <p:txBody>
-          <a:bodyPr wrap="square" anchor="t" lIns="0" rIns="0" tIns="0" bIns="0"/>
-          <a:lstStyle/>
-          <a:p>
-            <a:pPr algn="l">
-              <a:lnSpc>
-                <a:spcPct val="112000"/>
-              </a:lnSpc>
-              <a:spcBef>
-                <a:spcPts val="0"/>
-              </a:spcBef>
-              <a:spcAft>
-                <a:spcPts val="0"/>
-              </a:spcAft>
-            </a:pPr>
-            <a:r>
-              <a:rPr sz="1050" b="1" i="0" lang="en-AU" spc="0">
-                <a:solidFill>
-                  <a:srgbClr val="EA493F"/>
-                </a:solidFill>
-                <a:latin typeface="Inter"/>
-              </a:rPr>
-              <a:t>—  </a:t>
-            </a:r>
-            <a:r>
-              <a:rPr sz="1050" b="0" i="0" lang="en-AU" spc="0">
-                <a:solidFill>
-                  <a:srgbClr val="D6D6D6"/>
-                </a:solidFill>
-                <a:latin typeface="Inter"/>
-              </a:rPr>
-              <a:t>Scale capacity up or down by the day, week or sprint</a:t>
-            </a:r>
-          </a:p>
-        </p:txBody>
-      </p:sp>
-      <p:sp>
-        <p:nvSpPr>
-          <p:cNvPr id="11" name="TextBox 10"/>
-          <p:cNvSpPr txBox="1"/>
-          <p:nvPr/>
-        </p:nvSpPr>
-        <p:spPr>
-          <a:xfrm>
-            <a:off x="1152144" y="4379976"/>
-            <a:ext cx="4486503" cy="420624"/>
-          </a:xfrm>
-          <a:prstGeom prst="rect">
-            <a:avLst/>
-          </a:prstGeom>
-          <a:noFill/>
-        </p:spPr>
-        <p:txBody>
-          <a:bodyPr wrap="square" anchor="t" lIns="0" rIns="0" tIns="0" bIns="0"/>
-          <a:lstStyle/>
-          <a:p>
-            <a:pPr algn="l">
-              <a:lnSpc>
-                <a:spcPct val="112000"/>
-              </a:lnSpc>
-              <a:spcBef>
-                <a:spcPts val="0"/>
-              </a:spcBef>
-              <a:spcAft>
-                <a:spcPts val="0"/>
-              </a:spcAft>
-            </a:pPr>
-            <a:r>
-              <a:rPr sz="1050" b="1" i="0" lang="en-AU" spc="0">
-                <a:solidFill>
-                  <a:srgbClr val="EA493F"/>
-                </a:solidFill>
-                <a:latin typeface="Inter"/>
-              </a:rPr>
-              <a:t>—  </a:t>
-            </a:r>
-            <a:r>
-              <a:rPr sz="1050" b="0" i="0" lang="en-AU" spc="0">
-                <a:solidFill>
-                  <a:srgbClr val="D6D6D6"/>
-                </a:solidFill>
-                <a:latin typeface="Inter"/>
-              </a:rPr>
-              <a:t>Ideal for project surge, BAU backlog, leave cover or niche skills</a:t>
-            </a:r>
-          </a:p>
-        </p:txBody>
-      </p:sp>
-      <p:sp>
-        <p:nvSpPr>
-          <p:cNvPr id="12" name="TextBox 11"/>
-          <p:cNvSpPr txBox="1"/>
-          <p:nvPr/>
-        </p:nvSpPr>
-        <p:spPr>
-          <a:xfrm>
-            <a:off x="1152144" y="4800600"/>
-            <a:ext cx="4486503" cy="420624"/>
-          </a:xfrm>
-          <a:prstGeom prst="rect">
-            <a:avLst/>
-          </a:prstGeom>
-          <a:noFill/>
-        </p:spPr>
-        <p:txBody>
-          <a:bodyPr wrap="square" anchor="t" lIns="0" rIns="0" tIns="0" bIns="0"/>
-          <a:lstStyle/>
-          <a:p>
-            <a:pPr algn="l">
-              <a:lnSpc>
-                <a:spcPct val="112000"/>
-              </a:lnSpc>
-              <a:spcBef>
-                <a:spcPts val="0"/>
-              </a:spcBef>
-              <a:spcAft>
-                <a:spcPts val="0"/>
-              </a:spcAft>
-            </a:pPr>
-            <a:r>
-              <a:rPr sz="1050" b="1" i="0" lang="en-AU" spc="0">
-                <a:solidFill>
-                  <a:srgbClr val="EA493F"/>
-                </a:solidFill>
-                <a:latin typeface="Inter"/>
-              </a:rPr>
-              <a:t>—  </a:t>
-            </a:r>
-            <a:r>
-              <a:rPr sz="1050" b="0" i="0" lang="en-AU" spc="0">
-                <a:solidFill>
-                  <a:srgbClr val="D6D6D6"/>
-                </a:solidFill>
-                <a:latin typeface="Inter"/>
-              </a:rPr>
-              <a:t>Onshore (AU), offshore (India) or a blended model</a:t>
-            </a:r>
-          </a:p>
-        </p:txBody>
-      </p:sp>
-      <p:sp>
-        <p:nvSpPr>
-          <p:cNvPr id="13" name="TextBox 12"/>
-          <p:cNvSpPr txBox="1"/>
-          <p:nvPr/>
-        </p:nvSpPr>
-        <p:spPr>
-          <a:xfrm>
-            <a:off x="1152144" y="5221224"/>
-            <a:ext cx="4486503" cy="420624"/>
-          </a:xfrm>
-          <a:prstGeom prst="rect">
-            <a:avLst/>
-          </a:prstGeom>
-          <a:noFill/>
-        </p:spPr>
-        <p:txBody>
-          <a:bodyPr wrap="square" anchor="t" lIns="0" rIns="0" tIns="0" bIns="0"/>
-          <a:lstStyle/>
-          <a:p>
-            <a:pPr algn="l">
-              <a:lnSpc>
-                <a:spcPct val="112000"/>
-              </a:lnSpc>
-              <a:spcBef>
-                <a:spcPts val="0"/>
-              </a:spcBef>
-              <a:spcAft>
-                <a:spcPts val="0"/>
-              </a:spcAft>
-            </a:pPr>
-            <a:r>
-              <a:rPr sz="1050" b="1" i="0" lang="en-AU" spc="0">
-                <a:solidFill>
-                  <a:srgbClr val="EA493F"/>
-                </a:solidFill>
-                <a:latin typeface="Inter"/>
-              </a:rPr>
-              <a:t>—  </a:t>
-            </a:r>
-            <a:r>
-              <a:rPr sz="1050" b="0" i="0" lang="en-AU" spc="0">
-                <a:solidFill>
-                  <a:srgbClr val="D6D6D6"/>
-                </a:solidFill>
-                <a:latin typeface="Inter"/>
-              </a:rPr>
-              <a:t>Time-and-materials or a pre-agreed block of hours</a:t>
-            </a:r>
-          </a:p>
-        </p:txBody>
-      </p:sp>
-      <p:sp>
-        <p:nvSpPr>
-          <p:cNvPr id="14" name="Rectangle 13"/>
+              <a:t>Deploy Workday HCM, Payroll &amp; Finance.</a:t>
+            </a:r>
+          </a:p>
+        </p:txBody>
+      </p:sp>
+      <p:sp>
+        <p:nvSpPr>
+          <p:cNvPr id="8" name="Rectangle 7"/>
           <p:cNvSpPr/>
           <p:nvPr/>
         </p:nvSpPr>
         <p:spPr>
           <a:xfrm>
-            <a:off x="6278727" y="2331720"/>
-            <a:ext cx="5035143" cy="3291840"/>
+            <a:off x="4478426" y="2194560"/>
+            <a:ext cx="3234842" cy="1783080"/>
           </a:xfrm>
           <a:prstGeom prst="rect">
             <a:avLst/>
@@ -5572,14 +5269,362 @@
       </p:sp>
       <p:sp>
         <p:nvSpPr>
+          <p:cNvPr id="9" name="TextBox 8"/>
+          <p:cNvSpPr txBox="1"/>
+          <p:nvPr/>
+        </p:nvSpPr>
+        <p:spPr>
+          <a:xfrm>
+            <a:off x="4752746" y="2468879"/>
+            <a:ext cx="2731922" cy="365760"/>
+          </a:xfrm>
+          <a:prstGeom prst="rect">
+            <a:avLst/>
+          </a:prstGeom>
+          <a:noFill/>
+        </p:spPr>
+        <p:txBody>
+          <a:bodyPr wrap="square" anchor="t" lIns="0" rIns="0" tIns="0" bIns="0"/>
+          <a:lstStyle/>
+          <a:p>
+            <a:pPr algn="l">
+              <a:lnSpc>
+                <a:spcPct val="100000"/>
+              </a:lnSpc>
+              <a:spcBef>
+                <a:spcPts val="0"/>
+              </a:spcBef>
+              <a:spcAft>
+                <a:spcPts val="0"/>
+              </a:spcAft>
+            </a:pPr>
+            <a:r>
+              <a:rPr sz="1400" b="1" i="0" lang="en-AU" spc="112" cap="all">
+                <a:solidFill>
+                  <a:srgbClr val="EA493F"/>
+                </a:solidFill>
+                <a:latin typeface="Inter"/>
+              </a:rPr>
+              <a:t>OPTIMISE</a:t>
+            </a:r>
+          </a:p>
+        </p:txBody>
+      </p:sp>
+      <p:sp>
+        <p:nvSpPr>
+          <p:cNvPr id="10" name="TextBox 9"/>
+          <p:cNvSpPr txBox="1"/>
+          <p:nvPr/>
+        </p:nvSpPr>
+        <p:spPr>
+          <a:xfrm>
+            <a:off x="4752746" y="2962656"/>
+            <a:ext cx="2686202" cy="822959"/>
+          </a:xfrm>
+          <a:prstGeom prst="rect">
+            <a:avLst/>
+          </a:prstGeom>
+          <a:noFill/>
+        </p:spPr>
+        <p:txBody>
+          <a:bodyPr wrap="square" anchor="t" lIns="0" rIns="0" tIns="0" bIns="0"/>
+          <a:lstStyle/>
+          <a:p>
+            <a:pPr algn="l">
+              <a:lnSpc>
+                <a:spcPct val="132000"/>
+              </a:lnSpc>
+              <a:spcBef>
+                <a:spcPts val="0"/>
+              </a:spcBef>
+              <a:spcAft>
+                <a:spcPts val="0"/>
+              </a:spcAft>
+            </a:pPr>
+            <a:r>
+              <a:rPr sz="1350" b="1" i="0" lang="en-AU" spc="-13">
+                <a:solidFill>
+                  <a:srgbClr val="FFFFFF"/>
+                </a:solidFill>
+                <a:latin typeface="Inter"/>
+              </a:rPr>
+              <a:t>Phase 2, integrations &amp; reporting.</a:t>
+            </a:r>
+          </a:p>
+        </p:txBody>
+      </p:sp>
+      <p:sp>
+        <p:nvSpPr>
+          <p:cNvPr id="11" name="Rectangle 10"/>
+          <p:cNvSpPr/>
+          <p:nvPr/>
+        </p:nvSpPr>
+        <p:spPr>
+          <a:xfrm>
+            <a:off x="8079028" y="2194560"/>
+            <a:ext cx="3234842" cy="1783080"/>
+          </a:xfrm>
+          <a:prstGeom prst="rect">
+            <a:avLst/>
+          </a:prstGeom>
+          <a:solidFill>
+            <a:srgbClr val="141414"/>
+          </a:solidFill>
+          <a:ln w="12700">
+            <a:solidFill>
+              <a:srgbClr val="3A3A3A"/>
+            </a:solidFill>
+          </a:ln>
+          <a:effectLst/>
+        </p:spPr>
+        <p:style>
+          <a:lnRef idx="1">
+            <a:schemeClr val="accent1"/>
+          </a:lnRef>
+          <a:fillRef idx="3">
+            <a:schemeClr val="accent1"/>
+          </a:fillRef>
+          <a:effectRef idx="2">
+            <a:schemeClr val="accent1"/>
+          </a:effectRef>
+          <a:fontRef idx="minor">
+            <a:schemeClr val="lt1"/>
+          </a:fontRef>
+        </p:style>
+        <p:txBody>
+          <a:bodyPr rtlCol="0" anchor="ctr"/>
+          <a:lstStyle/>
+          <a:p>
+            <a:pPr algn="ctr"/>
+          </a:p>
+        </p:txBody>
+      </p:sp>
+      <p:sp>
+        <p:nvSpPr>
+          <p:cNvPr id="12" name="TextBox 11"/>
+          <p:cNvSpPr txBox="1"/>
+          <p:nvPr/>
+        </p:nvSpPr>
+        <p:spPr>
+          <a:xfrm>
+            <a:off x="8353348" y="2468879"/>
+            <a:ext cx="2731922" cy="365760"/>
+          </a:xfrm>
+          <a:prstGeom prst="rect">
+            <a:avLst/>
+          </a:prstGeom>
+          <a:noFill/>
+        </p:spPr>
+        <p:txBody>
+          <a:bodyPr wrap="square" anchor="t" lIns="0" rIns="0" tIns="0" bIns="0"/>
+          <a:lstStyle/>
+          <a:p>
+            <a:pPr algn="l">
+              <a:lnSpc>
+                <a:spcPct val="100000"/>
+              </a:lnSpc>
+              <a:spcBef>
+                <a:spcPts val="0"/>
+              </a:spcBef>
+              <a:spcAft>
+                <a:spcPts val="0"/>
+              </a:spcAft>
+            </a:pPr>
+            <a:r>
+              <a:rPr sz="1400" b="1" i="0" lang="en-AU" spc="112" cap="all">
+                <a:solidFill>
+                  <a:srgbClr val="EA493F"/>
+                </a:solidFill>
+                <a:latin typeface="Inter"/>
+              </a:rPr>
+              <a:t>MANAGE</a:t>
+            </a:r>
+          </a:p>
+        </p:txBody>
+      </p:sp>
+      <p:sp>
+        <p:nvSpPr>
+          <p:cNvPr id="13" name="TextBox 12"/>
+          <p:cNvSpPr txBox="1"/>
+          <p:nvPr/>
+        </p:nvSpPr>
+        <p:spPr>
+          <a:xfrm>
+            <a:off x="8353348" y="2962656"/>
+            <a:ext cx="2686202" cy="822959"/>
+          </a:xfrm>
+          <a:prstGeom prst="rect">
+            <a:avLst/>
+          </a:prstGeom>
+          <a:noFill/>
+        </p:spPr>
+        <p:txBody>
+          <a:bodyPr wrap="square" anchor="t" lIns="0" rIns="0" tIns="0" bIns="0"/>
+          <a:lstStyle/>
+          <a:p>
+            <a:pPr algn="l">
+              <a:lnSpc>
+                <a:spcPct val="132000"/>
+              </a:lnSpc>
+              <a:spcBef>
+                <a:spcPts val="0"/>
+              </a:spcBef>
+              <a:spcAft>
+                <a:spcPts val="0"/>
+              </a:spcAft>
+            </a:pPr>
+            <a:r>
+              <a:rPr sz="1350" b="1" i="0" lang="en-AU" spc="-13">
+                <a:solidFill>
+                  <a:srgbClr val="FFFFFF"/>
+                </a:solidFill>
+                <a:latin typeface="Inter"/>
+              </a:rPr>
+              <a:t>Managed Services &amp; Managed Payroll — 24×7, continuous improvement.</a:t>
+            </a:r>
+          </a:p>
+        </p:txBody>
+      </p:sp>
+      <p:sp>
+        <p:nvSpPr>
+          <p:cNvPr id="14" name="TextBox 13"/>
+          <p:cNvSpPr txBox="1"/>
+          <p:nvPr/>
+        </p:nvSpPr>
+        <p:spPr>
+          <a:xfrm>
+            <a:off x="4167530" y="2830068"/>
+            <a:ext cx="548640" cy="512064"/>
+          </a:xfrm>
+          <a:prstGeom prst="rect">
+            <a:avLst/>
+          </a:prstGeom>
+          <a:noFill/>
+        </p:spPr>
+        <p:txBody>
+          <a:bodyPr wrap="square" anchor="ctr" lIns="0" rIns="0" tIns="0" bIns="0"/>
+          <a:lstStyle/>
+          <a:p>
+            <a:pPr algn="ctr">
+              <a:lnSpc>
+                <a:spcPct val="100000"/>
+              </a:lnSpc>
+              <a:spcBef>
+                <a:spcPts val="0"/>
+              </a:spcBef>
+              <a:spcAft>
+                <a:spcPts val="0"/>
+              </a:spcAft>
+            </a:pPr>
+            <a:r>
+              <a:rPr sz="2600" b="1" i="0" lang="en-AU" spc="0">
+                <a:solidFill>
+                  <a:srgbClr val="EA493F"/>
+                </a:solidFill>
+                <a:latin typeface="Inter"/>
+              </a:rPr>
+              <a:t>›</a:t>
+            </a:r>
+          </a:p>
+        </p:txBody>
+      </p:sp>
+      <p:sp>
+        <p:nvSpPr>
           <p:cNvPr id="15" name="TextBox 14"/>
           <p:cNvSpPr txBox="1"/>
           <p:nvPr/>
         </p:nvSpPr>
         <p:spPr>
           <a:xfrm>
-            <a:off x="6553047" y="2569463"/>
-            <a:ext cx="4532223" cy="365760"/>
+            <a:off x="7768132" y="2830068"/>
+            <a:ext cx="548640" cy="512064"/>
+          </a:xfrm>
+          <a:prstGeom prst="rect">
+            <a:avLst/>
+          </a:prstGeom>
+          <a:noFill/>
+        </p:spPr>
+        <p:txBody>
+          <a:bodyPr wrap="square" anchor="ctr" lIns="0" rIns="0" tIns="0" bIns="0"/>
+          <a:lstStyle/>
+          <a:p>
+            <a:pPr algn="ctr">
+              <a:lnSpc>
+                <a:spcPct val="100000"/>
+              </a:lnSpc>
+              <a:spcBef>
+                <a:spcPts val="0"/>
+              </a:spcBef>
+              <a:spcAft>
+                <a:spcPts val="0"/>
+              </a:spcAft>
+            </a:pPr>
+            <a:r>
+              <a:rPr sz="2600" b="1" i="0" lang="en-AU" spc="0">
+                <a:solidFill>
+                  <a:srgbClr val="EA493F"/>
+                </a:solidFill>
+                <a:latin typeface="Inter"/>
+              </a:rPr>
+              <a:t>›</a:t>
+            </a:r>
+          </a:p>
+        </p:txBody>
+      </p:sp>
+      <p:sp>
+        <p:nvSpPr>
+          <p:cNvPr id="16" name="Rectangle 15"/>
+          <p:cNvSpPr/>
+          <p:nvPr/>
+        </p:nvSpPr>
+        <p:spPr>
+          <a:xfrm>
+            <a:off x="877824" y="4389120"/>
+            <a:ext cx="6835444" cy="914400"/>
+          </a:xfrm>
+          <a:prstGeom prst="rect">
+            <a:avLst/>
+          </a:prstGeom>
+          <a:noFill/>
+          <a:ln w="19050">
+            <a:solidFill>
+              <a:srgbClr val="EA493F"/>
+            </a:solidFill>
+          </a:ln>
+          <a:effectLst/>
+        </p:spPr>
+        <p:style>
+          <a:lnRef idx="1">
+            <a:schemeClr val="accent1"/>
+          </a:lnRef>
+          <a:fillRef idx="3">
+            <a:schemeClr val="accent1"/>
+          </a:fillRef>
+          <a:effectRef idx="2">
+            <a:schemeClr val="accent1"/>
+          </a:effectRef>
+          <a:fontRef idx="minor">
+            <a:schemeClr val="lt1"/>
+          </a:fontRef>
+        </p:style>
+        <p:txBody>
+          <a:bodyPr rtlCol="0" anchor="ctr"/>
+          <a:lstStyle/>
+          <a:p>
+            <a:pPr algn="ctr"/>
+          </a:p>
+        </p:txBody>
+      </p:sp>
+      <p:sp>
+        <p:nvSpPr>
+          <p:cNvPr id="17" name="TextBox 16"/>
+          <p:cNvSpPr txBox="1"/>
+          <p:nvPr/>
+        </p:nvSpPr>
+        <p:spPr>
+          <a:xfrm>
+            <a:off x="1152144" y="4572000"/>
+            <a:ext cx="6286804" cy="329184"/>
           </a:xfrm>
           <a:prstGeom prst="rect">
             <a:avLst/>
@@ -5602,27 +5647,27 @@
               </a:spcAft>
             </a:pPr>
             <a:r>
-              <a:rPr sz="1250" b="1" i="0" lang="en-AU" spc="150" cap="all">
+              <a:rPr sz="1150" b="1" i="0" lang="en-AU" spc="115" cap="all">
                 <a:solidFill>
                   <a:srgbClr val="EA493F"/>
                 </a:solidFill>
                 <a:latin typeface="Inter"/>
               </a:rPr>
-              <a:t>MANAGED SERVICES (AMS)</a:t>
-            </a:r>
-          </a:p>
-        </p:txBody>
-      </p:sp>
-      <p:sp>
-        <p:nvSpPr>
-          <p:cNvPr id="16" name="TextBox 15"/>
-          <p:cNvSpPr txBox="1"/>
-          <p:nvPr/>
-        </p:nvSpPr>
-        <p:spPr>
-          <a:xfrm>
-            <a:off x="6553047" y="2935224"/>
-            <a:ext cx="4532223" cy="457200"/>
+              <a:t>STAFF AUGMENTATION</a:t>
+            </a:r>
+          </a:p>
+        </p:txBody>
+      </p:sp>
+      <p:sp>
+        <p:nvSpPr>
+          <p:cNvPr id="18" name="TextBox 17"/>
+          <p:cNvSpPr txBox="1"/>
+          <p:nvPr/>
+        </p:nvSpPr>
+        <p:spPr>
+          <a:xfrm>
+            <a:off x="1152144" y="4901183"/>
+            <a:ext cx="6286804" cy="329184"/>
           </a:xfrm>
           <a:prstGeom prst="rect">
             <a:avLst/>
@@ -5635,37 +5680,124 @@
           <a:p>
             <a:pPr algn="l">
               <a:lnSpc>
-                <a:spcPct val="105000"/>
-              </a:lnSpc>
-              <a:spcBef>
-                <a:spcPts val="0"/>
-              </a:spcBef>
-              <a:spcAft>
-                <a:spcPts val="0"/>
-              </a:spcAft>
-            </a:pPr>
-            <a:r>
-              <a:rPr sz="1450" b="1" i="0" lang="en-AU" spc="-14">
+                <a:spcPct val="100000"/>
+              </a:lnSpc>
+              <a:spcBef>
+                <a:spcPts val="0"/>
+              </a:spcBef>
+              <a:spcAft>
+                <a:spcPts val="0"/>
+              </a:spcAft>
+            </a:pPr>
+            <a:r>
+              <a:rPr sz="1200" b="0" i="0" lang="en-AU" spc="0">
+                <a:solidFill>
+                  <a:srgbClr val="D6D6D6"/>
+                </a:solidFill>
+                <a:latin typeface="Inter"/>
+              </a:rPr>
+              <a:t>Our certified consultants, embedded in your team — through Implement and Optimise.</a:t>
+            </a:r>
+          </a:p>
+        </p:txBody>
+      </p:sp>
+      <p:sp>
+        <p:nvSpPr>
+          <p:cNvPr id="19" name="Rectangle 18"/>
+          <p:cNvSpPr/>
+          <p:nvPr/>
+        </p:nvSpPr>
+        <p:spPr>
+          <a:xfrm>
+            <a:off x="8079028" y="4389120"/>
+            <a:ext cx="3234842" cy="914400"/>
+          </a:xfrm>
+          <a:prstGeom prst="rect">
+            <a:avLst/>
+          </a:prstGeom>
+          <a:solidFill>
+            <a:srgbClr val="EA493F"/>
+          </a:solidFill>
+          <a:ln>
+            <a:noFill/>
+          </a:ln>
+          <a:effectLst/>
+        </p:spPr>
+        <p:style>
+          <a:lnRef idx="1">
+            <a:schemeClr val="accent1"/>
+          </a:lnRef>
+          <a:fillRef idx="3">
+            <a:schemeClr val="accent1"/>
+          </a:fillRef>
+          <a:effectRef idx="2">
+            <a:schemeClr val="accent1"/>
+          </a:effectRef>
+          <a:fontRef idx="minor">
+            <a:schemeClr val="lt1"/>
+          </a:fontRef>
+        </p:style>
+        <p:txBody>
+          <a:bodyPr rtlCol="0" anchor="ctr"/>
+          <a:lstStyle/>
+          <a:p>
+            <a:pPr algn="ctr"/>
+          </a:p>
+        </p:txBody>
+      </p:sp>
+      <p:sp>
+        <p:nvSpPr>
+          <p:cNvPr id="20" name="TextBox 19"/>
+          <p:cNvSpPr txBox="1"/>
+          <p:nvPr/>
+        </p:nvSpPr>
+        <p:spPr>
+          <a:xfrm>
+            <a:off x="8353348" y="4572000"/>
+            <a:ext cx="2686202" cy="329184"/>
+          </a:xfrm>
+          <a:prstGeom prst="rect">
+            <a:avLst/>
+          </a:prstGeom>
+          <a:noFill/>
+        </p:spPr>
+        <p:txBody>
+          <a:bodyPr wrap="square" anchor="t" lIns="0" rIns="0" tIns="0" bIns="0"/>
+          <a:lstStyle/>
+          <a:p>
+            <a:pPr algn="l">
+              <a:lnSpc>
+                <a:spcPct val="100000"/>
+              </a:lnSpc>
+              <a:spcBef>
+                <a:spcPts val="0"/>
+              </a:spcBef>
+              <a:spcAft>
+                <a:spcPts val="0"/>
+              </a:spcAft>
+            </a:pPr>
+            <a:r>
+              <a:rPr sz="1150" b="1" i="0" lang="en-AU" spc="115" cap="all">
                 <a:solidFill>
                   <a:srgbClr val="FFFFFF"/>
                 </a:solidFill>
                 <a:latin typeface="Inter"/>
               </a:rPr>
-              <a:t>We own the outcome, end to end</a:t>
-            </a:r>
-          </a:p>
-        </p:txBody>
-      </p:sp>
-      <p:sp>
-        <p:nvSpPr>
-          <p:cNvPr id="17" name="TextBox 16"/>
-          <p:cNvSpPr txBox="1"/>
-          <p:nvPr/>
-        </p:nvSpPr>
-        <p:spPr>
-          <a:xfrm>
-            <a:off x="6553047" y="3538728"/>
-            <a:ext cx="4486503" cy="420624"/>
+              <a:t>MANAGED SERVICES</a:t>
+            </a:r>
+          </a:p>
+        </p:txBody>
+      </p:sp>
+      <p:sp>
+        <p:nvSpPr>
+          <p:cNvPr id="21" name="TextBox 20"/>
+          <p:cNvSpPr txBox="1"/>
+          <p:nvPr/>
+        </p:nvSpPr>
+        <p:spPr>
+          <a:xfrm>
+            <a:off x="8353348" y="4901183"/>
+            <a:ext cx="2686202" cy="329184"/>
           </a:xfrm>
           <a:prstGeom prst="rect">
             <a:avLst/>
@@ -5678,46 +5810,37 @@
           <a:p>
             <a:pPr algn="l">
               <a:lnSpc>
-                <a:spcPct val="112000"/>
-              </a:lnSpc>
-              <a:spcBef>
-                <a:spcPts val="0"/>
-              </a:spcBef>
-              <a:spcAft>
-                <a:spcPts val="0"/>
-              </a:spcAft>
-            </a:pPr>
-            <a:r>
-              <a:rPr sz="1050" b="1" i="0" lang="en-AU" spc="0">
-                <a:solidFill>
-                  <a:srgbClr val="EA493F"/>
-                </a:solidFill>
-                <a:latin typeface="Inter"/>
-              </a:rPr>
-              <a:t>—  </a:t>
-            </a:r>
-            <a:r>
-              <a:rPr sz="1050" b="0" i="0" lang="en-AU" spc="0">
-                <a:solidFill>
-                  <a:srgbClr val="D6D6D6"/>
-                </a:solidFill>
-                <a:latin typeface="Inter"/>
-              </a:rPr>
-              <a:t>Mivada owns incident, problem, change &amp; release management</a:t>
-            </a:r>
-          </a:p>
-        </p:txBody>
-      </p:sp>
-      <p:sp>
-        <p:nvSpPr>
-          <p:cNvPr id="18" name="TextBox 17"/>
-          <p:cNvSpPr txBox="1"/>
-          <p:nvPr/>
-        </p:nvSpPr>
-        <p:spPr>
-          <a:xfrm>
-            <a:off x="6553047" y="3959352"/>
-            <a:ext cx="4486503" cy="420624"/>
+                <a:spcPct val="100000"/>
+              </a:lnSpc>
+              <a:spcBef>
+                <a:spcPts val="0"/>
+              </a:spcBef>
+              <a:spcAft>
+                <a:spcPts val="0"/>
+              </a:spcAft>
+            </a:pPr>
+            <a:r>
+              <a:rPr sz="1200" b="1" i="0" lang="en-AU" spc="0">
+                <a:solidFill>
+                  <a:srgbClr val="FFFFFF"/>
+                </a:solidFill>
+                <a:latin typeface="Inter"/>
+              </a:rPr>
+              <a:t>We own the outcome at Manage</a:t>
+            </a:r>
+          </a:p>
+        </p:txBody>
+      </p:sp>
+      <p:sp>
+        <p:nvSpPr>
+          <p:cNvPr id="22" name="TextBox 21"/>
+          <p:cNvSpPr txBox="1"/>
+          <p:nvPr/>
+        </p:nvSpPr>
+        <p:spPr>
+          <a:xfrm>
+            <a:off x="877824" y="6144768"/>
+            <a:ext cx="10436047" cy="365760"/>
           </a:xfrm>
           <a:prstGeom prst="rect">
             <a:avLst/>
@@ -5730,214 +5853,6 @@
           <a:p>
             <a:pPr algn="l">
               <a:lnSpc>
-                <a:spcPct val="112000"/>
-              </a:lnSpc>
-              <a:spcBef>
-                <a:spcPts val="0"/>
-              </a:spcBef>
-              <a:spcAft>
-                <a:spcPts val="0"/>
-              </a:spcAft>
-            </a:pPr>
-            <a:r>
-              <a:rPr sz="1050" b="1" i="0" lang="en-AU" spc="0">
-                <a:solidFill>
-                  <a:srgbClr val="EA493F"/>
-                </a:solidFill>
-                <a:latin typeface="Inter"/>
-              </a:rPr>
-              <a:t>—  </a:t>
-            </a:r>
-            <a:r>
-              <a:rPr sz="1050" b="0" i="0" lang="en-AU" spc="0">
-                <a:solidFill>
-                  <a:srgbClr val="D6D6D6"/>
-                </a:solidFill>
-                <a:latin typeface="Inter"/>
-              </a:rPr>
-              <a:t>SLA-backed and governed, with 24×7 P1/P2 on-call</a:t>
-            </a:r>
-          </a:p>
-        </p:txBody>
-      </p:sp>
-      <p:sp>
-        <p:nvSpPr>
-          <p:cNvPr id="19" name="TextBox 18"/>
-          <p:cNvSpPr txBox="1"/>
-          <p:nvPr/>
-        </p:nvSpPr>
-        <p:spPr>
-          <a:xfrm>
-            <a:off x="6553047" y="4379976"/>
-            <a:ext cx="4486503" cy="420624"/>
-          </a:xfrm>
-          <a:prstGeom prst="rect">
-            <a:avLst/>
-          </a:prstGeom>
-          <a:noFill/>
-        </p:spPr>
-        <p:txBody>
-          <a:bodyPr wrap="square" anchor="t" lIns="0" rIns="0" tIns="0" bIns="0"/>
-          <a:lstStyle/>
-          <a:p>
-            <a:pPr algn="l">
-              <a:lnSpc>
-                <a:spcPct val="112000"/>
-              </a:lnSpc>
-              <a:spcBef>
-                <a:spcPts val="0"/>
-              </a:spcBef>
-              <a:spcAft>
-                <a:spcPts val="0"/>
-              </a:spcAft>
-            </a:pPr>
-            <a:r>
-              <a:rPr sz="1050" b="1" i="0" lang="en-AU" spc="0">
-                <a:solidFill>
-                  <a:srgbClr val="EA493F"/>
-                </a:solidFill>
-                <a:latin typeface="Inter"/>
-              </a:rPr>
-              <a:t>—  </a:t>
-            </a:r>
-            <a:r>
-              <a:rPr sz="1050" b="0" i="0" lang="en-AU" spc="0">
-                <a:solidFill>
-                  <a:srgbClr val="D6D6D6"/>
-                </a:solidFill>
-                <a:latin typeface="Inter"/>
-              </a:rPr>
-              <a:t>Continuous improvement and bi-annual release management</a:t>
-            </a:r>
-          </a:p>
-        </p:txBody>
-      </p:sp>
-      <p:sp>
-        <p:nvSpPr>
-          <p:cNvPr id="20" name="TextBox 19"/>
-          <p:cNvSpPr txBox="1"/>
-          <p:nvPr/>
-        </p:nvSpPr>
-        <p:spPr>
-          <a:xfrm>
-            <a:off x="6553047" y="4800600"/>
-            <a:ext cx="4486503" cy="420624"/>
-          </a:xfrm>
-          <a:prstGeom prst="rect">
-            <a:avLst/>
-          </a:prstGeom>
-          <a:noFill/>
-        </p:spPr>
-        <p:txBody>
-          <a:bodyPr wrap="square" anchor="t" lIns="0" rIns="0" tIns="0" bIns="0"/>
-          <a:lstStyle/>
-          <a:p>
-            <a:pPr algn="l">
-              <a:lnSpc>
-                <a:spcPct val="112000"/>
-              </a:lnSpc>
-              <a:spcBef>
-                <a:spcPts val="0"/>
-              </a:spcBef>
-              <a:spcAft>
-                <a:spcPts val="0"/>
-              </a:spcAft>
-            </a:pPr>
-            <a:r>
-              <a:rPr sz="1050" b="1" i="0" lang="en-AU" spc="0">
-                <a:solidFill>
-                  <a:srgbClr val="EA493F"/>
-                </a:solidFill>
-                <a:latin typeface="Inter"/>
-              </a:rPr>
-              <a:t>—  </a:t>
-            </a:r>
-            <a:r>
-              <a:rPr sz="1050" b="0" i="0" lang="en-AU" spc="0">
-                <a:solidFill>
-                  <a:srgbClr val="D6D6D6"/>
-                </a:solidFill>
-                <a:latin typeface="Inter"/>
-              </a:rPr>
-              <a:t>Ideal for steady-state operations and long-term partnership</a:t>
-            </a:r>
-          </a:p>
-        </p:txBody>
-      </p:sp>
-      <p:sp>
-        <p:nvSpPr>
-          <p:cNvPr id="21" name="TextBox 20"/>
-          <p:cNvSpPr txBox="1"/>
-          <p:nvPr/>
-        </p:nvSpPr>
-        <p:spPr>
-          <a:xfrm>
-            <a:off x="6553047" y="5221224"/>
-            <a:ext cx="4486503" cy="420624"/>
-          </a:xfrm>
-          <a:prstGeom prst="rect">
-            <a:avLst/>
-          </a:prstGeom>
-          <a:noFill/>
-        </p:spPr>
-        <p:txBody>
-          <a:bodyPr wrap="square" anchor="t" lIns="0" rIns="0" tIns="0" bIns="0"/>
-          <a:lstStyle/>
-          <a:p>
-            <a:pPr algn="l">
-              <a:lnSpc>
-                <a:spcPct val="112000"/>
-              </a:lnSpc>
-              <a:spcBef>
-                <a:spcPts val="0"/>
-              </a:spcBef>
-              <a:spcAft>
-                <a:spcPts val="0"/>
-              </a:spcAft>
-            </a:pPr>
-            <a:r>
-              <a:rPr sz="1050" b="1" i="0" lang="en-AU" spc="0">
-                <a:solidFill>
-                  <a:srgbClr val="EA493F"/>
-                </a:solidFill>
-                <a:latin typeface="Inter"/>
-              </a:rPr>
-              <a:t>—  </a:t>
-            </a:r>
-            <a:r>
-              <a:rPr sz="1050" b="0" i="0" lang="en-AU" spc="0">
-                <a:solidFill>
-                  <a:srgbClr val="D6D6D6"/>
-                </a:solidFill>
-                <a:latin typeface="Inter"/>
-              </a:rPr>
-              <a:t>Fixed monthly hours with carry-forward flexibility</a:t>
-            </a:r>
-          </a:p>
-        </p:txBody>
-      </p:sp>
-      <p:sp>
-        <p:nvSpPr>
-          <p:cNvPr id="22" name="TextBox 21"/>
-          <p:cNvSpPr txBox="1"/>
-          <p:nvPr/>
-        </p:nvSpPr>
-        <p:spPr>
-          <a:xfrm>
-            <a:off x="877824" y="5806440"/>
-            <a:ext cx="10436047" cy="457200"/>
-          </a:xfrm>
-          <a:prstGeom prst="rect">
-            <a:avLst/>
-          </a:prstGeom>
-          <a:noFill/>
-        </p:spPr>
-        <p:txBody>
-          <a:bodyPr wrap="square" anchor="t" lIns="0" rIns="0" tIns="0" bIns="0"/>
-          <a:lstStyle/>
-          <a:p>
-            <a:pPr algn="l">
-              <a:lnSpc>
                 <a:spcPct val="100000"/>
               </a:lnSpc>
               <a:spcBef>
@@ -5948,13 +5863,13 @@
               </a:spcAft>
             </a:pPr>
             <a:r>
-              <a:rPr sz="1200" b="1" i="0" lang="en-AU" spc="0">
+              <a:rPr sz="1200" b="1" i="0" lang="en-AU" spc="24">
                 <a:solidFill>
                   <a:srgbClr val="AEAEAE"/>
                 </a:solidFill>
                 <a:latin typeface="Inter"/>
               </a:rPr>
-              <a:t>Many clients start with augmentation and move into AMS as their environment stabilises — the same team carries the knowledge across.</a:t>
+              <a:t>Flex between engagement models as you move from build to run.</a:t>
             </a:r>
           </a:p>
         </p:txBody>
@@ -5973,7 +5888,7 @@
     <p:bg>
       <p:bgPr>
         <a:solidFill>
-          <a:srgbClr val="FAFAFA"/>
+          <a:srgbClr val="000000"/>
         </a:solidFill>
         <a:effectLst/>
       </p:bgPr>
@@ -5987,7 +5902,7 @@
       <p:grpSpPr/>
       <p:pic>
         <p:nvPicPr>
-          <p:cNvPr id="2" name="Picture 1" descr="Mivada_Icon_Melon_RGB_L.png"/>
+          <p:cNvPr id="2" name="Picture 1" descr="Mivada_Icon_White_RGB_L.png"/>
           <p:cNvPicPr>
             <a:picLocks noChangeAspect="1"/>
           </p:cNvPicPr>
@@ -6086,11 +6001,11 @@
             <a:r>
               <a:rPr sz="3300" b="1" i="0" lang="en-AU" spc="-72">
                 <a:solidFill>
-                  <a:srgbClr val="111111"/>
-                </a:solidFill>
-                <a:latin typeface="Inter"/>
-              </a:rPr>
-              <a:t>AMS operating </a:t>
+                  <a:srgbClr val="FFFFFF"/>
+                </a:solidFill>
+                <a:latin typeface="Inter"/>
+              </a:rPr>
+              <a:t>AMS, built on </a:t>
             </a:r>
             <a:r>
               <a:rPr sz="3300" b="1" i="0" lang="en-AU" spc="-72">
@@ -6099,7 +6014,7 @@
                 </a:solidFill>
                 <a:latin typeface="Inter"/>
               </a:rPr>
-              <a:t>framework.</a:t>
+              <a:t>ITIL.</a:t>
             </a:r>
           </a:p>
         </p:txBody>
@@ -6138,11 +6053,11 @@
             <a:r>
               <a:rPr sz="1300" b="0" i="0" lang="en-AU" spc="0">
                 <a:solidFill>
-                  <a:srgbClr val="323232"/>
-                </a:solidFill>
-                <a:latin typeface="Inter"/>
-              </a:rPr>
-              <a:t>Driving operational excellence through governance, integration and continuous improvement.</a:t>
+                  <a:srgbClr val="CFCFCF"/>
+                </a:solidFill>
+                <a:latin typeface="Inter"/>
+              </a:rPr>
+              <a:t>We run Workday on ITIL — the global standard for IT service management.</a:t>
             </a:r>
           </a:p>
         </p:txBody>
@@ -6155,17 +6070,19 @@
         </p:nvSpPr>
         <p:spPr>
           <a:xfrm>
-            <a:off x="877824" y="2286000"/>
-            <a:ext cx="10436047" cy="310896"/>
+            <a:off x="877824" y="2514600"/>
+            <a:ext cx="3234842" cy="3017520"/>
           </a:xfrm>
           <a:prstGeom prst="rect">
             <a:avLst/>
           </a:prstGeom>
           <a:solidFill>
-            <a:srgbClr val="EA493F"/>
+            <a:srgbClr val="141414"/>
           </a:solidFill>
-          <a:ln>
-            <a:noFill/>
+          <a:ln w="12700">
+            <a:solidFill>
+              <a:srgbClr val="3A3A3A"/>
+            </a:solidFill>
           </a:ln>
           <a:effectLst/>
         </p:spPr>
@@ -6199,16 +6116,16 @@
         </p:nvSpPr>
         <p:spPr>
           <a:xfrm>
-            <a:off x="1106424" y="2286000"/>
-            <a:ext cx="9978847" cy="310896"/>
-          </a:xfrm>
-          <a:prstGeom prst="rect">
-            <a:avLst/>
-          </a:prstGeom>
-          <a:noFill/>
-        </p:spPr>
-        <p:txBody>
-          <a:bodyPr wrap="square" anchor="ctr" lIns="0" rIns="0" tIns="0" bIns="0"/>
+            <a:off x="1152144" y="2807208"/>
+            <a:ext cx="2731922" cy="365760"/>
+          </a:xfrm>
+          <a:prstGeom prst="rect">
+            <a:avLst/>
+          </a:prstGeom>
+          <a:noFill/>
+        </p:spPr>
+        <p:txBody>
+          <a:bodyPr wrap="square" anchor="t" lIns="0" rIns="0" tIns="0" bIns="0"/>
           <a:lstStyle/>
           <a:p>
             <a:pPr algn="l">
@@ -6223,36 +6140,81 @@
               </a:spcAft>
             </a:pPr>
             <a:r>
-              <a:rPr sz="1150" b="1" i="0" lang="en-AU" spc="115" cap="all">
-                <a:solidFill>
-                  <a:srgbClr val="FFFFFF"/>
-                </a:solidFill>
-                <a:latin typeface="Inter"/>
-              </a:rPr>
-              <a:t>CONTINUOUS IMPROVEMENT</a:t>
-            </a:r>
-          </a:p>
-        </p:txBody>
-      </p:sp>
-      <p:sp>
-        <p:nvSpPr>
-          <p:cNvPr id="8" name="Rectangle 7"/>
+              <a:rPr sz="1250" b="1" i="0" lang="en-AU" spc="125" cap="all">
+                <a:solidFill>
+                  <a:srgbClr val="EA493F"/>
+                </a:solidFill>
+                <a:latin typeface="Inter"/>
+              </a:rPr>
+              <a:t>WHAT IT IS</a:t>
+            </a:r>
+          </a:p>
+        </p:txBody>
+      </p:sp>
+      <p:sp>
+        <p:nvSpPr>
+          <p:cNvPr id="8" name="TextBox 7"/>
+          <p:cNvSpPr txBox="1"/>
+          <p:nvPr/>
+        </p:nvSpPr>
+        <p:spPr>
+          <a:xfrm>
+            <a:off x="1152144" y="3355848"/>
+            <a:ext cx="2686202" cy="1920239"/>
+          </a:xfrm>
+          <a:prstGeom prst="rect">
+            <a:avLst/>
+          </a:prstGeom>
+          <a:noFill/>
+        </p:spPr>
+        <p:txBody>
+          <a:bodyPr wrap="square" anchor="t" lIns="0" rIns="0" tIns="0" bIns="0"/>
+          <a:lstStyle/>
+          <a:p>
+            <a:pPr algn="l">
+              <a:lnSpc>
+                <a:spcPct val="140000"/>
+              </a:lnSpc>
+              <a:spcBef>
+                <a:spcPts val="0"/>
+              </a:spcBef>
+              <a:spcAft>
+                <a:spcPts val="0"/>
+              </a:spcAft>
+            </a:pPr>
+            <a:r>
+              <a:rPr sz="1300" b="0" i="0" lang="en-AU" spc="0">
+                <a:solidFill>
+                  <a:srgbClr val="D6D6D6"/>
+                </a:solidFill>
+                <a:latin typeface="Inter"/>
+              </a:rPr>
+              <a:t>The proven framework for running IT services — incident, problem, change and release management, done to a recognised standard.</a:t>
+            </a:r>
+          </a:p>
+        </p:txBody>
+      </p:sp>
+      <p:sp>
+        <p:nvSpPr>
+          <p:cNvPr id="9" name="Rectangle 8"/>
           <p:cNvSpPr/>
           <p:nvPr/>
         </p:nvSpPr>
         <p:spPr>
           <a:xfrm>
-            <a:off x="877824" y="2633472"/>
-            <a:ext cx="10436047" cy="420624"/>
+            <a:off x="4478426" y="2514600"/>
+            <a:ext cx="3234842" cy="3017520"/>
           </a:xfrm>
           <a:prstGeom prst="rect">
             <a:avLst/>
           </a:prstGeom>
           <a:solidFill>
-            <a:srgbClr val="111111"/>
+            <a:srgbClr val="141414"/>
           </a:solidFill>
-          <a:ln>
-            <a:noFill/>
+          <a:ln w="12700">
+            <a:solidFill>
+              <a:srgbClr val="3A3A3A"/>
+            </a:solidFill>
           </a:ln>
           <a:effectLst/>
         </p:spPr>
@@ -6280,22 +6242,22 @@
       </p:sp>
       <p:sp>
         <p:nvSpPr>
-          <p:cNvPr id="9" name="TextBox 8"/>
-          <p:cNvSpPr txBox="1"/>
-          <p:nvPr/>
-        </p:nvSpPr>
-        <p:spPr>
-          <a:xfrm>
-            <a:off x="1106424" y="2633472"/>
-            <a:ext cx="9978847" cy="420624"/>
-          </a:xfrm>
-          <a:prstGeom prst="rect">
-            <a:avLst/>
-          </a:prstGeom>
-          <a:noFill/>
-        </p:spPr>
-        <p:txBody>
-          <a:bodyPr wrap="square" anchor="ctr" lIns="0" rIns="0" tIns="0" bIns="0"/>
+          <p:cNvPr id="10" name="TextBox 9"/>
+          <p:cNvSpPr txBox="1"/>
+          <p:nvPr/>
+        </p:nvSpPr>
+        <p:spPr>
+          <a:xfrm>
+            <a:off x="4752746" y="2807208"/>
+            <a:ext cx="2731922" cy="365760"/>
+          </a:xfrm>
+          <a:prstGeom prst="rect">
+            <a:avLst/>
+          </a:prstGeom>
+          <a:noFill/>
+        </p:spPr>
+        <p:txBody>
+          <a:bodyPr wrap="square" anchor="t" lIns="0" rIns="0" tIns="0" bIns="0"/>
           <a:lstStyle/>
           <a:p>
             <a:pPr algn="l">
@@ -6310,46 +6272,80 @@
               </a:spcAft>
             </a:pPr>
             <a:r>
-              <a:rPr sz="1150" b="1" i="0" lang="en-AU" spc="115" cap="all">
-                <a:solidFill>
-                  <a:srgbClr val="FFFFFF"/>
-                </a:solidFill>
-                <a:latin typeface="Inter"/>
-              </a:rPr>
-              <a:t>GOVERNANCE</a:t>
-            </a:r>
-            <a:r>
-              <a:rPr sz="1000" b="0" i="0" lang="en-AU" spc="0">
-                <a:solidFill>
-                  <a:srgbClr val="FFFFFF"/>
-                </a:solidFill>
-                <a:latin typeface="Inter"/>
-              </a:rPr>
-              <a:t>    Thought leadership · Product &amp; vendor relationship · Technical-debt reduction · WD bi-annual release management</a:t>
-            </a:r>
-          </a:p>
-        </p:txBody>
-      </p:sp>
-      <p:sp>
-        <p:nvSpPr>
-          <p:cNvPr id="10" name="Rectangle 9"/>
+              <a:rPr sz="1250" b="1" i="0" lang="en-AU" spc="125" cap="all">
+                <a:solidFill>
+                  <a:srgbClr val="EA493F"/>
+                </a:solidFill>
+                <a:latin typeface="Inter"/>
+              </a:rPr>
+              <a:t>WHY IT MATTERS</a:t>
+            </a:r>
+          </a:p>
+        </p:txBody>
+      </p:sp>
+      <p:sp>
+        <p:nvSpPr>
+          <p:cNvPr id="11" name="TextBox 10"/>
+          <p:cNvSpPr txBox="1"/>
+          <p:nvPr/>
+        </p:nvSpPr>
+        <p:spPr>
+          <a:xfrm>
+            <a:off x="4752746" y="3355848"/>
+            <a:ext cx="2686202" cy="1920239"/>
+          </a:xfrm>
+          <a:prstGeom prst="rect">
+            <a:avLst/>
+          </a:prstGeom>
+          <a:noFill/>
+        </p:spPr>
+        <p:txBody>
+          <a:bodyPr wrap="square" anchor="t" lIns="0" rIns="0" tIns="0" bIns="0"/>
+          <a:lstStyle/>
+          <a:p>
+            <a:pPr algn="l">
+              <a:lnSpc>
+                <a:spcPct val="140000"/>
+              </a:lnSpc>
+              <a:spcBef>
+                <a:spcPts val="0"/>
+              </a:spcBef>
+              <a:spcAft>
+                <a:spcPts val="0"/>
+              </a:spcAft>
+            </a:pPr>
+            <a:r>
+              <a:rPr sz="1300" b="0" i="0" lang="en-AU" spc="0">
+                <a:solidFill>
+                  <a:srgbClr val="D6D6D6"/>
+                </a:solidFill>
+                <a:latin typeface="Inter"/>
+              </a:rPr>
+              <a:t>Predictable, SLA-backed support: fewer incidents, faster resolution, controlled change and continuous improvement.</a:t>
+            </a:r>
+          </a:p>
+        </p:txBody>
+      </p:sp>
+      <p:sp>
+        <p:nvSpPr>
+          <p:cNvPr id="12" name="Rectangle 11"/>
           <p:cNvSpPr/>
           <p:nvPr/>
         </p:nvSpPr>
         <p:spPr>
           <a:xfrm>
-            <a:off x="877824" y="3200400"/>
-            <a:ext cx="2512999" cy="457200"/>
+            <a:off x="8079028" y="2514600"/>
+            <a:ext cx="3234842" cy="3017520"/>
           </a:xfrm>
           <a:prstGeom prst="rect">
             <a:avLst/>
           </a:prstGeom>
           <a:solidFill>
-            <a:srgbClr val="FFFFFF"/>
+            <a:srgbClr val="141414"/>
           </a:solidFill>
           <a:ln w="12700">
             <a:solidFill>
-              <a:srgbClr val="E4E4E0"/>
+              <a:srgbClr val="3A3A3A"/>
             </a:solidFill>
           </a:ln>
           <a:effectLst/>
@@ -6378,25 +6374,25 @@
       </p:sp>
       <p:sp>
         <p:nvSpPr>
-          <p:cNvPr id="11" name="TextBox 10"/>
-          <p:cNvSpPr txBox="1"/>
-          <p:nvPr/>
-        </p:nvSpPr>
-        <p:spPr>
-          <a:xfrm>
-            <a:off x="950976" y="3200400"/>
-            <a:ext cx="2366695" cy="457200"/>
-          </a:xfrm>
-          <a:prstGeom prst="rect">
-            <a:avLst/>
-          </a:prstGeom>
-          <a:noFill/>
-        </p:spPr>
-        <p:txBody>
-          <a:bodyPr wrap="square" anchor="ctr" lIns="0" rIns="0" tIns="0" bIns="0"/>
-          <a:lstStyle/>
-          <a:p>
-            <a:pPr algn="ctr">
+          <p:cNvPr id="13" name="TextBox 12"/>
+          <p:cNvSpPr txBox="1"/>
+          <p:nvPr/>
+        </p:nvSpPr>
+        <p:spPr>
+          <a:xfrm>
+            <a:off x="8353348" y="2807208"/>
+            <a:ext cx="2731922" cy="365760"/>
+          </a:xfrm>
+          <a:prstGeom prst="rect">
+            <a:avLst/>
+          </a:prstGeom>
+          <a:noFill/>
+        </p:spPr>
+        <p:txBody>
+          <a:bodyPr wrap="square" anchor="t" lIns="0" rIns="0" tIns="0" bIns="0"/>
+          <a:lstStyle/>
+          <a:p>
+            <a:pPr algn="l">
               <a:lnSpc>
                 <a:spcPct val="100000"/>
               </a:lnSpc>
@@ -6408,84 +6404,81 @@
               </a:spcAft>
             </a:pPr>
             <a:r>
-              <a:rPr sz="950" b="1" i="0" lang="en-AU" spc="-4">
-                <a:solidFill>
-                  <a:srgbClr val="111111"/>
-                </a:solidFill>
-                <a:latin typeface="Inter"/>
-              </a:rPr>
-              <a:t>Incident management</a:t>
-            </a:r>
-          </a:p>
-        </p:txBody>
-      </p:sp>
-      <p:sp>
-        <p:nvSpPr>
-          <p:cNvPr id="12" name="Rectangle 11"/>
-          <p:cNvSpPr/>
-          <p:nvPr/>
-        </p:nvSpPr>
-        <p:spPr>
-          <a:xfrm>
-            <a:off x="3518839" y="3200400"/>
-            <a:ext cx="2512999" cy="457200"/>
-          </a:xfrm>
-          <a:prstGeom prst="rect">
-            <a:avLst/>
-          </a:prstGeom>
-          <a:solidFill>
-            <a:srgbClr val="FFFFFF"/>
-          </a:solidFill>
-          <a:ln w="12700">
-            <a:solidFill>
-              <a:srgbClr val="E4E4E0"/>
-            </a:solidFill>
-          </a:ln>
-          <a:effectLst/>
-        </p:spPr>
-        <p:style>
-          <a:lnRef idx="1">
-            <a:schemeClr val="accent1"/>
-          </a:lnRef>
-          <a:fillRef idx="3">
-            <a:schemeClr val="accent1"/>
-          </a:fillRef>
-          <a:effectRef idx="2">
-            <a:schemeClr val="accent1"/>
-          </a:effectRef>
-          <a:fontRef idx="minor">
-            <a:schemeClr val="lt1"/>
-          </a:fontRef>
-        </p:style>
-        <p:txBody>
-          <a:bodyPr rtlCol="0" anchor="ctr"/>
-          <a:lstStyle/>
-          <a:p>
-            <a:pPr algn="ctr"/>
-          </a:p>
-        </p:txBody>
-      </p:sp>
-      <p:sp>
-        <p:nvSpPr>
-          <p:cNvPr id="13" name="TextBox 12"/>
-          <p:cNvSpPr txBox="1"/>
-          <p:nvPr/>
-        </p:nvSpPr>
-        <p:spPr>
-          <a:xfrm>
-            <a:off x="3591991" y="3200400"/>
-            <a:ext cx="2366695" cy="457200"/>
-          </a:xfrm>
-          <a:prstGeom prst="rect">
-            <a:avLst/>
-          </a:prstGeom>
-          <a:noFill/>
-        </p:spPr>
-        <p:txBody>
-          <a:bodyPr wrap="square" anchor="ctr" lIns="0" rIns="0" tIns="0" bIns="0"/>
-          <a:lstStyle/>
-          <a:p>
-            <a:pPr algn="ctr">
+              <a:rPr sz="1250" b="1" i="0" lang="en-AU" spc="125" cap="all">
+                <a:solidFill>
+                  <a:srgbClr val="EA493F"/>
+                </a:solidFill>
+                <a:latin typeface="Inter"/>
+              </a:rPr>
+              <a:t>HOW WE APPLY IT</a:t>
+            </a:r>
+          </a:p>
+        </p:txBody>
+      </p:sp>
+      <p:sp>
+        <p:nvSpPr>
+          <p:cNvPr id="14" name="TextBox 13"/>
+          <p:cNvSpPr txBox="1"/>
+          <p:nvPr/>
+        </p:nvSpPr>
+        <p:spPr>
+          <a:xfrm>
+            <a:off x="8353348" y="3355848"/>
+            <a:ext cx="2686202" cy="1920239"/>
+          </a:xfrm>
+          <a:prstGeom prst="rect">
+            <a:avLst/>
+          </a:prstGeom>
+          <a:noFill/>
+        </p:spPr>
+        <p:txBody>
+          <a:bodyPr wrap="square" anchor="t" lIns="0" rIns="0" tIns="0" bIns="0"/>
+          <a:lstStyle/>
+          <a:p>
+            <a:pPr algn="l">
+              <a:lnSpc>
+                <a:spcPct val="140000"/>
+              </a:lnSpc>
+              <a:spcBef>
+                <a:spcPts val="0"/>
+              </a:spcBef>
+              <a:spcAft>
+                <a:spcPts val="0"/>
+              </a:spcAft>
+            </a:pPr>
+            <a:r>
+              <a:rPr sz="1300" b="0" i="0" lang="en-AU" spc="0">
+                <a:solidFill>
+                  <a:srgbClr val="D6D6D6"/>
+                </a:solidFill>
+                <a:latin typeface="Inter"/>
+              </a:rPr>
+              <a:t>Governed run operations · 24×7 P1/P2 on-call · change &amp; release control · continuous improvement.</a:t>
+            </a:r>
+          </a:p>
+        </p:txBody>
+      </p:sp>
+      <p:sp>
+        <p:nvSpPr>
+          <p:cNvPr id="15" name="TextBox 14"/>
+          <p:cNvSpPr txBox="1"/>
+          <p:nvPr/>
+        </p:nvSpPr>
+        <p:spPr>
+          <a:xfrm>
+            <a:off x="877824" y="5943600"/>
+            <a:ext cx="10436047" cy="365760"/>
+          </a:xfrm>
+          <a:prstGeom prst="rect">
+            <a:avLst/>
+          </a:prstGeom>
+          <a:noFill/>
+        </p:spPr>
+        <p:txBody>
+          <a:bodyPr wrap="square" anchor="t" lIns="0" rIns="0" tIns="0" bIns="0"/>
+          <a:lstStyle/>
+          <a:p>
+            <a:pPr algn="l">
               <a:lnSpc>
                 <a:spcPct val="100000"/>
               </a:lnSpc>
@@ -6497,1613 +6490,13 @@
               </a:spcAft>
             </a:pPr>
             <a:r>
-              <a:rPr sz="950" b="1" i="0" lang="en-AU" spc="-4">
-                <a:solidFill>
-                  <a:srgbClr val="111111"/>
-                </a:solidFill>
-                <a:latin typeface="Inter"/>
-              </a:rPr>
-              <a:t>Problem management</a:t>
-            </a:r>
-          </a:p>
-        </p:txBody>
-      </p:sp>
-      <p:sp>
-        <p:nvSpPr>
-          <p:cNvPr id="14" name="Rectangle 13"/>
-          <p:cNvSpPr/>
-          <p:nvPr/>
-        </p:nvSpPr>
-        <p:spPr>
-          <a:xfrm>
-            <a:off x="6159855" y="3200400"/>
-            <a:ext cx="2512999" cy="457200"/>
-          </a:xfrm>
-          <a:prstGeom prst="rect">
-            <a:avLst/>
-          </a:prstGeom>
-          <a:solidFill>
-            <a:srgbClr val="FFFFFF"/>
-          </a:solidFill>
-          <a:ln w="12700">
-            <a:solidFill>
-              <a:srgbClr val="E4E4E0"/>
-            </a:solidFill>
-          </a:ln>
-          <a:effectLst/>
-        </p:spPr>
-        <p:style>
-          <a:lnRef idx="1">
-            <a:schemeClr val="accent1"/>
-          </a:lnRef>
-          <a:fillRef idx="3">
-            <a:schemeClr val="accent1"/>
-          </a:fillRef>
-          <a:effectRef idx="2">
-            <a:schemeClr val="accent1"/>
-          </a:effectRef>
-          <a:fontRef idx="minor">
-            <a:schemeClr val="lt1"/>
-          </a:fontRef>
-        </p:style>
-        <p:txBody>
-          <a:bodyPr rtlCol="0" anchor="ctr"/>
-          <a:lstStyle/>
-          <a:p>
-            <a:pPr algn="ctr"/>
-          </a:p>
-        </p:txBody>
-      </p:sp>
-      <p:sp>
-        <p:nvSpPr>
-          <p:cNvPr id="15" name="TextBox 14"/>
-          <p:cNvSpPr txBox="1"/>
-          <p:nvPr/>
-        </p:nvSpPr>
-        <p:spPr>
-          <a:xfrm>
-            <a:off x="6233007" y="3200400"/>
-            <a:ext cx="2366695" cy="457200"/>
-          </a:xfrm>
-          <a:prstGeom prst="rect">
-            <a:avLst/>
-          </a:prstGeom>
-          <a:noFill/>
-        </p:spPr>
-        <p:txBody>
-          <a:bodyPr wrap="square" anchor="ctr" lIns="0" rIns="0" tIns="0" bIns="0"/>
-          <a:lstStyle/>
-          <a:p>
-            <a:pPr algn="ctr">
-              <a:lnSpc>
-                <a:spcPct val="100000"/>
-              </a:lnSpc>
-              <a:spcBef>
-                <a:spcPts val="0"/>
-              </a:spcBef>
-              <a:spcAft>
-                <a:spcPts val="0"/>
-              </a:spcAft>
-            </a:pPr>
-            <a:r>
-              <a:rPr sz="950" b="1" i="0" lang="en-AU" spc="-4">
-                <a:solidFill>
-                  <a:srgbClr val="111111"/>
-                </a:solidFill>
-                <a:latin typeface="Inter"/>
-              </a:rPr>
-              <a:t>Change management</a:t>
-            </a:r>
-          </a:p>
-        </p:txBody>
-      </p:sp>
-      <p:sp>
-        <p:nvSpPr>
-          <p:cNvPr id="16" name="Rectangle 15"/>
-          <p:cNvSpPr/>
-          <p:nvPr/>
-        </p:nvSpPr>
-        <p:spPr>
-          <a:xfrm>
-            <a:off x="8800871" y="3200400"/>
-            <a:ext cx="2512999" cy="457200"/>
-          </a:xfrm>
-          <a:prstGeom prst="rect">
-            <a:avLst/>
-          </a:prstGeom>
-          <a:solidFill>
-            <a:srgbClr val="FFFFFF"/>
-          </a:solidFill>
-          <a:ln w="12700">
-            <a:solidFill>
-              <a:srgbClr val="E4E4E0"/>
-            </a:solidFill>
-          </a:ln>
-          <a:effectLst/>
-        </p:spPr>
-        <p:style>
-          <a:lnRef idx="1">
-            <a:schemeClr val="accent1"/>
-          </a:lnRef>
-          <a:fillRef idx="3">
-            <a:schemeClr val="accent1"/>
-          </a:fillRef>
-          <a:effectRef idx="2">
-            <a:schemeClr val="accent1"/>
-          </a:effectRef>
-          <a:fontRef idx="minor">
-            <a:schemeClr val="lt1"/>
-          </a:fontRef>
-        </p:style>
-        <p:txBody>
-          <a:bodyPr rtlCol="0" anchor="ctr"/>
-          <a:lstStyle/>
-          <a:p>
-            <a:pPr algn="ctr"/>
-          </a:p>
-        </p:txBody>
-      </p:sp>
-      <p:sp>
-        <p:nvSpPr>
-          <p:cNvPr id="17" name="TextBox 16"/>
-          <p:cNvSpPr txBox="1"/>
-          <p:nvPr/>
-        </p:nvSpPr>
-        <p:spPr>
-          <a:xfrm>
-            <a:off x="8874023" y="3200400"/>
-            <a:ext cx="2366695" cy="457200"/>
-          </a:xfrm>
-          <a:prstGeom prst="rect">
-            <a:avLst/>
-          </a:prstGeom>
-          <a:noFill/>
-        </p:spPr>
-        <p:txBody>
-          <a:bodyPr wrap="square" anchor="ctr" lIns="0" rIns="0" tIns="0" bIns="0"/>
-          <a:lstStyle/>
-          <a:p>
-            <a:pPr algn="ctr">
-              <a:lnSpc>
-                <a:spcPct val="100000"/>
-              </a:lnSpc>
-              <a:spcBef>
-                <a:spcPts val="0"/>
-              </a:spcBef>
-              <a:spcAft>
-                <a:spcPts val="0"/>
-              </a:spcAft>
-            </a:pPr>
-            <a:r>
-              <a:rPr sz="950" b="1" i="0" lang="en-AU" spc="-4">
-                <a:solidFill>
-                  <a:srgbClr val="111111"/>
-                </a:solidFill>
-                <a:latin typeface="Inter"/>
-              </a:rPr>
-              <a:t>Release management</a:t>
-            </a:r>
-          </a:p>
-        </p:txBody>
-      </p:sp>
-      <p:sp>
-        <p:nvSpPr>
-          <p:cNvPr id="18" name="Rectangle 17"/>
-          <p:cNvSpPr/>
-          <p:nvPr/>
-        </p:nvSpPr>
-        <p:spPr>
-          <a:xfrm>
-            <a:off x="877824" y="3785615"/>
-            <a:ext cx="2512999" cy="457200"/>
-          </a:xfrm>
-          <a:prstGeom prst="rect">
-            <a:avLst/>
-          </a:prstGeom>
-          <a:solidFill>
-            <a:srgbClr val="FFFFFF"/>
-          </a:solidFill>
-          <a:ln w="12700">
-            <a:solidFill>
-              <a:srgbClr val="E4E4E0"/>
-            </a:solidFill>
-          </a:ln>
-          <a:effectLst/>
-        </p:spPr>
-        <p:style>
-          <a:lnRef idx="1">
-            <a:schemeClr val="accent1"/>
-          </a:lnRef>
-          <a:fillRef idx="3">
-            <a:schemeClr val="accent1"/>
-          </a:fillRef>
-          <a:effectRef idx="2">
-            <a:schemeClr val="accent1"/>
-          </a:effectRef>
-          <a:fontRef idx="minor">
-            <a:schemeClr val="lt1"/>
-          </a:fontRef>
-        </p:style>
-        <p:txBody>
-          <a:bodyPr rtlCol="0" anchor="ctr"/>
-          <a:lstStyle/>
-          <a:p>
-            <a:pPr algn="ctr"/>
-          </a:p>
-        </p:txBody>
-      </p:sp>
-      <p:sp>
-        <p:nvSpPr>
-          <p:cNvPr id="19" name="TextBox 18"/>
-          <p:cNvSpPr txBox="1"/>
-          <p:nvPr/>
-        </p:nvSpPr>
-        <p:spPr>
-          <a:xfrm>
-            <a:off x="950976" y="3785615"/>
-            <a:ext cx="2366695" cy="457200"/>
-          </a:xfrm>
-          <a:prstGeom prst="rect">
-            <a:avLst/>
-          </a:prstGeom>
-          <a:noFill/>
-        </p:spPr>
-        <p:txBody>
-          <a:bodyPr wrap="square" anchor="ctr" lIns="0" rIns="0" tIns="0" bIns="0"/>
-          <a:lstStyle/>
-          <a:p>
-            <a:pPr algn="ctr">
-              <a:lnSpc>
-                <a:spcPct val="100000"/>
-              </a:lnSpc>
-              <a:spcBef>
-                <a:spcPts val="0"/>
-              </a:spcBef>
-              <a:spcAft>
-                <a:spcPts val="0"/>
-              </a:spcAft>
-            </a:pPr>
-            <a:r>
-              <a:rPr sz="950" b="1" i="0" lang="en-AU" spc="-4">
-                <a:solidFill>
-                  <a:srgbClr val="111111"/>
-                </a:solidFill>
-                <a:latin typeface="Inter"/>
-              </a:rPr>
-              <a:t>Service requests</a:t>
-            </a:r>
-          </a:p>
-        </p:txBody>
-      </p:sp>
-      <p:sp>
-        <p:nvSpPr>
-          <p:cNvPr id="20" name="Rectangle 19"/>
-          <p:cNvSpPr/>
-          <p:nvPr/>
-        </p:nvSpPr>
-        <p:spPr>
-          <a:xfrm>
-            <a:off x="3518839" y="3785615"/>
-            <a:ext cx="2512999" cy="457200"/>
-          </a:xfrm>
-          <a:prstGeom prst="rect">
-            <a:avLst/>
-          </a:prstGeom>
-          <a:solidFill>
-            <a:srgbClr val="FFFFFF"/>
-          </a:solidFill>
-          <a:ln w="12700">
-            <a:solidFill>
-              <a:srgbClr val="E4E4E0"/>
-            </a:solidFill>
-          </a:ln>
-          <a:effectLst/>
-        </p:spPr>
-        <p:style>
-          <a:lnRef idx="1">
-            <a:schemeClr val="accent1"/>
-          </a:lnRef>
-          <a:fillRef idx="3">
-            <a:schemeClr val="accent1"/>
-          </a:fillRef>
-          <a:effectRef idx="2">
-            <a:schemeClr val="accent1"/>
-          </a:effectRef>
-          <a:fontRef idx="minor">
-            <a:schemeClr val="lt1"/>
-          </a:fontRef>
-        </p:style>
-        <p:txBody>
-          <a:bodyPr rtlCol="0" anchor="ctr"/>
-          <a:lstStyle/>
-          <a:p>
-            <a:pPr algn="ctr"/>
-          </a:p>
-        </p:txBody>
-      </p:sp>
-      <p:sp>
-        <p:nvSpPr>
-          <p:cNvPr id="21" name="TextBox 20"/>
-          <p:cNvSpPr txBox="1"/>
-          <p:nvPr/>
-        </p:nvSpPr>
-        <p:spPr>
-          <a:xfrm>
-            <a:off x="3591991" y="3785615"/>
-            <a:ext cx="2366695" cy="457200"/>
-          </a:xfrm>
-          <a:prstGeom prst="rect">
-            <a:avLst/>
-          </a:prstGeom>
-          <a:noFill/>
-        </p:spPr>
-        <p:txBody>
-          <a:bodyPr wrap="square" anchor="ctr" lIns="0" rIns="0" tIns="0" bIns="0"/>
-          <a:lstStyle/>
-          <a:p>
-            <a:pPr algn="ctr">
-              <a:lnSpc>
-                <a:spcPct val="100000"/>
-              </a:lnSpc>
-              <a:spcBef>
-                <a:spcPts val="0"/>
-              </a:spcBef>
-              <a:spcAft>
-                <a:spcPts val="0"/>
-              </a:spcAft>
-            </a:pPr>
-            <a:r>
-              <a:rPr sz="950" b="1" i="0" lang="en-AU" spc="-4">
-                <a:solidFill>
-                  <a:srgbClr val="111111"/>
-                </a:solidFill>
-                <a:latin typeface="Inter"/>
-              </a:rPr>
-              <a:t>Change Advisory Board</a:t>
-            </a:r>
-          </a:p>
-        </p:txBody>
-      </p:sp>
-      <p:sp>
-        <p:nvSpPr>
-          <p:cNvPr id="22" name="Rectangle 21"/>
-          <p:cNvSpPr/>
-          <p:nvPr/>
-        </p:nvSpPr>
-        <p:spPr>
-          <a:xfrm>
-            <a:off x="6159855" y="3785615"/>
-            <a:ext cx="2512999" cy="457200"/>
-          </a:xfrm>
-          <a:prstGeom prst="rect">
-            <a:avLst/>
-          </a:prstGeom>
-          <a:solidFill>
-            <a:srgbClr val="FFFFFF"/>
-          </a:solidFill>
-          <a:ln w="12700">
-            <a:solidFill>
-              <a:srgbClr val="E4E4E0"/>
-            </a:solidFill>
-          </a:ln>
-          <a:effectLst/>
-        </p:spPr>
-        <p:style>
-          <a:lnRef idx="1">
-            <a:schemeClr val="accent1"/>
-          </a:lnRef>
-          <a:fillRef idx="3">
-            <a:schemeClr val="accent1"/>
-          </a:fillRef>
-          <a:effectRef idx="2">
-            <a:schemeClr val="accent1"/>
-          </a:effectRef>
-          <a:fontRef idx="minor">
-            <a:schemeClr val="lt1"/>
-          </a:fontRef>
-        </p:style>
-        <p:txBody>
-          <a:bodyPr rtlCol="0" anchor="ctr"/>
-          <a:lstStyle/>
-          <a:p>
-            <a:pPr algn="ctr"/>
-          </a:p>
-        </p:txBody>
-      </p:sp>
-      <p:sp>
-        <p:nvSpPr>
-          <p:cNvPr id="23" name="TextBox 22"/>
-          <p:cNvSpPr txBox="1"/>
-          <p:nvPr/>
-        </p:nvSpPr>
-        <p:spPr>
-          <a:xfrm>
-            <a:off x="6233007" y="3785615"/>
-            <a:ext cx="2366695" cy="457200"/>
-          </a:xfrm>
-          <a:prstGeom prst="rect">
-            <a:avLst/>
-          </a:prstGeom>
-          <a:noFill/>
-        </p:spPr>
-        <p:txBody>
-          <a:bodyPr wrap="square" anchor="ctr" lIns="0" rIns="0" tIns="0" bIns="0"/>
-          <a:lstStyle/>
-          <a:p>
-            <a:pPr algn="ctr">
-              <a:lnSpc>
-                <a:spcPct val="100000"/>
-              </a:lnSpc>
-              <a:spcBef>
-                <a:spcPts val="0"/>
-              </a:spcBef>
-              <a:spcAft>
-                <a:spcPts val="0"/>
-              </a:spcAft>
-            </a:pPr>
-            <a:r>
-              <a:rPr sz="950" b="1" i="0" lang="en-AU" spc="-4">
-                <a:solidFill>
-                  <a:srgbClr val="111111"/>
-                </a:solidFill>
-                <a:latin typeface="Inter"/>
-              </a:rPr>
-              <a:t>SLAs</a:t>
-            </a:r>
-          </a:p>
-        </p:txBody>
-      </p:sp>
-      <p:sp>
-        <p:nvSpPr>
-          <p:cNvPr id="24" name="Rectangle 23"/>
-          <p:cNvSpPr/>
-          <p:nvPr/>
-        </p:nvSpPr>
-        <p:spPr>
-          <a:xfrm>
-            <a:off x="8800871" y="3785615"/>
-            <a:ext cx="2512999" cy="457200"/>
-          </a:xfrm>
-          <a:prstGeom prst="rect">
-            <a:avLst/>
-          </a:prstGeom>
-          <a:solidFill>
-            <a:srgbClr val="FFFFFF"/>
-          </a:solidFill>
-          <a:ln w="12700">
-            <a:solidFill>
-              <a:srgbClr val="E4E4E0"/>
-            </a:solidFill>
-          </a:ln>
-          <a:effectLst/>
-        </p:spPr>
-        <p:style>
-          <a:lnRef idx="1">
-            <a:schemeClr val="accent1"/>
-          </a:lnRef>
-          <a:fillRef idx="3">
-            <a:schemeClr val="accent1"/>
-          </a:fillRef>
-          <a:effectRef idx="2">
-            <a:schemeClr val="accent1"/>
-          </a:effectRef>
-          <a:fontRef idx="minor">
-            <a:schemeClr val="lt1"/>
-          </a:fontRef>
-        </p:style>
-        <p:txBody>
-          <a:bodyPr rtlCol="0" anchor="ctr"/>
-          <a:lstStyle/>
-          <a:p>
-            <a:pPr algn="ctr"/>
-          </a:p>
-        </p:txBody>
-      </p:sp>
-      <p:sp>
-        <p:nvSpPr>
-          <p:cNvPr id="25" name="TextBox 24"/>
-          <p:cNvSpPr txBox="1"/>
-          <p:nvPr/>
-        </p:nvSpPr>
-        <p:spPr>
-          <a:xfrm>
-            <a:off x="8874023" y="3785615"/>
-            <a:ext cx="2366695" cy="457200"/>
-          </a:xfrm>
-          <a:prstGeom prst="rect">
-            <a:avLst/>
-          </a:prstGeom>
-          <a:noFill/>
-        </p:spPr>
-        <p:txBody>
-          <a:bodyPr wrap="square" anchor="ctr" lIns="0" rIns="0" tIns="0" bIns="0"/>
-          <a:lstStyle/>
-          <a:p>
-            <a:pPr algn="ctr">
-              <a:lnSpc>
-                <a:spcPct val="100000"/>
-              </a:lnSpc>
-              <a:spcBef>
-                <a:spcPts val="0"/>
-              </a:spcBef>
-              <a:spcAft>
-                <a:spcPts val="0"/>
-              </a:spcAft>
-            </a:pPr>
-            <a:r>
-              <a:rPr sz="950" b="1" i="0" lang="en-AU" spc="-4">
-                <a:solidFill>
-                  <a:srgbClr val="111111"/>
-                </a:solidFill>
-                <a:latin typeface="Inter"/>
-              </a:rPr>
-              <a:t>Metrics</a:t>
-            </a:r>
-          </a:p>
-        </p:txBody>
-      </p:sp>
-      <p:sp>
-        <p:nvSpPr>
-          <p:cNvPr id="26" name="Rectangle 25"/>
-          <p:cNvSpPr/>
-          <p:nvPr/>
-        </p:nvSpPr>
-        <p:spPr>
-          <a:xfrm>
-            <a:off x="877824" y="4370832"/>
-            <a:ext cx="2512999" cy="457200"/>
-          </a:xfrm>
-          <a:prstGeom prst="rect">
-            <a:avLst/>
-          </a:prstGeom>
-          <a:solidFill>
-            <a:srgbClr val="FFFFFF"/>
-          </a:solidFill>
-          <a:ln w="12700">
-            <a:solidFill>
-              <a:srgbClr val="E4E4E0"/>
-            </a:solidFill>
-          </a:ln>
-          <a:effectLst/>
-        </p:spPr>
-        <p:style>
-          <a:lnRef idx="1">
-            <a:schemeClr val="accent1"/>
-          </a:lnRef>
-          <a:fillRef idx="3">
-            <a:schemeClr val="accent1"/>
-          </a:fillRef>
-          <a:effectRef idx="2">
-            <a:schemeClr val="accent1"/>
-          </a:effectRef>
-          <a:fontRef idx="minor">
-            <a:schemeClr val="lt1"/>
-          </a:fontRef>
-        </p:style>
-        <p:txBody>
-          <a:bodyPr rtlCol="0" anchor="ctr"/>
-          <a:lstStyle/>
-          <a:p>
-            <a:pPr algn="ctr"/>
-          </a:p>
-        </p:txBody>
-      </p:sp>
-      <p:sp>
-        <p:nvSpPr>
-          <p:cNvPr id="27" name="TextBox 26"/>
-          <p:cNvSpPr txBox="1"/>
-          <p:nvPr/>
-        </p:nvSpPr>
-        <p:spPr>
-          <a:xfrm>
-            <a:off x="950976" y="4370832"/>
-            <a:ext cx="2366695" cy="457200"/>
-          </a:xfrm>
-          <a:prstGeom prst="rect">
-            <a:avLst/>
-          </a:prstGeom>
-          <a:noFill/>
-        </p:spPr>
-        <p:txBody>
-          <a:bodyPr wrap="square" anchor="ctr" lIns="0" rIns="0" tIns="0" bIns="0"/>
-          <a:lstStyle/>
-          <a:p>
-            <a:pPr algn="ctr">
-              <a:lnSpc>
-                <a:spcPct val="100000"/>
-              </a:lnSpc>
-              <a:spcBef>
-                <a:spcPts val="0"/>
-              </a:spcBef>
-              <a:spcAft>
-                <a:spcPts val="0"/>
-              </a:spcAft>
-            </a:pPr>
-            <a:r>
-              <a:rPr sz="950" b="1" i="0" lang="en-AU" spc="-4">
-                <a:solidFill>
-                  <a:srgbClr val="111111"/>
-                </a:solidFill>
-                <a:latin typeface="Inter"/>
-              </a:rPr>
-              <a:t>Integration health checks</a:t>
-            </a:r>
-          </a:p>
-        </p:txBody>
-      </p:sp>
-      <p:sp>
-        <p:nvSpPr>
-          <p:cNvPr id="28" name="Rectangle 27"/>
-          <p:cNvSpPr/>
-          <p:nvPr/>
-        </p:nvSpPr>
-        <p:spPr>
-          <a:xfrm>
-            <a:off x="3518839" y="4370832"/>
-            <a:ext cx="2512999" cy="457200"/>
-          </a:xfrm>
-          <a:prstGeom prst="rect">
-            <a:avLst/>
-          </a:prstGeom>
-          <a:solidFill>
-            <a:srgbClr val="FFFFFF"/>
-          </a:solidFill>
-          <a:ln w="12700">
-            <a:solidFill>
-              <a:srgbClr val="E4E4E0"/>
-            </a:solidFill>
-          </a:ln>
-          <a:effectLst/>
-        </p:spPr>
-        <p:style>
-          <a:lnRef idx="1">
-            <a:schemeClr val="accent1"/>
-          </a:lnRef>
-          <a:fillRef idx="3">
-            <a:schemeClr val="accent1"/>
-          </a:fillRef>
-          <a:effectRef idx="2">
-            <a:schemeClr val="accent1"/>
-          </a:effectRef>
-          <a:fontRef idx="minor">
-            <a:schemeClr val="lt1"/>
-          </a:fontRef>
-        </p:style>
-        <p:txBody>
-          <a:bodyPr rtlCol="0" anchor="ctr"/>
-          <a:lstStyle/>
-          <a:p>
-            <a:pPr algn="ctr"/>
-          </a:p>
-        </p:txBody>
-      </p:sp>
-      <p:sp>
-        <p:nvSpPr>
-          <p:cNvPr id="29" name="TextBox 28"/>
-          <p:cNvSpPr txBox="1"/>
-          <p:nvPr/>
-        </p:nvSpPr>
-        <p:spPr>
-          <a:xfrm>
-            <a:off x="3591991" y="4370832"/>
-            <a:ext cx="2366695" cy="457200"/>
-          </a:xfrm>
-          <a:prstGeom prst="rect">
-            <a:avLst/>
-          </a:prstGeom>
-          <a:noFill/>
-        </p:spPr>
-        <p:txBody>
-          <a:bodyPr wrap="square" anchor="ctr" lIns="0" rIns="0" tIns="0" bIns="0"/>
-          <a:lstStyle/>
-          <a:p>
-            <a:pPr algn="ctr">
-              <a:lnSpc>
-                <a:spcPct val="100000"/>
-              </a:lnSpc>
-              <a:spcBef>
-                <a:spcPts val="0"/>
-              </a:spcBef>
-              <a:spcAft>
-                <a:spcPts val="0"/>
-              </a:spcAft>
-            </a:pPr>
-            <a:r>
-              <a:rPr sz="950" b="1" i="0" lang="en-AU" spc="-4">
-                <a:solidFill>
-                  <a:srgbClr val="111111"/>
-                </a:solidFill>
-                <a:latin typeface="Inter"/>
-              </a:rPr>
-              <a:t>Backlog management</a:t>
-            </a:r>
-          </a:p>
-        </p:txBody>
-      </p:sp>
-      <p:sp>
-        <p:nvSpPr>
-          <p:cNvPr id="30" name="Rectangle 29"/>
-          <p:cNvSpPr/>
-          <p:nvPr/>
-        </p:nvSpPr>
-        <p:spPr>
-          <a:xfrm>
-            <a:off x="6159855" y="4370832"/>
-            <a:ext cx="2512999" cy="457200"/>
-          </a:xfrm>
-          <a:prstGeom prst="rect">
-            <a:avLst/>
-          </a:prstGeom>
-          <a:solidFill>
-            <a:srgbClr val="FFFFFF"/>
-          </a:solidFill>
-          <a:ln w="12700">
-            <a:solidFill>
-              <a:srgbClr val="E4E4E0"/>
-            </a:solidFill>
-          </a:ln>
-          <a:effectLst/>
-        </p:spPr>
-        <p:style>
-          <a:lnRef idx="1">
-            <a:schemeClr val="accent1"/>
-          </a:lnRef>
-          <a:fillRef idx="3">
-            <a:schemeClr val="accent1"/>
-          </a:fillRef>
-          <a:effectRef idx="2">
-            <a:schemeClr val="accent1"/>
-          </a:effectRef>
-          <a:fontRef idx="minor">
-            <a:schemeClr val="lt1"/>
-          </a:fontRef>
-        </p:style>
-        <p:txBody>
-          <a:bodyPr rtlCol="0" anchor="ctr"/>
-          <a:lstStyle/>
-          <a:p>
-            <a:pPr algn="ctr"/>
-          </a:p>
-        </p:txBody>
-      </p:sp>
-      <p:sp>
-        <p:nvSpPr>
-          <p:cNvPr id="31" name="TextBox 30"/>
-          <p:cNvSpPr txBox="1"/>
-          <p:nvPr/>
-        </p:nvSpPr>
-        <p:spPr>
-          <a:xfrm>
-            <a:off x="6233007" y="4370832"/>
-            <a:ext cx="2366695" cy="457200"/>
-          </a:xfrm>
-          <a:prstGeom prst="rect">
-            <a:avLst/>
-          </a:prstGeom>
-          <a:noFill/>
-        </p:spPr>
-        <p:txBody>
-          <a:bodyPr wrap="square" anchor="ctr" lIns="0" rIns="0" tIns="0" bIns="0"/>
-          <a:lstStyle/>
-          <a:p>
-            <a:pPr algn="ctr">
-              <a:lnSpc>
-                <a:spcPct val="100000"/>
-              </a:lnSpc>
-              <a:spcBef>
-                <a:spcPts val="0"/>
-              </a:spcBef>
-              <a:spcAft>
-                <a:spcPts val="0"/>
-              </a:spcAft>
-            </a:pPr>
-            <a:r>
-              <a:rPr sz="950" b="1" i="0" lang="en-AU" spc="-4">
-                <a:solidFill>
-                  <a:srgbClr val="111111"/>
-                </a:solidFill>
-                <a:latin typeface="Inter"/>
-              </a:rPr>
-              <a:t>Prioritisation forum</a:t>
-            </a:r>
-          </a:p>
-        </p:txBody>
-      </p:sp>
-      <p:sp>
-        <p:nvSpPr>
-          <p:cNvPr id="32" name="Rectangle 31"/>
-          <p:cNvSpPr/>
-          <p:nvPr/>
-        </p:nvSpPr>
-        <p:spPr>
-          <a:xfrm>
-            <a:off x="8800871" y="4370832"/>
-            <a:ext cx="2512999" cy="457200"/>
-          </a:xfrm>
-          <a:prstGeom prst="rect">
-            <a:avLst/>
-          </a:prstGeom>
-          <a:solidFill>
-            <a:srgbClr val="FFFFFF"/>
-          </a:solidFill>
-          <a:ln w="12700">
-            <a:solidFill>
-              <a:srgbClr val="E4E4E0"/>
-            </a:solidFill>
-          </a:ln>
-          <a:effectLst/>
-        </p:spPr>
-        <p:style>
-          <a:lnRef idx="1">
-            <a:schemeClr val="accent1"/>
-          </a:lnRef>
-          <a:fillRef idx="3">
-            <a:schemeClr val="accent1"/>
-          </a:fillRef>
-          <a:effectRef idx="2">
-            <a:schemeClr val="accent1"/>
-          </a:effectRef>
-          <a:fontRef idx="minor">
-            <a:schemeClr val="lt1"/>
-          </a:fontRef>
-        </p:style>
-        <p:txBody>
-          <a:bodyPr rtlCol="0" anchor="ctr"/>
-          <a:lstStyle/>
-          <a:p>
-            <a:pPr algn="ctr"/>
-          </a:p>
-        </p:txBody>
-      </p:sp>
-      <p:sp>
-        <p:nvSpPr>
-          <p:cNvPr id="33" name="TextBox 32"/>
-          <p:cNvSpPr txBox="1"/>
-          <p:nvPr/>
-        </p:nvSpPr>
-        <p:spPr>
-          <a:xfrm>
-            <a:off x="8874023" y="4370832"/>
-            <a:ext cx="2366695" cy="457200"/>
-          </a:xfrm>
-          <a:prstGeom prst="rect">
-            <a:avLst/>
-          </a:prstGeom>
-          <a:noFill/>
-        </p:spPr>
-        <p:txBody>
-          <a:bodyPr wrap="square" anchor="ctr" lIns="0" rIns="0" tIns="0" bIns="0"/>
-          <a:lstStyle/>
-          <a:p>
-            <a:pPr algn="ctr">
-              <a:lnSpc>
-                <a:spcPct val="100000"/>
-              </a:lnSpc>
-              <a:spcBef>
-                <a:spcPts val="0"/>
-              </a:spcBef>
-              <a:spcAft>
-                <a:spcPts val="0"/>
-              </a:spcAft>
-            </a:pPr>
-            <a:r>
-              <a:rPr sz="950" b="1" i="0" lang="en-AU" spc="-4">
-                <a:solidFill>
-                  <a:srgbClr val="111111"/>
-                </a:solidFill>
-                <a:latin typeface="Inter"/>
-              </a:rPr>
-              <a:t>Capacity management</a:t>
-            </a:r>
-          </a:p>
-        </p:txBody>
-      </p:sp>
-      <p:sp>
-        <p:nvSpPr>
-          <p:cNvPr id="34" name="Rectangle 33"/>
-          <p:cNvSpPr/>
-          <p:nvPr/>
-        </p:nvSpPr>
-        <p:spPr>
-          <a:xfrm>
-            <a:off x="877824" y="4956048"/>
-            <a:ext cx="2512999" cy="457200"/>
-          </a:xfrm>
-          <a:prstGeom prst="rect">
-            <a:avLst/>
-          </a:prstGeom>
-          <a:solidFill>
-            <a:srgbClr val="FFFFFF"/>
-          </a:solidFill>
-          <a:ln w="12700">
-            <a:solidFill>
-              <a:srgbClr val="E4E4E0"/>
-            </a:solidFill>
-          </a:ln>
-          <a:effectLst/>
-        </p:spPr>
-        <p:style>
-          <a:lnRef idx="1">
-            <a:schemeClr val="accent1"/>
-          </a:lnRef>
-          <a:fillRef idx="3">
-            <a:schemeClr val="accent1"/>
-          </a:fillRef>
-          <a:effectRef idx="2">
-            <a:schemeClr val="accent1"/>
-          </a:effectRef>
-          <a:fontRef idx="minor">
-            <a:schemeClr val="lt1"/>
-          </a:fontRef>
-        </p:style>
-        <p:txBody>
-          <a:bodyPr rtlCol="0" anchor="ctr"/>
-          <a:lstStyle/>
-          <a:p>
-            <a:pPr algn="ctr"/>
-          </a:p>
-        </p:txBody>
-      </p:sp>
-      <p:sp>
-        <p:nvSpPr>
-          <p:cNvPr id="35" name="TextBox 34"/>
-          <p:cNvSpPr txBox="1"/>
-          <p:nvPr/>
-        </p:nvSpPr>
-        <p:spPr>
-          <a:xfrm>
-            <a:off x="950976" y="4956048"/>
-            <a:ext cx="2366695" cy="457200"/>
-          </a:xfrm>
-          <a:prstGeom prst="rect">
-            <a:avLst/>
-          </a:prstGeom>
-          <a:noFill/>
-        </p:spPr>
-        <p:txBody>
-          <a:bodyPr wrap="square" anchor="ctr" lIns="0" rIns="0" tIns="0" bIns="0"/>
-          <a:lstStyle/>
-          <a:p>
-            <a:pPr algn="ctr">
-              <a:lnSpc>
-                <a:spcPct val="100000"/>
-              </a:lnSpc>
-              <a:spcBef>
-                <a:spcPts val="0"/>
-              </a:spcBef>
-              <a:spcAft>
-                <a:spcPts val="0"/>
-              </a:spcAft>
-            </a:pPr>
-            <a:r>
-              <a:rPr sz="950" b="1" i="0" lang="en-AU" spc="-4">
-                <a:solidFill>
-                  <a:srgbClr val="111111"/>
-                </a:solidFill>
-                <a:latin typeface="Inter"/>
-              </a:rPr>
-              <a:t>Enhancements</a:t>
-            </a:r>
-          </a:p>
-        </p:txBody>
-      </p:sp>
-      <p:sp>
-        <p:nvSpPr>
-          <p:cNvPr id="36" name="Rectangle 35"/>
-          <p:cNvSpPr/>
-          <p:nvPr/>
-        </p:nvSpPr>
-        <p:spPr>
-          <a:xfrm>
-            <a:off x="3518839" y="4956048"/>
-            <a:ext cx="2512999" cy="457200"/>
-          </a:xfrm>
-          <a:prstGeom prst="rect">
-            <a:avLst/>
-          </a:prstGeom>
-          <a:solidFill>
-            <a:srgbClr val="FFFFFF"/>
-          </a:solidFill>
-          <a:ln w="12700">
-            <a:solidFill>
-              <a:srgbClr val="E4E4E0"/>
-            </a:solidFill>
-          </a:ln>
-          <a:effectLst/>
-        </p:spPr>
-        <p:style>
-          <a:lnRef idx="1">
-            <a:schemeClr val="accent1"/>
-          </a:lnRef>
-          <a:fillRef idx="3">
-            <a:schemeClr val="accent1"/>
-          </a:fillRef>
-          <a:effectRef idx="2">
-            <a:schemeClr val="accent1"/>
-          </a:effectRef>
-          <a:fontRef idx="minor">
-            <a:schemeClr val="lt1"/>
-          </a:fontRef>
-        </p:style>
-        <p:txBody>
-          <a:bodyPr rtlCol="0" anchor="ctr"/>
-          <a:lstStyle/>
-          <a:p>
-            <a:pPr algn="ctr"/>
-          </a:p>
-        </p:txBody>
-      </p:sp>
-      <p:sp>
-        <p:nvSpPr>
-          <p:cNvPr id="37" name="TextBox 36"/>
-          <p:cNvSpPr txBox="1"/>
-          <p:nvPr/>
-        </p:nvSpPr>
-        <p:spPr>
-          <a:xfrm>
-            <a:off x="3591991" y="4956048"/>
-            <a:ext cx="2366695" cy="457200"/>
-          </a:xfrm>
-          <a:prstGeom prst="rect">
-            <a:avLst/>
-          </a:prstGeom>
-          <a:noFill/>
-        </p:spPr>
-        <p:txBody>
-          <a:bodyPr wrap="square" anchor="ctr" lIns="0" rIns="0" tIns="0" bIns="0"/>
-          <a:lstStyle/>
-          <a:p>
-            <a:pPr algn="ctr">
-              <a:lnSpc>
-                <a:spcPct val="100000"/>
-              </a:lnSpc>
-              <a:spcBef>
-                <a:spcPts val="0"/>
-              </a:spcBef>
-              <a:spcAft>
-                <a:spcPts val="0"/>
-              </a:spcAft>
-            </a:pPr>
-            <a:r>
-              <a:rPr sz="950" b="1" i="0" lang="en-AU" spc="-4">
-                <a:solidFill>
-                  <a:srgbClr val="111111"/>
-                </a:solidFill>
-                <a:latin typeface="Inter"/>
-              </a:rPr>
-              <a:t>Knowledge base</a:t>
-            </a:r>
-          </a:p>
-        </p:txBody>
-      </p:sp>
-      <p:sp>
-        <p:nvSpPr>
-          <p:cNvPr id="38" name="Rectangle 37"/>
-          <p:cNvSpPr/>
-          <p:nvPr/>
-        </p:nvSpPr>
-        <p:spPr>
-          <a:xfrm>
-            <a:off x="6159855" y="4956048"/>
-            <a:ext cx="2512999" cy="457200"/>
-          </a:xfrm>
-          <a:prstGeom prst="rect">
-            <a:avLst/>
-          </a:prstGeom>
-          <a:solidFill>
-            <a:srgbClr val="FFFFFF"/>
-          </a:solidFill>
-          <a:ln w="12700">
-            <a:solidFill>
-              <a:srgbClr val="E4E4E0"/>
-            </a:solidFill>
-          </a:ln>
-          <a:effectLst/>
-        </p:spPr>
-        <p:style>
-          <a:lnRef idx="1">
-            <a:schemeClr val="accent1"/>
-          </a:lnRef>
-          <a:fillRef idx="3">
-            <a:schemeClr val="accent1"/>
-          </a:fillRef>
-          <a:effectRef idx="2">
-            <a:schemeClr val="accent1"/>
-          </a:effectRef>
-          <a:fontRef idx="minor">
-            <a:schemeClr val="lt1"/>
-          </a:fontRef>
-        </p:style>
-        <p:txBody>
-          <a:bodyPr rtlCol="0" anchor="ctr"/>
-          <a:lstStyle/>
-          <a:p>
-            <a:pPr algn="ctr"/>
-          </a:p>
-        </p:txBody>
-      </p:sp>
-      <p:sp>
-        <p:nvSpPr>
-          <p:cNvPr id="39" name="TextBox 38"/>
-          <p:cNvSpPr txBox="1"/>
-          <p:nvPr/>
-        </p:nvSpPr>
-        <p:spPr>
-          <a:xfrm>
-            <a:off x="6233007" y="4956048"/>
-            <a:ext cx="2366695" cy="457200"/>
-          </a:xfrm>
-          <a:prstGeom prst="rect">
-            <a:avLst/>
-          </a:prstGeom>
-          <a:noFill/>
-        </p:spPr>
-        <p:txBody>
-          <a:bodyPr wrap="square" anchor="ctr" lIns="0" rIns="0" tIns="0" bIns="0"/>
-          <a:lstStyle/>
-          <a:p>
-            <a:pPr algn="ctr">
-              <a:lnSpc>
-                <a:spcPct val="100000"/>
-              </a:lnSpc>
-              <a:spcBef>
-                <a:spcPts val="0"/>
-              </a:spcBef>
-              <a:spcAft>
-                <a:spcPts val="0"/>
-              </a:spcAft>
-            </a:pPr>
-            <a:r>
-              <a:rPr sz="950" b="1" i="0" lang="en-AU" spc="-4">
-                <a:solidFill>
-                  <a:srgbClr val="111111"/>
-                </a:solidFill>
-                <a:latin typeface="Inter"/>
-              </a:rPr>
-              <a:t>Cyber security</a:t>
-            </a:r>
-          </a:p>
-        </p:txBody>
-      </p:sp>
-      <p:sp>
-        <p:nvSpPr>
-          <p:cNvPr id="40" name="Rectangle 39"/>
-          <p:cNvSpPr/>
-          <p:nvPr/>
-        </p:nvSpPr>
-        <p:spPr>
-          <a:xfrm>
-            <a:off x="8800871" y="4956048"/>
-            <a:ext cx="2512999" cy="457200"/>
-          </a:xfrm>
-          <a:prstGeom prst="rect">
-            <a:avLst/>
-          </a:prstGeom>
-          <a:solidFill>
-            <a:srgbClr val="FFFFFF"/>
-          </a:solidFill>
-          <a:ln w="12700">
-            <a:solidFill>
-              <a:srgbClr val="E4E4E0"/>
-            </a:solidFill>
-          </a:ln>
-          <a:effectLst/>
-        </p:spPr>
-        <p:style>
-          <a:lnRef idx="1">
-            <a:schemeClr val="accent1"/>
-          </a:lnRef>
-          <a:fillRef idx="3">
-            <a:schemeClr val="accent1"/>
-          </a:fillRef>
-          <a:effectRef idx="2">
-            <a:schemeClr val="accent1"/>
-          </a:effectRef>
-          <a:fontRef idx="minor">
-            <a:schemeClr val="lt1"/>
-          </a:fontRef>
-        </p:style>
-        <p:txBody>
-          <a:bodyPr rtlCol="0" anchor="ctr"/>
-          <a:lstStyle/>
-          <a:p>
-            <a:pPr algn="ctr"/>
-          </a:p>
-        </p:txBody>
-      </p:sp>
-      <p:sp>
-        <p:nvSpPr>
-          <p:cNvPr id="41" name="TextBox 40"/>
-          <p:cNvSpPr txBox="1"/>
-          <p:nvPr/>
-        </p:nvSpPr>
-        <p:spPr>
-          <a:xfrm>
-            <a:off x="8874023" y="4956048"/>
-            <a:ext cx="2366695" cy="457200"/>
-          </a:xfrm>
-          <a:prstGeom prst="rect">
-            <a:avLst/>
-          </a:prstGeom>
-          <a:noFill/>
-        </p:spPr>
-        <p:txBody>
-          <a:bodyPr wrap="square" anchor="ctr" lIns="0" rIns="0" tIns="0" bIns="0"/>
-          <a:lstStyle/>
-          <a:p>
-            <a:pPr algn="ctr">
-              <a:lnSpc>
-                <a:spcPct val="100000"/>
-              </a:lnSpc>
-              <a:spcBef>
-                <a:spcPts val="0"/>
-              </a:spcBef>
-              <a:spcAft>
-                <a:spcPts val="0"/>
-              </a:spcAft>
-            </a:pPr>
-            <a:r>
-              <a:rPr sz="950" b="1" i="0" lang="en-AU" spc="-4">
-                <a:solidFill>
-                  <a:srgbClr val="111111"/>
-                </a:solidFill>
-                <a:latin typeface="Inter"/>
-              </a:rPr>
-              <a:t>BP &amp; security config</a:t>
-            </a:r>
-          </a:p>
-        </p:txBody>
-      </p:sp>
-      <p:sp>
-        <p:nvSpPr>
-          <p:cNvPr id="42" name="Rectangle 41"/>
-          <p:cNvSpPr/>
-          <p:nvPr/>
-        </p:nvSpPr>
-        <p:spPr>
-          <a:xfrm>
-            <a:off x="877824" y="5541264"/>
-            <a:ext cx="10436047" cy="384048"/>
-          </a:xfrm>
-          <a:prstGeom prst="rect">
-            <a:avLst/>
-          </a:prstGeom>
-          <a:solidFill>
-            <a:srgbClr val="EA493F"/>
-          </a:solidFill>
-          <a:ln>
-            <a:noFill/>
-          </a:ln>
-          <a:effectLst/>
-        </p:spPr>
-        <p:style>
-          <a:lnRef idx="1">
-            <a:schemeClr val="accent1"/>
-          </a:lnRef>
-          <a:fillRef idx="3">
-            <a:schemeClr val="accent1"/>
-          </a:fillRef>
-          <a:effectRef idx="2">
-            <a:schemeClr val="accent1"/>
-          </a:effectRef>
-          <a:fontRef idx="minor">
-            <a:schemeClr val="lt1"/>
-          </a:fontRef>
-        </p:style>
-        <p:txBody>
-          <a:bodyPr rtlCol="0" anchor="ctr"/>
-          <a:lstStyle/>
-          <a:p>
-            <a:pPr algn="ctr"/>
-          </a:p>
-        </p:txBody>
-      </p:sp>
-      <p:sp>
-        <p:nvSpPr>
-          <p:cNvPr id="43" name="TextBox 42"/>
-          <p:cNvSpPr txBox="1"/>
-          <p:nvPr/>
-        </p:nvSpPr>
-        <p:spPr>
-          <a:xfrm>
-            <a:off x="1106424" y="5541264"/>
-            <a:ext cx="9978847" cy="384048"/>
-          </a:xfrm>
-          <a:prstGeom prst="rect">
-            <a:avLst/>
-          </a:prstGeom>
-          <a:noFill/>
-        </p:spPr>
-        <p:txBody>
-          <a:bodyPr wrap="square" anchor="ctr" lIns="0" rIns="0" tIns="0" bIns="0"/>
-          <a:lstStyle/>
-          <a:p>
-            <a:pPr algn="l">
-              <a:lnSpc>
-                <a:spcPct val="100000"/>
-              </a:lnSpc>
-              <a:spcBef>
-                <a:spcPts val="0"/>
-              </a:spcBef>
-              <a:spcAft>
-                <a:spcPts val="0"/>
-              </a:spcAft>
-            </a:pPr>
-            <a:r>
-              <a:rPr sz="1150" b="1" i="0" lang="en-AU" spc="115" cap="all">
-                <a:solidFill>
-                  <a:srgbClr val="FFFFFF"/>
-                </a:solidFill>
-                <a:latin typeface="Inter"/>
-              </a:rPr>
-              <a:t>SERVICE INTEGRATION · ITSM</a:t>
-            </a:r>
-          </a:p>
-        </p:txBody>
-      </p:sp>
-      <p:sp>
-        <p:nvSpPr>
-          <p:cNvPr id="44" name="Rectangle 43"/>
-          <p:cNvSpPr/>
-          <p:nvPr/>
-        </p:nvSpPr>
-        <p:spPr>
-          <a:xfrm>
-            <a:off x="877824" y="6016752"/>
-            <a:ext cx="3387242" cy="365760"/>
-          </a:xfrm>
-          <a:prstGeom prst="rect">
-            <a:avLst/>
-          </a:prstGeom>
-          <a:solidFill>
-            <a:srgbClr val="F2F3EE"/>
-          </a:solidFill>
-          <a:ln w="12700">
-            <a:solidFill>
-              <a:srgbClr val="E4E4E0"/>
-            </a:solidFill>
-          </a:ln>
-          <a:effectLst/>
-        </p:spPr>
-        <p:style>
-          <a:lnRef idx="1">
-            <a:schemeClr val="accent1"/>
-          </a:lnRef>
-          <a:fillRef idx="3">
-            <a:schemeClr val="accent1"/>
-          </a:fillRef>
-          <a:effectRef idx="2">
-            <a:schemeClr val="accent1"/>
-          </a:effectRef>
-          <a:fontRef idx="minor">
-            <a:schemeClr val="lt1"/>
-          </a:fontRef>
-        </p:style>
-        <p:txBody>
-          <a:bodyPr rtlCol="0" anchor="ctr"/>
-          <a:lstStyle/>
-          <a:p>
-            <a:pPr algn="ctr"/>
-          </a:p>
-        </p:txBody>
-      </p:sp>
-      <p:sp>
-        <p:nvSpPr>
-          <p:cNvPr id="45" name="TextBox 44"/>
-          <p:cNvSpPr txBox="1"/>
-          <p:nvPr/>
-        </p:nvSpPr>
-        <p:spPr>
-          <a:xfrm>
-            <a:off x="950976" y="6016752"/>
-            <a:ext cx="3240938" cy="365760"/>
-          </a:xfrm>
-          <a:prstGeom prst="rect">
-            <a:avLst/>
-          </a:prstGeom>
-          <a:noFill/>
-        </p:spPr>
-        <p:txBody>
-          <a:bodyPr wrap="square" anchor="ctr" lIns="0" rIns="0" tIns="0" bIns="0"/>
-          <a:lstStyle/>
-          <a:p>
-            <a:pPr algn="ctr">
-              <a:lnSpc>
-                <a:spcPct val="100000"/>
-              </a:lnSpc>
-              <a:spcBef>
-                <a:spcPts val="0"/>
-              </a:spcBef>
-              <a:spcAft>
-                <a:spcPts val="0"/>
-              </a:spcAft>
-            </a:pPr>
-            <a:r>
-              <a:rPr sz="1000" b="1" i="0" lang="en-AU" spc="-5">
-                <a:solidFill>
-                  <a:srgbClr val="EA493F"/>
-                </a:solidFill>
-                <a:latin typeface="Inter"/>
-              </a:rPr>
-              <a:t>OPERATIONS AS A PRIORITY</a:t>
-            </a:r>
-          </a:p>
-        </p:txBody>
-      </p:sp>
-      <p:sp>
-        <p:nvSpPr>
-          <p:cNvPr id="46" name="Rectangle 45"/>
-          <p:cNvSpPr/>
-          <p:nvPr/>
-        </p:nvSpPr>
-        <p:spPr>
-          <a:xfrm>
-            <a:off x="4402226" y="6016752"/>
-            <a:ext cx="3387242" cy="365760"/>
-          </a:xfrm>
-          <a:prstGeom prst="rect">
-            <a:avLst/>
-          </a:prstGeom>
-          <a:solidFill>
-            <a:srgbClr val="F2F3EE"/>
-          </a:solidFill>
-          <a:ln w="12700">
-            <a:solidFill>
-              <a:srgbClr val="E4E4E0"/>
-            </a:solidFill>
-          </a:ln>
-          <a:effectLst/>
-        </p:spPr>
-        <p:style>
-          <a:lnRef idx="1">
-            <a:schemeClr val="accent1"/>
-          </a:lnRef>
-          <a:fillRef idx="3">
-            <a:schemeClr val="accent1"/>
-          </a:fillRef>
-          <a:effectRef idx="2">
-            <a:schemeClr val="accent1"/>
-          </a:effectRef>
-          <a:fontRef idx="minor">
-            <a:schemeClr val="lt1"/>
-          </a:fontRef>
-        </p:style>
-        <p:txBody>
-          <a:bodyPr rtlCol="0" anchor="ctr"/>
-          <a:lstStyle/>
-          <a:p>
-            <a:pPr algn="ctr"/>
-          </a:p>
-        </p:txBody>
-      </p:sp>
-      <p:sp>
-        <p:nvSpPr>
-          <p:cNvPr id="47" name="TextBox 46"/>
-          <p:cNvSpPr txBox="1"/>
-          <p:nvPr/>
-        </p:nvSpPr>
-        <p:spPr>
-          <a:xfrm>
-            <a:off x="4475378" y="6016752"/>
-            <a:ext cx="3240938" cy="365760"/>
-          </a:xfrm>
-          <a:prstGeom prst="rect">
-            <a:avLst/>
-          </a:prstGeom>
-          <a:noFill/>
-        </p:spPr>
-        <p:txBody>
-          <a:bodyPr wrap="square" anchor="ctr" lIns="0" rIns="0" tIns="0" bIns="0"/>
-          <a:lstStyle/>
-          <a:p>
-            <a:pPr algn="ctr">
-              <a:lnSpc>
-                <a:spcPct val="100000"/>
-              </a:lnSpc>
-              <a:spcBef>
-                <a:spcPts val="0"/>
-              </a:spcBef>
-              <a:spcAft>
-                <a:spcPts val="0"/>
-              </a:spcAft>
-            </a:pPr>
-            <a:r>
-              <a:rPr sz="1000" b="1" i="0" lang="en-AU" spc="-5">
-                <a:solidFill>
-                  <a:srgbClr val="EA493F"/>
-                </a:solidFill>
-                <a:latin typeface="Inter"/>
-              </a:rPr>
-              <a:t>BUSINESS VALUE REALISATION</a:t>
-            </a:r>
-          </a:p>
-        </p:txBody>
-      </p:sp>
-      <p:sp>
-        <p:nvSpPr>
-          <p:cNvPr id="48" name="Rectangle 47"/>
-          <p:cNvSpPr/>
-          <p:nvPr/>
-        </p:nvSpPr>
-        <p:spPr>
-          <a:xfrm>
-            <a:off x="7926628" y="6016752"/>
-            <a:ext cx="3387242" cy="365760"/>
-          </a:xfrm>
-          <a:prstGeom prst="rect">
-            <a:avLst/>
-          </a:prstGeom>
-          <a:solidFill>
-            <a:srgbClr val="F2F3EE"/>
-          </a:solidFill>
-          <a:ln w="12700">
-            <a:solidFill>
-              <a:srgbClr val="E4E4E0"/>
-            </a:solidFill>
-          </a:ln>
-          <a:effectLst/>
-        </p:spPr>
-        <p:style>
-          <a:lnRef idx="1">
-            <a:schemeClr val="accent1"/>
-          </a:lnRef>
-          <a:fillRef idx="3">
-            <a:schemeClr val="accent1"/>
-          </a:fillRef>
-          <a:effectRef idx="2">
-            <a:schemeClr val="accent1"/>
-          </a:effectRef>
-          <a:fontRef idx="minor">
-            <a:schemeClr val="lt1"/>
-          </a:fontRef>
-        </p:style>
-        <p:txBody>
-          <a:bodyPr rtlCol="0" anchor="ctr"/>
-          <a:lstStyle/>
-          <a:p>
-            <a:pPr algn="ctr"/>
-          </a:p>
-        </p:txBody>
-      </p:sp>
-      <p:sp>
-        <p:nvSpPr>
-          <p:cNvPr id="49" name="TextBox 48"/>
-          <p:cNvSpPr txBox="1"/>
-          <p:nvPr/>
-        </p:nvSpPr>
-        <p:spPr>
-          <a:xfrm>
-            <a:off x="7999780" y="6016752"/>
-            <a:ext cx="3240938" cy="365760"/>
-          </a:xfrm>
-          <a:prstGeom prst="rect">
-            <a:avLst/>
-          </a:prstGeom>
-          <a:noFill/>
-        </p:spPr>
-        <p:txBody>
-          <a:bodyPr wrap="square" anchor="ctr" lIns="0" rIns="0" tIns="0" bIns="0"/>
-          <a:lstStyle/>
-          <a:p>
-            <a:pPr algn="ctr">
-              <a:lnSpc>
-                <a:spcPct val="100000"/>
-              </a:lnSpc>
-              <a:spcBef>
-                <a:spcPts val="0"/>
-              </a:spcBef>
-              <a:spcAft>
-                <a:spcPts val="0"/>
-              </a:spcAft>
-            </a:pPr>
-            <a:r>
-              <a:rPr sz="1000" b="1" i="0" lang="en-AU" spc="-5">
-                <a:solidFill>
-                  <a:srgbClr val="EA493F"/>
-                </a:solidFill>
-                <a:latin typeface="Inter"/>
-              </a:rPr>
-              <a:t>OPERATIONAL EXCELLENCE · ITIL</a:t>
+              <a:rPr sz="1200" b="1" i="0" lang="en-AU" spc="24">
+                <a:solidFill>
+                  <a:srgbClr val="AEAEAE"/>
+                </a:solidFill>
+                <a:latin typeface="Inter"/>
+              </a:rPr>
+              <a:t>Operational excellence, by design.</a:t>
             </a:r>
           </a:p>
         </p:txBody>

</xml_diff>